<commit_message>
action_plan.pptx v4.1 - unify schedule to 08.31 for all items
</commit_message>
<xml_diff>
--- a/action_plan.pptx
+++ b/action_plan.pptx
@@ -2367,7 +2367,7 @@
                 <a:ea typeface="Calibri" pitchFamily="34" charset="-122"/>
                 <a:cs typeface="Calibri" pitchFamily="34" charset="-120"/>
               </a:rPr>
-              <a:t>2026. 08. 05   |   v4.0</a:t>
+              <a:t>2026. 08. 05   |   v4.1</a:t>
             </a:r>
             <a:endParaRPr lang="en-US" sz="1050" dirty="0"/>
           </a:p>
@@ -4271,7 +4271,7 @@
                 <a:ea typeface="Calibri" pitchFamily="34" charset="-122"/>
                 <a:cs typeface="Calibri" pitchFamily="34" charset="-120"/>
               </a:rPr>
-              <a:t>㈜인시스  ·  셰플러 이천공장 수입검사 실행계획서 v4.0</a:t>
+              <a:t>㈜인시스  ·  셰플러 이천공장 수입검사 실행계획서 v4.1</a:t>
             </a:r>
             <a:endParaRPr lang="en-US" sz="800" dirty="0"/>
           </a:p>
@@ -5365,7 +5365,7 @@
                 <a:ea typeface="Calibri" pitchFamily="34" charset="-122"/>
                 <a:cs typeface="Calibri" pitchFamily="34" charset="-120"/>
               </a:rPr>
-              <a:t>㈜인시스  ·  셰플러 이천공장 수입검사 실행계획서 v4.0</a:t>
+              <a:t>㈜인시스  ·  셰플러 이천공장 수입검사 실행계획서 v4.1</a:t>
             </a:r>
             <a:endParaRPr lang="en-US" sz="800" dirty="0"/>
           </a:p>
@@ -6849,7 +6849,7 @@
                 <a:ea typeface="Calibri" pitchFamily="34" charset="-122"/>
                 <a:cs typeface="Calibri" pitchFamily="34" charset="-120"/>
               </a:rPr>
-              <a:t>㈜인시스  ·  셰플러 이천공장 수입검사 실행계획서 v4.0</a:t>
+              <a:t>㈜인시스  ·  셰플러 이천공장 수입검사 실행계획서 v4.1</a:t>
             </a:r>
             <a:endParaRPr lang="en-US" sz="800" dirty="0"/>
           </a:p>
@@ -7500,7 +7500,7 @@
                 <a:ea typeface="Calibri" pitchFamily="34" charset="-122"/>
                 <a:cs typeface="Calibri" pitchFamily="34" charset="-120"/>
               </a:rPr>
-              <a:t>08.15</a:t>
+              <a:t>08.31</a:t>
             </a:r>
             <a:endParaRPr lang="en-US" sz="930" dirty="0"/>
           </a:p>
@@ -7761,7 +7761,7 @@
                 <a:ea typeface="Calibri" pitchFamily="34" charset="-122"/>
                 <a:cs typeface="Calibri" pitchFamily="34" charset="-120"/>
               </a:rPr>
-              <a:t>08.15</a:t>
+              <a:t>08.31</a:t>
             </a:r>
             <a:endParaRPr lang="en-US" sz="930" dirty="0"/>
           </a:p>
@@ -7776,287 +7776,6 @@
         <p:spPr>
           <a:xfrm>
             <a:off x="7735824" y="1961388"/>
-            <a:ext cx="859536" cy="256032"/>
-          </a:xfrm>
-          <a:prstGeom prst="roundRect">
-            <a:avLst>
-              <a:gd name="adj" fmla="val 17857"/>
-            </a:avLst>
-          </a:prstGeom>
-          <a:solidFill>
-            <a:srgbClr val="FFFFFF"/>
-          </a:solidFill>
-          <a:ln w="12700">
-            <a:solidFill>
-              <a:srgbClr val="1F6B4A"/>
-            </a:solidFill>
-            <a:prstDash val="solid"/>
-          </a:ln>
-        </p:spPr>
-      </p:sp>
-      <p:sp>
-        <p:nvSpPr>
-          <p:cNvPr id="27" name="Text 25"/>
-          <p:cNvSpPr/>
-          <p:nvPr/>
-        </p:nvSpPr>
-        <p:spPr>
-          <a:xfrm>
-            <a:off x="7735824" y="1961388"/>
-            <a:ext cx="859536" cy="256032"/>
-          </a:xfrm>
-          <a:prstGeom prst="rect">
-            <a:avLst/>
-          </a:prstGeom>
-          <a:noFill/>
-          <a:ln/>
-        </p:spPr>
-        <p:txBody>
-          <a:bodyPr wrap="square" lIns="0" tIns="0" rIns="0" bIns="0" rtlCol="0" anchor="ctr"/>
-          <a:lstStyle/>
-          <a:p>
-            <a:pPr algn="ctr" indent="0" marL="0">
-              <a:buNone/>
-            </a:pPr>
-            <a:r>
-              <a:rPr lang="en-US" sz="830" b="1" dirty="0">
-                <a:solidFill>
-                  <a:srgbClr val="1F6B4A"/>
-                </a:solidFill>
-                <a:latin typeface="Calibri" pitchFamily="34" charset="0"/>
-                <a:ea typeface="Calibri" pitchFamily="34" charset="-122"/>
-                <a:cs typeface="Calibri" pitchFamily="34" charset="-120"/>
-              </a:rPr>
-              <a:t>완료</a:t>
-            </a:r>
-            <a:endParaRPr lang="en-US" sz="830" dirty="0"/>
-          </a:p>
-        </p:txBody>
-      </p:sp>
-      <p:sp>
-        <p:nvSpPr>
-          <p:cNvPr id="28" name="Shape 26"/>
-          <p:cNvSpPr/>
-          <p:nvPr/>
-        </p:nvSpPr>
-        <p:spPr>
-          <a:xfrm>
-            <a:off x="457200" y="2286000"/>
-            <a:ext cx="8229600" cy="393192"/>
-          </a:xfrm>
-          <a:prstGeom prst="rect">
-            <a:avLst/>
-          </a:prstGeom>
-          <a:solidFill>
-            <a:srgbClr val="FAFBFC"/>
-          </a:solidFill>
-          <a:ln/>
-        </p:spPr>
-      </p:sp>
-      <p:sp>
-        <p:nvSpPr>
-          <p:cNvPr id="29" name="Text 27"/>
-          <p:cNvSpPr/>
-          <p:nvPr/>
-        </p:nvSpPr>
-        <p:spPr>
-          <a:xfrm>
-            <a:off x="457200" y="2286000"/>
-            <a:ext cx="475488" cy="393192"/>
-          </a:xfrm>
-          <a:prstGeom prst="rect">
-            <a:avLst/>
-          </a:prstGeom>
-          <a:noFill/>
-          <a:ln/>
-        </p:spPr>
-        <p:txBody>
-          <a:bodyPr wrap="square" lIns="0" tIns="0" rIns="0" bIns="0" rtlCol="0" anchor="ctr"/>
-          <a:lstStyle/>
-          <a:p>
-            <a:pPr algn="ctr" indent="0" marL="0">
-              <a:buNone/>
-            </a:pPr>
-            <a:r>
-              <a:rPr lang="en-US" sz="980" b="1" dirty="0">
-                <a:solidFill>
-                  <a:srgbClr val="1C7293"/>
-                </a:solidFill>
-                <a:latin typeface="Cambria" pitchFamily="34" charset="0"/>
-                <a:ea typeface="Cambria" pitchFamily="34" charset="-122"/>
-                <a:cs typeface="Cambria" pitchFamily="34" charset="-120"/>
-              </a:rPr>
-              <a:t>03</a:t>
-            </a:r>
-            <a:endParaRPr lang="en-US" sz="980" dirty="0"/>
-          </a:p>
-        </p:txBody>
-      </p:sp>
-      <p:sp>
-        <p:nvSpPr>
-          <p:cNvPr id="30" name="Text 28"/>
-          <p:cNvSpPr/>
-          <p:nvPr/>
-        </p:nvSpPr>
-        <p:spPr>
-          <a:xfrm>
-            <a:off x="987552" y="2286000"/>
-            <a:ext cx="2523744" cy="393192"/>
-          </a:xfrm>
-          <a:prstGeom prst="rect">
-            <a:avLst/>
-          </a:prstGeom>
-          <a:noFill/>
-          <a:ln/>
-        </p:spPr>
-        <p:txBody>
-          <a:bodyPr wrap="square" lIns="762" tIns="762" rIns="762" bIns="762" rtlCol="0" anchor="ctr"/>
-          <a:lstStyle/>
-          <a:p>
-            <a:pPr indent="0" marL="0">
-              <a:buNone/>
-            </a:pPr>
-            <a:r>
-              <a:rPr lang="en-US" sz="1030" b="1" dirty="0">
-                <a:solidFill>
-                  <a:srgbClr val="21295C"/>
-                </a:solidFill>
-                <a:latin typeface="Calibri" pitchFamily="34" charset="0"/>
-                <a:ea typeface="Calibri" pitchFamily="34" charset="-122"/>
-                <a:cs typeface="Calibri" pitchFamily="34" charset="-120"/>
-              </a:rPr>
-              <a:t>품질 마인드 강화</a:t>
-            </a:r>
-            <a:endParaRPr lang="en-US" sz="1030" dirty="0"/>
-          </a:p>
-        </p:txBody>
-      </p:sp>
-      <p:sp>
-        <p:nvSpPr>
-          <p:cNvPr id="31" name="Text 29"/>
-          <p:cNvSpPr/>
-          <p:nvPr/>
-        </p:nvSpPr>
-        <p:spPr>
-          <a:xfrm>
-            <a:off x="3566160" y="2286000"/>
-            <a:ext cx="2011680" cy="393192"/>
-          </a:xfrm>
-          <a:prstGeom prst="rect">
-            <a:avLst/>
-          </a:prstGeom>
-          <a:noFill/>
-          <a:ln/>
-        </p:spPr>
-        <p:txBody>
-          <a:bodyPr wrap="square" lIns="762" tIns="762" rIns="762" bIns="762" rtlCol="0" anchor="ctr"/>
-          <a:lstStyle/>
-          <a:p>
-            <a:pPr indent="0" marL="0">
-              <a:buNone/>
-            </a:pPr>
-            <a:r>
-              <a:rPr lang="en-US" sz="880" dirty="0">
-                <a:solidFill>
-                  <a:srgbClr val="5A6B7C"/>
-                </a:solidFill>
-                <a:latin typeface="Calibri" pitchFamily="34" charset="0"/>
-                <a:ea typeface="Calibri" pitchFamily="34" charset="-122"/>
-                <a:cs typeface="Calibri" pitchFamily="34" charset="-120"/>
-              </a:rPr>
-              <a:t>행동 지침서 · 교육 이력</a:t>
-            </a:r>
-            <a:endParaRPr lang="en-US" sz="880" dirty="0"/>
-          </a:p>
-        </p:txBody>
-      </p:sp>
-      <p:sp>
-        <p:nvSpPr>
-          <p:cNvPr id="32" name="Text 30"/>
-          <p:cNvSpPr/>
-          <p:nvPr/>
-        </p:nvSpPr>
-        <p:spPr>
-          <a:xfrm>
-            <a:off x="5632704" y="2286000"/>
-            <a:ext cx="1207008" cy="393192"/>
-          </a:xfrm>
-          <a:prstGeom prst="rect">
-            <a:avLst/>
-          </a:prstGeom>
-          <a:noFill/>
-          <a:ln/>
-        </p:spPr>
-        <p:txBody>
-          <a:bodyPr wrap="square" lIns="0" tIns="0" rIns="0" bIns="0" rtlCol="0" anchor="ctr"/>
-          <a:lstStyle/>
-          <a:p>
-            <a:pPr algn="ctr" indent="0" marL="0">
-              <a:buNone/>
-            </a:pPr>
-            <a:r>
-              <a:rPr lang="en-US" sz="930" dirty="0">
-                <a:solidFill>
-                  <a:srgbClr val="1A2634"/>
-                </a:solidFill>
-                <a:latin typeface="Calibri" pitchFamily="34" charset="0"/>
-                <a:ea typeface="Calibri" pitchFamily="34" charset="-122"/>
-                <a:cs typeface="Calibri" pitchFamily="34" charset="-120"/>
-              </a:rPr>
-              <a:t>김종선 대리</a:t>
-            </a:r>
-            <a:endParaRPr lang="en-US" sz="930" dirty="0"/>
-          </a:p>
-        </p:txBody>
-      </p:sp>
-      <p:sp>
-        <p:nvSpPr>
-          <p:cNvPr id="33" name="Text 31"/>
-          <p:cNvSpPr/>
-          <p:nvPr/>
-        </p:nvSpPr>
-        <p:spPr>
-          <a:xfrm>
-            <a:off x="6876288" y="2286000"/>
-            <a:ext cx="749808" cy="393192"/>
-          </a:xfrm>
-          <a:prstGeom prst="rect">
-            <a:avLst/>
-          </a:prstGeom>
-          <a:noFill/>
-          <a:ln/>
-        </p:spPr>
-        <p:txBody>
-          <a:bodyPr wrap="square" lIns="0" tIns="0" rIns="0" bIns="0" rtlCol="0" anchor="ctr"/>
-          <a:lstStyle/>
-          <a:p>
-            <a:pPr algn="ctr" indent="0" marL="0">
-              <a:buNone/>
-            </a:pPr>
-            <a:r>
-              <a:rPr lang="en-US" sz="930" dirty="0">
-                <a:solidFill>
-                  <a:srgbClr val="1A2634"/>
-                </a:solidFill>
-                <a:latin typeface="Calibri" pitchFamily="34" charset="0"/>
-                <a:ea typeface="Calibri" pitchFamily="34" charset="-122"/>
-                <a:cs typeface="Calibri" pitchFamily="34" charset="-120"/>
-              </a:rPr>
-              <a:t>08.31</a:t>
-            </a:r>
-            <a:endParaRPr lang="en-US" sz="930" dirty="0"/>
-          </a:p>
-        </p:txBody>
-      </p:sp>
-      <p:sp>
-        <p:nvSpPr>
-          <p:cNvPr id="34" name="Shape 32"/>
-          <p:cNvSpPr/>
-          <p:nvPr/>
-        </p:nvSpPr>
-        <p:spPr>
-          <a:xfrm>
-            <a:off x="7735824" y="2354580"/>
             <a:ext cx="859536" cy="256032"/>
           </a:xfrm>
           <a:prstGeom prst="roundRect">
@@ -8077,13 +7796,13 @@
       </p:sp>
       <p:sp>
         <p:nvSpPr>
-          <p:cNvPr id="35" name="Text 33"/>
-          <p:cNvSpPr/>
-          <p:nvPr/>
-        </p:nvSpPr>
-        <p:spPr>
-          <a:xfrm>
-            <a:off x="7735824" y="2354580"/>
+          <p:cNvPr id="27" name="Text 25"/>
+          <p:cNvSpPr/>
+          <p:nvPr/>
+        </p:nvSpPr>
+        <p:spPr>
+          <a:xfrm>
+            <a:off x="7735824" y="1961388"/>
             <a:ext cx="859536" cy="256032"/>
           </a:xfrm>
           <a:prstGeom prst="rect">
@@ -8116,13 +7835,33 @@
       </p:sp>
       <p:sp>
         <p:nvSpPr>
-          <p:cNvPr id="36" name="Text 34"/>
-          <p:cNvSpPr/>
-          <p:nvPr/>
-        </p:nvSpPr>
-        <p:spPr>
-          <a:xfrm>
-            <a:off x="457200" y="2679192"/>
+          <p:cNvPr id="28" name="Shape 26"/>
+          <p:cNvSpPr/>
+          <p:nvPr/>
+        </p:nvSpPr>
+        <p:spPr>
+          <a:xfrm>
+            <a:off x="457200" y="2286000"/>
+            <a:ext cx="8229600" cy="393192"/>
+          </a:xfrm>
+          <a:prstGeom prst="rect">
+            <a:avLst/>
+          </a:prstGeom>
+          <a:solidFill>
+            <a:srgbClr val="FAFBFC"/>
+          </a:solidFill>
+          <a:ln/>
+        </p:spPr>
+      </p:sp>
+      <p:sp>
+        <p:nvSpPr>
+          <p:cNvPr id="29" name="Text 27"/>
+          <p:cNvSpPr/>
+          <p:nvPr/>
+        </p:nvSpPr>
+        <p:spPr>
+          <a:xfrm>
+            <a:off x="457200" y="2286000"/>
             <a:ext cx="475488" cy="393192"/>
           </a:xfrm>
           <a:prstGeom prst="rect">
@@ -8147,7 +7886,7 @@
                 <a:ea typeface="Cambria" pitchFamily="34" charset="-122"/>
                 <a:cs typeface="Cambria" pitchFamily="34" charset="-120"/>
               </a:rPr>
-              <a:t>04</a:t>
+              <a:t>03</a:t>
             </a:r>
             <a:endParaRPr lang="en-US" sz="980" dirty="0"/>
           </a:p>
@@ -8155,13 +7894,13 @@
       </p:sp>
       <p:sp>
         <p:nvSpPr>
-          <p:cNvPr id="37" name="Text 35"/>
-          <p:cNvSpPr/>
-          <p:nvPr/>
-        </p:nvSpPr>
-        <p:spPr>
-          <a:xfrm>
-            <a:off x="987552" y="2679192"/>
+          <p:cNvPr id="30" name="Text 28"/>
+          <p:cNvSpPr/>
+          <p:nvPr/>
+        </p:nvSpPr>
+        <p:spPr>
+          <a:xfrm>
+            <a:off x="987552" y="2286000"/>
             <a:ext cx="2523744" cy="393192"/>
           </a:xfrm>
           <a:prstGeom prst="rect">
@@ -8186,7 +7925,7 @@
                 <a:ea typeface="Calibri" pitchFamily="34" charset="-122"/>
                 <a:cs typeface="Calibri" pitchFamily="34" charset="-120"/>
               </a:rPr>
-              <a:t>업무일지 운영</a:t>
+              <a:t>품질 마인드 강화</a:t>
             </a:r>
             <a:endParaRPr lang="en-US" sz="1030" dirty="0"/>
           </a:p>
@@ -8194,13 +7933,13 @@
       </p:sp>
       <p:sp>
         <p:nvSpPr>
-          <p:cNvPr id="38" name="Text 36"/>
-          <p:cNvSpPr/>
-          <p:nvPr/>
-        </p:nvSpPr>
-        <p:spPr>
-          <a:xfrm>
-            <a:off x="3566160" y="2679192"/>
+          <p:cNvPr id="31" name="Text 29"/>
+          <p:cNvSpPr/>
+          <p:nvPr/>
+        </p:nvSpPr>
+        <p:spPr>
+          <a:xfrm>
+            <a:off x="3566160" y="2286000"/>
             <a:ext cx="2011680" cy="393192"/>
           </a:xfrm>
           <a:prstGeom prst="rect">
@@ -8225,7 +7964,7 @@
                 <a:ea typeface="Calibri" pitchFamily="34" charset="-122"/>
                 <a:cs typeface="Calibri" pitchFamily="34" charset="-120"/>
               </a:rPr>
-              <a:t>일일 업무보고 자동 생성</a:t>
+              <a:t>행동 지침서 · 교육 이력</a:t>
             </a:r>
             <a:endParaRPr lang="en-US" sz="880" dirty="0"/>
           </a:p>
@@ -8233,13 +7972,13 @@
       </p:sp>
       <p:sp>
         <p:nvSpPr>
-          <p:cNvPr id="39" name="Text 37"/>
-          <p:cNvSpPr/>
-          <p:nvPr/>
-        </p:nvSpPr>
-        <p:spPr>
-          <a:xfrm>
-            <a:off x="5632704" y="2679192"/>
+          <p:cNvPr id="32" name="Text 30"/>
+          <p:cNvSpPr/>
+          <p:nvPr/>
+        </p:nvSpPr>
+        <p:spPr>
+          <a:xfrm>
+            <a:off x="5632704" y="2286000"/>
             <a:ext cx="1207008" cy="393192"/>
           </a:xfrm>
           <a:prstGeom prst="rect">
@@ -8272,13 +8011,13 @@
       </p:sp>
       <p:sp>
         <p:nvSpPr>
-          <p:cNvPr id="40" name="Text 38"/>
-          <p:cNvSpPr/>
-          <p:nvPr/>
-        </p:nvSpPr>
-        <p:spPr>
-          <a:xfrm>
-            <a:off x="6876288" y="2679192"/>
+          <p:cNvPr id="33" name="Text 31"/>
+          <p:cNvSpPr/>
+          <p:nvPr/>
+        </p:nvSpPr>
+        <p:spPr>
+          <a:xfrm>
+            <a:off x="6876288" y="2286000"/>
             <a:ext cx="749808" cy="393192"/>
           </a:xfrm>
           <a:prstGeom prst="rect">
@@ -8303,7 +8042,7 @@
                 <a:ea typeface="Calibri" pitchFamily="34" charset="-122"/>
                 <a:cs typeface="Calibri" pitchFamily="34" charset="-120"/>
               </a:rPr>
-              <a:t>08.08</a:t>
+              <a:t>08.31</a:t>
             </a:r>
             <a:endParaRPr lang="en-US" sz="930" dirty="0"/>
           </a:p>
@@ -8311,836 +8050,13 @@
       </p:sp>
       <p:sp>
         <p:nvSpPr>
-          <p:cNvPr id="41" name="Shape 39"/>
-          <p:cNvSpPr/>
-          <p:nvPr/>
-        </p:nvSpPr>
-        <p:spPr>
-          <a:xfrm>
-            <a:off x="7735824" y="2747772"/>
-            <a:ext cx="859536" cy="256032"/>
-          </a:xfrm>
-          <a:prstGeom prst="roundRect">
-            <a:avLst>
-              <a:gd name="adj" fmla="val 17857"/>
-            </a:avLst>
-          </a:prstGeom>
-          <a:solidFill>
-            <a:srgbClr val="FFFFFF"/>
-          </a:solidFill>
-          <a:ln w="12700">
-            <a:solidFill>
-              <a:srgbClr val="1F6B4A"/>
-            </a:solidFill>
-            <a:prstDash val="solid"/>
-          </a:ln>
-        </p:spPr>
-      </p:sp>
-      <p:sp>
-        <p:nvSpPr>
-          <p:cNvPr id="42" name="Text 40"/>
-          <p:cNvSpPr/>
-          <p:nvPr/>
-        </p:nvSpPr>
-        <p:spPr>
-          <a:xfrm>
-            <a:off x="7735824" y="2747772"/>
-            <a:ext cx="859536" cy="256032"/>
-          </a:xfrm>
-          <a:prstGeom prst="rect">
-            <a:avLst/>
-          </a:prstGeom>
-          <a:noFill/>
-          <a:ln/>
-        </p:spPr>
-        <p:txBody>
-          <a:bodyPr wrap="square" lIns="0" tIns="0" rIns="0" bIns="0" rtlCol="0" anchor="ctr"/>
-          <a:lstStyle/>
-          <a:p>
-            <a:pPr algn="ctr" indent="0" marL="0">
-              <a:buNone/>
-            </a:pPr>
-            <a:r>
-              <a:rPr lang="en-US" sz="830" b="1" dirty="0">
-                <a:solidFill>
-                  <a:srgbClr val="1F6B4A"/>
-                </a:solidFill>
-                <a:latin typeface="Calibri" pitchFamily="34" charset="0"/>
-                <a:ea typeface="Calibri" pitchFamily="34" charset="-122"/>
-                <a:cs typeface="Calibri" pitchFamily="34" charset="-120"/>
-              </a:rPr>
-              <a:t>완료</a:t>
-            </a:r>
-            <a:endParaRPr lang="en-US" sz="830" dirty="0"/>
-          </a:p>
-        </p:txBody>
-      </p:sp>
-      <p:sp>
-        <p:nvSpPr>
-          <p:cNvPr id="43" name="Shape 41"/>
-          <p:cNvSpPr/>
-          <p:nvPr/>
-        </p:nvSpPr>
-        <p:spPr>
-          <a:xfrm>
-            <a:off x="457200" y="3072384"/>
-            <a:ext cx="8229600" cy="393192"/>
-          </a:xfrm>
-          <a:prstGeom prst="rect">
-            <a:avLst/>
-          </a:prstGeom>
-          <a:solidFill>
-            <a:srgbClr val="FAFBFC"/>
-          </a:solidFill>
-          <a:ln/>
-        </p:spPr>
-      </p:sp>
-      <p:sp>
-        <p:nvSpPr>
-          <p:cNvPr id="44" name="Text 42"/>
-          <p:cNvSpPr/>
-          <p:nvPr/>
-        </p:nvSpPr>
-        <p:spPr>
-          <a:xfrm>
-            <a:off x="457200" y="3072384"/>
-            <a:ext cx="475488" cy="393192"/>
-          </a:xfrm>
-          <a:prstGeom prst="rect">
-            <a:avLst/>
-          </a:prstGeom>
-          <a:noFill/>
-          <a:ln/>
-        </p:spPr>
-        <p:txBody>
-          <a:bodyPr wrap="square" lIns="0" tIns="0" rIns="0" bIns="0" rtlCol="0" anchor="ctr"/>
-          <a:lstStyle/>
-          <a:p>
-            <a:pPr algn="ctr" indent="0" marL="0">
-              <a:buNone/>
-            </a:pPr>
-            <a:r>
-              <a:rPr lang="en-US" sz="980" b="1" dirty="0">
-                <a:solidFill>
-                  <a:srgbClr val="1C7293"/>
-                </a:solidFill>
-                <a:latin typeface="Cambria" pitchFamily="34" charset="0"/>
-                <a:ea typeface="Cambria" pitchFamily="34" charset="-122"/>
-                <a:cs typeface="Cambria" pitchFamily="34" charset="-120"/>
-              </a:rPr>
-              <a:t>05</a:t>
-            </a:r>
-            <a:endParaRPr lang="en-US" sz="980" dirty="0"/>
-          </a:p>
-        </p:txBody>
-      </p:sp>
-      <p:sp>
-        <p:nvSpPr>
-          <p:cNvPr id="45" name="Text 43"/>
-          <p:cNvSpPr/>
-          <p:nvPr/>
-        </p:nvSpPr>
-        <p:spPr>
-          <a:xfrm>
-            <a:off x="987552" y="3072384"/>
-            <a:ext cx="2523744" cy="393192"/>
-          </a:xfrm>
-          <a:prstGeom prst="rect">
-            <a:avLst/>
-          </a:prstGeom>
-          <a:noFill/>
-          <a:ln/>
-        </p:spPr>
-        <p:txBody>
-          <a:bodyPr wrap="square" lIns="762" tIns="762" rIns="762" bIns="762" rtlCol="0" anchor="ctr"/>
-          <a:lstStyle/>
-          <a:p>
-            <a:pPr indent="0" marL="0">
-              <a:buNone/>
-            </a:pPr>
-            <a:r>
-              <a:rPr lang="en-US" sz="1030" b="1" dirty="0">
-                <a:solidFill>
-                  <a:srgbClr val="21295C"/>
-                </a:solidFill>
-                <a:latin typeface="Calibri" pitchFamily="34" charset="0"/>
-                <a:ea typeface="Calibri" pitchFamily="34" charset="-122"/>
-                <a:cs typeface="Calibri" pitchFamily="34" charset="-120"/>
-              </a:rPr>
-              <a:t>ERP 기반 모니터링</a:t>
-            </a:r>
-            <a:endParaRPr lang="en-US" sz="1030" dirty="0"/>
-          </a:p>
-        </p:txBody>
-      </p:sp>
-      <p:sp>
-        <p:nvSpPr>
-          <p:cNvPr id="46" name="Text 44"/>
-          <p:cNvSpPr/>
-          <p:nvPr/>
-        </p:nvSpPr>
-        <p:spPr>
-          <a:xfrm>
-            <a:off x="3566160" y="3072384"/>
-            <a:ext cx="2011680" cy="393192"/>
-          </a:xfrm>
-          <a:prstGeom prst="rect">
-            <a:avLst/>
-          </a:prstGeom>
-          <a:noFill/>
-          <a:ln/>
-        </p:spPr>
-        <p:txBody>
-          <a:bodyPr wrap="square" lIns="762" tIns="762" rIns="762" bIns="762" rtlCol="0" anchor="ctr"/>
-          <a:lstStyle/>
-          <a:p>
-            <a:pPr indent="0" marL="0">
-              <a:buNone/>
-            </a:pPr>
-            <a:r>
-              <a:rPr lang="en-US" sz="880" dirty="0">
-                <a:solidFill>
-                  <a:srgbClr val="5A6B7C"/>
-                </a:solidFill>
-                <a:latin typeface="Calibri" pitchFamily="34" charset="0"/>
-                <a:ea typeface="Calibri" pitchFamily="34" charset="-122"/>
-                <a:cs typeface="Calibri" pitchFamily="34" charset="-120"/>
-              </a:rPr>
-              <a:t>업무관리 시스템 · 실시간 현황</a:t>
-            </a:r>
-            <a:endParaRPr lang="en-US" sz="880" dirty="0"/>
-          </a:p>
-        </p:txBody>
-      </p:sp>
-      <p:sp>
-        <p:nvSpPr>
-          <p:cNvPr id="47" name="Text 45"/>
-          <p:cNvSpPr/>
-          <p:nvPr/>
-        </p:nvSpPr>
-        <p:spPr>
-          <a:xfrm>
-            <a:off x="5632704" y="3072384"/>
-            <a:ext cx="1207008" cy="393192"/>
-          </a:xfrm>
-          <a:prstGeom prst="rect">
-            <a:avLst/>
-          </a:prstGeom>
-          <a:noFill/>
-          <a:ln/>
-        </p:spPr>
-        <p:txBody>
-          <a:bodyPr wrap="square" lIns="0" tIns="0" rIns="0" bIns="0" rtlCol="0" anchor="ctr"/>
-          <a:lstStyle/>
-          <a:p>
-            <a:pPr algn="ctr" indent="0" marL="0">
-              <a:buNone/>
-            </a:pPr>
-            <a:r>
-              <a:rPr lang="en-US" sz="930" dirty="0">
-                <a:solidFill>
-                  <a:srgbClr val="1A2634"/>
-                </a:solidFill>
-                <a:latin typeface="Calibri" pitchFamily="34" charset="0"/>
-                <a:ea typeface="Calibri" pitchFamily="34" charset="-122"/>
-                <a:cs typeface="Calibri" pitchFamily="34" charset="-120"/>
-              </a:rPr>
-              <a:t>김양섭 이사</a:t>
-            </a:r>
-            <a:endParaRPr lang="en-US" sz="930" dirty="0"/>
-          </a:p>
-        </p:txBody>
-      </p:sp>
-      <p:sp>
-        <p:nvSpPr>
-          <p:cNvPr id="48" name="Text 46"/>
-          <p:cNvSpPr/>
-          <p:nvPr/>
-        </p:nvSpPr>
-        <p:spPr>
-          <a:xfrm>
-            <a:off x="6876288" y="3072384"/>
-            <a:ext cx="749808" cy="393192"/>
-          </a:xfrm>
-          <a:prstGeom prst="rect">
-            <a:avLst/>
-          </a:prstGeom>
-          <a:noFill/>
-          <a:ln/>
-        </p:spPr>
-        <p:txBody>
-          <a:bodyPr wrap="square" lIns="0" tIns="0" rIns="0" bIns="0" rtlCol="0" anchor="ctr"/>
-          <a:lstStyle/>
-          <a:p>
-            <a:pPr algn="ctr" indent="0" marL="0">
-              <a:buNone/>
-            </a:pPr>
-            <a:r>
-              <a:rPr lang="en-US" sz="930" dirty="0">
-                <a:solidFill>
-                  <a:srgbClr val="1A2634"/>
-                </a:solidFill>
-                <a:latin typeface="Calibri" pitchFamily="34" charset="0"/>
-                <a:ea typeface="Calibri" pitchFamily="34" charset="-122"/>
-                <a:cs typeface="Calibri" pitchFamily="34" charset="-120"/>
-              </a:rPr>
-              <a:t>08.08</a:t>
-            </a:r>
-            <a:endParaRPr lang="en-US" sz="930" dirty="0"/>
-          </a:p>
-        </p:txBody>
-      </p:sp>
-      <p:sp>
-        <p:nvSpPr>
-          <p:cNvPr id="49" name="Shape 47"/>
-          <p:cNvSpPr/>
-          <p:nvPr/>
-        </p:nvSpPr>
-        <p:spPr>
-          <a:xfrm>
-            <a:off x="7735824" y="3140964"/>
-            <a:ext cx="859536" cy="256032"/>
-          </a:xfrm>
-          <a:prstGeom prst="roundRect">
-            <a:avLst>
-              <a:gd name="adj" fmla="val 17857"/>
-            </a:avLst>
-          </a:prstGeom>
-          <a:solidFill>
-            <a:srgbClr val="FFFFFF"/>
-          </a:solidFill>
-          <a:ln w="12700">
-            <a:solidFill>
-              <a:srgbClr val="1F6B4A"/>
-            </a:solidFill>
-            <a:prstDash val="solid"/>
-          </a:ln>
-        </p:spPr>
-      </p:sp>
-      <p:sp>
-        <p:nvSpPr>
-          <p:cNvPr id="50" name="Text 48"/>
-          <p:cNvSpPr/>
-          <p:nvPr/>
-        </p:nvSpPr>
-        <p:spPr>
-          <a:xfrm>
-            <a:off x="7735824" y="3140964"/>
-            <a:ext cx="859536" cy="256032"/>
-          </a:xfrm>
-          <a:prstGeom prst="rect">
-            <a:avLst/>
-          </a:prstGeom>
-          <a:noFill/>
-          <a:ln/>
-        </p:spPr>
-        <p:txBody>
-          <a:bodyPr wrap="square" lIns="0" tIns="0" rIns="0" bIns="0" rtlCol="0" anchor="ctr"/>
-          <a:lstStyle/>
-          <a:p>
-            <a:pPr algn="ctr" indent="0" marL="0">
-              <a:buNone/>
-            </a:pPr>
-            <a:r>
-              <a:rPr lang="en-US" sz="830" b="1" dirty="0">
-                <a:solidFill>
-                  <a:srgbClr val="1F6B4A"/>
-                </a:solidFill>
-                <a:latin typeface="Calibri" pitchFamily="34" charset="0"/>
-                <a:ea typeface="Calibri" pitchFamily="34" charset="-122"/>
-                <a:cs typeface="Calibri" pitchFamily="34" charset="-120"/>
-              </a:rPr>
-              <a:t>완료</a:t>
-            </a:r>
-            <a:endParaRPr lang="en-US" sz="830" dirty="0"/>
-          </a:p>
-        </p:txBody>
-      </p:sp>
-      <p:sp>
-        <p:nvSpPr>
-          <p:cNvPr id="51" name="Text 49"/>
-          <p:cNvSpPr/>
-          <p:nvPr/>
-        </p:nvSpPr>
-        <p:spPr>
-          <a:xfrm>
-            <a:off x="457200" y="3465576"/>
-            <a:ext cx="475488" cy="393192"/>
-          </a:xfrm>
-          <a:prstGeom prst="rect">
-            <a:avLst/>
-          </a:prstGeom>
-          <a:noFill/>
-          <a:ln/>
-        </p:spPr>
-        <p:txBody>
-          <a:bodyPr wrap="square" lIns="0" tIns="0" rIns="0" bIns="0" rtlCol="0" anchor="ctr"/>
-          <a:lstStyle/>
-          <a:p>
-            <a:pPr algn="ctr" indent="0" marL="0">
-              <a:buNone/>
-            </a:pPr>
-            <a:r>
-              <a:rPr lang="en-US" sz="980" b="1" dirty="0">
-                <a:solidFill>
-                  <a:srgbClr val="1C7293"/>
-                </a:solidFill>
-                <a:latin typeface="Cambria" pitchFamily="34" charset="0"/>
-                <a:ea typeface="Cambria" pitchFamily="34" charset="-122"/>
-                <a:cs typeface="Cambria" pitchFamily="34" charset="-120"/>
-              </a:rPr>
-              <a:t>06</a:t>
-            </a:r>
-            <a:endParaRPr lang="en-US" sz="980" dirty="0"/>
-          </a:p>
-        </p:txBody>
-      </p:sp>
-      <p:sp>
-        <p:nvSpPr>
-          <p:cNvPr id="52" name="Text 50"/>
-          <p:cNvSpPr/>
-          <p:nvPr/>
-        </p:nvSpPr>
-        <p:spPr>
-          <a:xfrm>
-            <a:off x="987552" y="3465576"/>
-            <a:ext cx="2523744" cy="393192"/>
-          </a:xfrm>
-          <a:prstGeom prst="rect">
-            <a:avLst/>
-          </a:prstGeom>
-          <a:noFill/>
-          <a:ln/>
-        </p:spPr>
-        <p:txBody>
-          <a:bodyPr wrap="square" lIns="762" tIns="762" rIns="762" bIns="762" rtlCol="0" anchor="ctr"/>
-          <a:lstStyle/>
-          <a:p>
-            <a:pPr indent="0" marL="0">
-              <a:buNone/>
-            </a:pPr>
-            <a:r>
-              <a:rPr lang="en-US" sz="1030" b="1" dirty="0">
-                <a:solidFill>
-                  <a:srgbClr val="21295C"/>
-                </a:solidFill>
-                <a:latin typeface="Calibri" pitchFamily="34" charset="0"/>
-                <a:ea typeface="Calibri" pitchFamily="34" charset="-122"/>
-                <a:cs typeface="Calibri" pitchFamily="34" charset="-120"/>
-              </a:rPr>
-              <a:t>시스템 환경 구축</a:t>
-            </a:r>
-            <a:endParaRPr lang="en-US" sz="1030" dirty="0"/>
-          </a:p>
-        </p:txBody>
-      </p:sp>
-      <p:sp>
-        <p:nvSpPr>
-          <p:cNvPr id="53" name="Text 51"/>
-          <p:cNvSpPr/>
-          <p:nvPr/>
-        </p:nvSpPr>
-        <p:spPr>
-          <a:xfrm>
-            <a:off x="3566160" y="3465576"/>
-            <a:ext cx="2011680" cy="393192"/>
-          </a:xfrm>
-          <a:prstGeom prst="rect">
-            <a:avLst/>
-          </a:prstGeom>
-          <a:noFill/>
-          <a:ln/>
-        </p:spPr>
-        <p:txBody>
-          <a:bodyPr wrap="square" lIns="762" tIns="762" rIns="762" bIns="762" rtlCol="0" anchor="ctr"/>
-          <a:lstStyle/>
-          <a:p>
-            <a:pPr indent="0" marL="0">
-              <a:buNone/>
-            </a:pPr>
-            <a:r>
-              <a:rPr lang="en-US" sz="880" dirty="0">
-                <a:solidFill>
-                  <a:srgbClr val="5A6B7C"/>
-                </a:solidFill>
-                <a:latin typeface="Calibri" pitchFamily="34" charset="0"/>
-                <a:ea typeface="Calibri" pitchFamily="34" charset="-122"/>
-                <a:cs typeface="Calibri" pitchFamily="34" charset="-120"/>
-              </a:rPr>
-              <a:t>USIM 라우터 · 전용 노트북</a:t>
-            </a:r>
-            <a:endParaRPr lang="en-US" sz="880" dirty="0"/>
-          </a:p>
-        </p:txBody>
-      </p:sp>
-      <p:sp>
-        <p:nvSpPr>
-          <p:cNvPr id="54" name="Text 52"/>
-          <p:cNvSpPr/>
-          <p:nvPr/>
-        </p:nvSpPr>
-        <p:spPr>
-          <a:xfrm>
-            <a:off x="5632704" y="3465576"/>
-            <a:ext cx="1207008" cy="393192"/>
-          </a:xfrm>
-          <a:prstGeom prst="rect">
-            <a:avLst/>
-          </a:prstGeom>
-          <a:noFill/>
-          <a:ln/>
-        </p:spPr>
-        <p:txBody>
-          <a:bodyPr wrap="square" lIns="0" tIns="0" rIns="0" bIns="0" rtlCol="0" anchor="ctr"/>
-          <a:lstStyle/>
-          <a:p>
-            <a:pPr algn="ctr" indent="0" marL="0">
-              <a:buNone/>
-            </a:pPr>
-            <a:r>
-              <a:rPr lang="en-US" sz="930" dirty="0">
-                <a:solidFill>
-                  <a:srgbClr val="1A2634"/>
-                </a:solidFill>
-                <a:latin typeface="Calibri" pitchFamily="34" charset="0"/>
-                <a:ea typeface="Calibri" pitchFamily="34" charset="-122"/>
-                <a:cs typeface="Calibri" pitchFamily="34" charset="-120"/>
-              </a:rPr>
-              <a:t>김양섭 이사</a:t>
-            </a:r>
-            <a:endParaRPr lang="en-US" sz="930" dirty="0"/>
-          </a:p>
-        </p:txBody>
-      </p:sp>
-      <p:sp>
-        <p:nvSpPr>
-          <p:cNvPr id="55" name="Text 53"/>
-          <p:cNvSpPr/>
-          <p:nvPr/>
-        </p:nvSpPr>
-        <p:spPr>
-          <a:xfrm>
-            <a:off x="6876288" y="3465576"/>
-            <a:ext cx="749808" cy="393192"/>
-          </a:xfrm>
-          <a:prstGeom prst="rect">
-            <a:avLst/>
-          </a:prstGeom>
-          <a:noFill/>
-          <a:ln/>
-        </p:spPr>
-        <p:txBody>
-          <a:bodyPr wrap="square" lIns="0" tIns="0" rIns="0" bIns="0" rtlCol="0" anchor="ctr"/>
-          <a:lstStyle/>
-          <a:p>
-            <a:pPr algn="ctr" indent="0" marL="0">
-              <a:buNone/>
-            </a:pPr>
-            <a:r>
-              <a:rPr lang="en-US" sz="930" dirty="0">
-                <a:solidFill>
-                  <a:srgbClr val="1A2634"/>
-                </a:solidFill>
-                <a:latin typeface="Calibri" pitchFamily="34" charset="0"/>
-                <a:ea typeface="Calibri" pitchFamily="34" charset="-122"/>
-                <a:cs typeface="Calibri" pitchFamily="34" charset="-120"/>
-              </a:rPr>
-              <a:t>08.15</a:t>
-            </a:r>
-            <a:endParaRPr lang="en-US" sz="930" dirty="0"/>
-          </a:p>
-        </p:txBody>
-      </p:sp>
-      <p:sp>
-        <p:nvSpPr>
-          <p:cNvPr id="56" name="Shape 54"/>
-          <p:cNvSpPr/>
-          <p:nvPr/>
-        </p:nvSpPr>
-        <p:spPr>
-          <a:xfrm>
-            <a:off x="7735824" y="3534156"/>
-            <a:ext cx="859536" cy="256032"/>
-          </a:xfrm>
-          <a:prstGeom prst="roundRect">
-            <a:avLst>
-              <a:gd name="adj" fmla="val 17857"/>
-            </a:avLst>
-          </a:prstGeom>
-          <a:solidFill>
-            <a:srgbClr val="FFFFFF"/>
-          </a:solidFill>
-          <a:ln w="12700">
-            <a:solidFill>
-              <a:srgbClr val="9A6B12"/>
-            </a:solidFill>
-            <a:prstDash val="solid"/>
-          </a:ln>
-        </p:spPr>
-      </p:sp>
-      <p:sp>
-        <p:nvSpPr>
-          <p:cNvPr id="57" name="Text 55"/>
-          <p:cNvSpPr/>
-          <p:nvPr/>
-        </p:nvSpPr>
-        <p:spPr>
-          <a:xfrm>
-            <a:off x="7735824" y="3534156"/>
-            <a:ext cx="859536" cy="256032"/>
-          </a:xfrm>
-          <a:prstGeom prst="rect">
-            <a:avLst/>
-          </a:prstGeom>
-          <a:noFill/>
-          <a:ln/>
-        </p:spPr>
-        <p:txBody>
-          <a:bodyPr wrap="square" lIns="0" tIns="0" rIns="0" bIns="0" rtlCol="0" anchor="ctr"/>
-          <a:lstStyle/>
-          <a:p>
-            <a:pPr algn="ctr" indent="0" marL="0">
-              <a:buNone/>
-            </a:pPr>
-            <a:r>
-              <a:rPr lang="en-US" sz="830" b="1" dirty="0">
-                <a:solidFill>
-                  <a:srgbClr val="9A6B12"/>
-                </a:solidFill>
-                <a:latin typeface="Calibri" pitchFamily="34" charset="0"/>
-                <a:ea typeface="Calibri" pitchFamily="34" charset="-122"/>
-                <a:cs typeface="Calibri" pitchFamily="34" charset="-120"/>
-              </a:rPr>
-              <a:t>구축 중</a:t>
-            </a:r>
-            <a:endParaRPr lang="en-US" sz="830" dirty="0"/>
-          </a:p>
-        </p:txBody>
-      </p:sp>
-      <p:sp>
-        <p:nvSpPr>
-          <p:cNvPr id="58" name="Shape 56"/>
-          <p:cNvSpPr/>
-          <p:nvPr/>
-        </p:nvSpPr>
-        <p:spPr>
-          <a:xfrm>
-            <a:off x="457200" y="3858768"/>
-            <a:ext cx="8229600" cy="393192"/>
-          </a:xfrm>
-          <a:prstGeom prst="rect">
-            <a:avLst/>
-          </a:prstGeom>
-          <a:solidFill>
-            <a:srgbClr val="FAFBFC"/>
-          </a:solidFill>
-          <a:ln/>
-        </p:spPr>
-      </p:sp>
-      <p:sp>
-        <p:nvSpPr>
-          <p:cNvPr id="59" name="Text 57"/>
-          <p:cNvSpPr/>
-          <p:nvPr/>
-        </p:nvSpPr>
-        <p:spPr>
-          <a:xfrm>
-            <a:off x="457200" y="3858768"/>
-            <a:ext cx="475488" cy="393192"/>
-          </a:xfrm>
-          <a:prstGeom prst="rect">
-            <a:avLst/>
-          </a:prstGeom>
-          <a:noFill/>
-          <a:ln/>
-        </p:spPr>
-        <p:txBody>
-          <a:bodyPr wrap="square" lIns="0" tIns="0" rIns="0" bIns="0" rtlCol="0" anchor="ctr"/>
-          <a:lstStyle/>
-          <a:p>
-            <a:pPr algn="ctr" indent="0" marL="0">
-              <a:buNone/>
-            </a:pPr>
-            <a:r>
-              <a:rPr lang="en-US" sz="980" b="1" dirty="0">
-                <a:solidFill>
-                  <a:srgbClr val="1C7293"/>
-                </a:solidFill>
-                <a:latin typeface="Cambria" pitchFamily="34" charset="0"/>
-                <a:ea typeface="Cambria" pitchFamily="34" charset="-122"/>
-                <a:cs typeface="Cambria" pitchFamily="34" charset="-120"/>
-              </a:rPr>
-              <a:t>07</a:t>
-            </a:r>
-            <a:endParaRPr lang="en-US" sz="980" dirty="0"/>
-          </a:p>
-        </p:txBody>
-      </p:sp>
-      <p:sp>
-        <p:nvSpPr>
-          <p:cNvPr id="60" name="Text 58"/>
-          <p:cNvSpPr/>
-          <p:nvPr/>
-        </p:nvSpPr>
-        <p:spPr>
-          <a:xfrm>
-            <a:off x="987552" y="3858768"/>
-            <a:ext cx="2523744" cy="393192"/>
-          </a:xfrm>
-          <a:prstGeom prst="rect">
-            <a:avLst/>
-          </a:prstGeom>
-          <a:noFill/>
-          <a:ln/>
-        </p:spPr>
-        <p:txBody>
-          <a:bodyPr wrap="square" lIns="762" tIns="762" rIns="762" bIns="762" rtlCol="0" anchor="ctr"/>
-          <a:lstStyle/>
-          <a:p>
-            <a:pPr indent="0" marL="0">
-              <a:buNone/>
-            </a:pPr>
-            <a:r>
-              <a:rPr lang="en-US" sz="1030" b="1" dirty="0">
-                <a:solidFill>
-                  <a:srgbClr val="21295C"/>
-                </a:solidFill>
-                <a:latin typeface="Calibri" pitchFamily="34" charset="0"/>
-                <a:ea typeface="Calibri" pitchFamily="34" charset="-122"/>
-                <a:cs typeface="Calibri" pitchFamily="34" charset="-120"/>
-              </a:rPr>
-              <a:t>교육 · 면담 체계 운영</a:t>
-            </a:r>
-            <a:endParaRPr lang="en-US" sz="1030" dirty="0"/>
-          </a:p>
-        </p:txBody>
-      </p:sp>
-      <p:sp>
-        <p:nvSpPr>
-          <p:cNvPr id="61" name="Text 59"/>
-          <p:cNvSpPr/>
-          <p:nvPr/>
-        </p:nvSpPr>
-        <p:spPr>
-          <a:xfrm>
-            <a:off x="3566160" y="3858768"/>
-            <a:ext cx="2011680" cy="393192"/>
-          </a:xfrm>
-          <a:prstGeom prst="rect">
-            <a:avLst/>
-          </a:prstGeom>
-          <a:noFill/>
-          <a:ln/>
-        </p:spPr>
-        <p:txBody>
-          <a:bodyPr wrap="square" lIns="762" tIns="762" rIns="762" bIns="762" rtlCol="0" anchor="ctr"/>
-          <a:lstStyle/>
-          <a:p>
-            <a:pPr indent="0" marL="0">
-              <a:buNone/>
-            </a:pPr>
-            <a:r>
-              <a:rPr lang="en-US" sz="880" dirty="0">
-                <a:solidFill>
-                  <a:srgbClr val="5A6B7C"/>
-                </a:solidFill>
-                <a:latin typeface="Calibri" pitchFamily="34" charset="0"/>
-                <a:ea typeface="Calibri" pitchFamily="34" charset="-122"/>
-                <a:cs typeface="Calibri" pitchFamily="34" charset="-120"/>
-              </a:rPr>
-              <a:t>월 1회 방문 면담 · 역량평가</a:t>
-            </a:r>
-            <a:endParaRPr lang="en-US" sz="880" dirty="0"/>
-          </a:p>
-        </p:txBody>
-      </p:sp>
-      <p:sp>
-        <p:nvSpPr>
-          <p:cNvPr id="62" name="Text 60"/>
-          <p:cNvSpPr/>
-          <p:nvPr/>
-        </p:nvSpPr>
-        <p:spPr>
-          <a:xfrm>
-            <a:off x="5632704" y="3858768"/>
-            <a:ext cx="1207008" cy="393192"/>
-          </a:xfrm>
-          <a:prstGeom prst="rect">
-            <a:avLst/>
-          </a:prstGeom>
-          <a:noFill/>
-          <a:ln/>
-        </p:spPr>
-        <p:txBody>
-          <a:bodyPr wrap="square" lIns="0" tIns="0" rIns="0" bIns="0" rtlCol="0" anchor="ctr"/>
-          <a:lstStyle/>
-          <a:p>
-            <a:pPr algn="ctr" indent="0" marL="0">
-              <a:buNone/>
-            </a:pPr>
-            <a:r>
-              <a:rPr lang="en-US" sz="930" dirty="0">
-                <a:solidFill>
-                  <a:srgbClr val="1A2634"/>
-                </a:solidFill>
-                <a:latin typeface="Calibri" pitchFamily="34" charset="0"/>
-                <a:ea typeface="Calibri" pitchFamily="34" charset="-122"/>
-                <a:cs typeface="Calibri" pitchFamily="34" charset="-120"/>
-              </a:rPr>
-              <a:t>김양섭 이사</a:t>
-            </a:r>
-            <a:endParaRPr lang="en-US" sz="930" dirty="0"/>
-          </a:p>
-        </p:txBody>
-      </p:sp>
-      <p:sp>
-        <p:nvSpPr>
-          <p:cNvPr id="63" name="Text 61"/>
-          <p:cNvSpPr/>
-          <p:nvPr/>
-        </p:nvSpPr>
-        <p:spPr>
-          <a:xfrm>
-            <a:off x="6876288" y="3858768"/>
-            <a:ext cx="749808" cy="393192"/>
-          </a:xfrm>
-          <a:prstGeom prst="rect">
-            <a:avLst/>
-          </a:prstGeom>
-          <a:noFill/>
-          <a:ln/>
-        </p:spPr>
-        <p:txBody>
-          <a:bodyPr wrap="square" lIns="0" tIns="0" rIns="0" bIns="0" rtlCol="0" anchor="ctr"/>
-          <a:lstStyle/>
-          <a:p>
-            <a:pPr algn="ctr" indent="0" marL="0">
-              <a:buNone/>
-            </a:pPr>
-            <a:r>
-              <a:rPr lang="en-US" sz="930" dirty="0">
-                <a:solidFill>
-                  <a:srgbClr val="1A2634"/>
-                </a:solidFill>
-                <a:latin typeface="Calibri" pitchFamily="34" charset="0"/>
-                <a:ea typeface="Calibri" pitchFamily="34" charset="-122"/>
-                <a:cs typeface="Calibri" pitchFamily="34" charset="-120"/>
-              </a:rPr>
-              <a:t>08.31</a:t>
-            </a:r>
-            <a:endParaRPr lang="en-US" sz="930" dirty="0"/>
-          </a:p>
-        </p:txBody>
-      </p:sp>
-      <p:sp>
-        <p:nvSpPr>
-          <p:cNvPr id="64" name="Shape 62"/>
-          <p:cNvSpPr/>
-          <p:nvPr/>
-        </p:nvSpPr>
-        <p:spPr>
-          <a:xfrm>
-            <a:off x="7735824" y="3927348"/>
+          <p:cNvPr id="34" name="Shape 32"/>
+          <p:cNvSpPr/>
+          <p:nvPr/>
+        </p:nvSpPr>
+        <p:spPr>
+          <a:xfrm>
+            <a:off x="7735824" y="2354580"/>
             <a:ext cx="859536" cy="256032"/>
           </a:xfrm>
           <a:prstGeom prst="roundRect">
@@ -9161,6 +8077,1090 @@
       </p:sp>
       <p:sp>
         <p:nvSpPr>
+          <p:cNvPr id="35" name="Text 33"/>
+          <p:cNvSpPr/>
+          <p:nvPr/>
+        </p:nvSpPr>
+        <p:spPr>
+          <a:xfrm>
+            <a:off x="7735824" y="2354580"/>
+            <a:ext cx="859536" cy="256032"/>
+          </a:xfrm>
+          <a:prstGeom prst="rect">
+            <a:avLst/>
+          </a:prstGeom>
+          <a:noFill/>
+          <a:ln/>
+        </p:spPr>
+        <p:txBody>
+          <a:bodyPr wrap="square" lIns="0" tIns="0" rIns="0" bIns="0" rtlCol="0" anchor="ctr"/>
+          <a:lstStyle/>
+          <a:p>
+            <a:pPr algn="ctr" indent="0" marL="0">
+              <a:buNone/>
+            </a:pPr>
+            <a:r>
+              <a:rPr lang="en-US" sz="830" b="1" dirty="0">
+                <a:solidFill>
+                  <a:srgbClr val="1C7293"/>
+                </a:solidFill>
+                <a:latin typeface="Calibri" pitchFamily="34" charset="0"/>
+                <a:ea typeface="Calibri" pitchFamily="34" charset="-122"/>
+                <a:cs typeface="Calibri" pitchFamily="34" charset="-120"/>
+              </a:rPr>
+              <a:t>진행 중</a:t>
+            </a:r>
+            <a:endParaRPr lang="en-US" sz="830" dirty="0"/>
+          </a:p>
+        </p:txBody>
+      </p:sp>
+      <p:sp>
+        <p:nvSpPr>
+          <p:cNvPr id="36" name="Text 34"/>
+          <p:cNvSpPr/>
+          <p:nvPr/>
+        </p:nvSpPr>
+        <p:spPr>
+          <a:xfrm>
+            <a:off x="457200" y="2679192"/>
+            <a:ext cx="475488" cy="393192"/>
+          </a:xfrm>
+          <a:prstGeom prst="rect">
+            <a:avLst/>
+          </a:prstGeom>
+          <a:noFill/>
+          <a:ln/>
+        </p:spPr>
+        <p:txBody>
+          <a:bodyPr wrap="square" lIns="0" tIns="0" rIns="0" bIns="0" rtlCol="0" anchor="ctr"/>
+          <a:lstStyle/>
+          <a:p>
+            <a:pPr algn="ctr" indent="0" marL="0">
+              <a:buNone/>
+            </a:pPr>
+            <a:r>
+              <a:rPr lang="en-US" sz="980" b="1" dirty="0">
+                <a:solidFill>
+                  <a:srgbClr val="1C7293"/>
+                </a:solidFill>
+                <a:latin typeface="Cambria" pitchFamily="34" charset="0"/>
+                <a:ea typeface="Cambria" pitchFamily="34" charset="-122"/>
+                <a:cs typeface="Cambria" pitchFamily="34" charset="-120"/>
+              </a:rPr>
+              <a:t>04</a:t>
+            </a:r>
+            <a:endParaRPr lang="en-US" sz="980" dirty="0"/>
+          </a:p>
+        </p:txBody>
+      </p:sp>
+      <p:sp>
+        <p:nvSpPr>
+          <p:cNvPr id="37" name="Text 35"/>
+          <p:cNvSpPr/>
+          <p:nvPr/>
+        </p:nvSpPr>
+        <p:spPr>
+          <a:xfrm>
+            <a:off x="987552" y="2679192"/>
+            <a:ext cx="2523744" cy="393192"/>
+          </a:xfrm>
+          <a:prstGeom prst="rect">
+            <a:avLst/>
+          </a:prstGeom>
+          <a:noFill/>
+          <a:ln/>
+        </p:spPr>
+        <p:txBody>
+          <a:bodyPr wrap="square" lIns="762" tIns="762" rIns="762" bIns="762" rtlCol="0" anchor="ctr"/>
+          <a:lstStyle/>
+          <a:p>
+            <a:pPr indent="0" marL="0">
+              <a:buNone/>
+            </a:pPr>
+            <a:r>
+              <a:rPr lang="en-US" sz="1030" b="1" dirty="0">
+                <a:solidFill>
+                  <a:srgbClr val="21295C"/>
+                </a:solidFill>
+                <a:latin typeface="Calibri" pitchFamily="34" charset="0"/>
+                <a:ea typeface="Calibri" pitchFamily="34" charset="-122"/>
+                <a:cs typeface="Calibri" pitchFamily="34" charset="-120"/>
+              </a:rPr>
+              <a:t>업무일지 운영</a:t>
+            </a:r>
+            <a:endParaRPr lang="en-US" sz="1030" dirty="0"/>
+          </a:p>
+        </p:txBody>
+      </p:sp>
+      <p:sp>
+        <p:nvSpPr>
+          <p:cNvPr id="38" name="Text 36"/>
+          <p:cNvSpPr/>
+          <p:nvPr/>
+        </p:nvSpPr>
+        <p:spPr>
+          <a:xfrm>
+            <a:off x="3566160" y="2679192"/>
+            <a:ext cx="2011680" cy="393192"/>
+          </a:xfrm>
+          <a:prstGeom prst="rect">
+            <a:avLst/>
+          </a:prstGeom>
+          <a:noFill/>
+          <a:ln/>
+        </p:spPr>
+        <p:txBody>
+          <a:bodyPr wrap="square" lIns="762" tIns="762" rIns="762" bIns="762" rtlCol="0" anchor="ctr"/>
+          <a:lstStyle/>
+          <a:p>
+            <a:pPr indent="0" marL="0">
+              <a:buNone/>
+            </a:pPr>
+            <a:r>
+              <a:rPr lang="en-US" sz="880" dirty="0">
+                <a:solidFill>
+                  <a:srgbClr val="5A6B7C"/>
+                </a:solidFill>
+                <a:latin typeface="Calibri" pitchFamily="34" charset="0"/>
+                <a:ea typeface="Calibri" pitchFamily="34" charset="-122"/>
+                <a:cs typeface="Calibri" pitchFamily="34" charset="-120"/>
+              </a:rPr>
+              <a:t>일일 업무보고 자동 생성</a:t>
+            </a:r>
+            <a:endParaRPr lang="en-US" sz="880" dirty="0"/>
+          </a:p>
+        </p:txBody>
+      </p:sp>
+      <p:sp>
+        <p:nvSpPr>
+          <p:cNvPr id="39" name="Text 37"/>
+          <p:cNvSpPr/>
+          <p:nvPr/>
+        </p:nvSpPr>
+        <p:spPr>
+          <a:xfrm>
+            <a:off x="5632704" y="2679192"/>
+            <a:ext cx="1207008" cy="393192"/>
+          </a:xfrm>
+          <a:prstGeom prst="rect">
+            <a:avLst/>
+          </a:prstGeom>
+          <a:noFill/>
+          <a:ln/>
+        </p:spPr>
+        <p:txBody>
+          <a:bodyPr wrap="square" lIns="0" tIns="0" rIns="0" bIns="0" rtlCol="0" anchor="ctr"/>
+          <a:lstStyle/>
+          <a:p>
+            <a:pPr algn="ctr" indent="0" marL="0">
+              <a:buNone/>
+            </a:pPr>
+            <a:r>
+              <a:rPr lang="en-US" sz="930" dirty="0">
+                <a:solidFill>
+                  <a:srgbClr val="1A2634"/>
+                </a:solidFill>
+                <a:latin typeface="Calibri" pitchFamily="34" charset="0"/>
+                <a:ea typeface="Calibri" pitchFamily="34" charset="-122"/>
+                <a:cs typeface="Calibri" pitchFamily="34" charset="-120"/>
+              </a:rPr>
+              <a:t>김종선 대리</a:t>
+            </a:r>
+            <a:endParaRPr lang="en-US" sz="930" dirty="0"/>
+          </a:p>
+        </p:txBody>
+      </p:sp>
+      <p:sp>
+        <p:nvSpPr>
+          <p:cNvPr id="40" name="Text 38"/>
+          <p:cNvSpPr/>
+          <p:nvPr/>
+        </p:nvSpPr>
+        <p:spPr>
+          <a:xfrm>
+            <a:off x="6876288" y="2679192"/>
+            <a:ext cx="749808" cy="393192"/>
+          </a:xfrm>
+          <a:prstGeom prst="rect">
+            <a:avLst/>
+          </a:prstGeom>
+          <a:noFill/>
+          <a:ln/>
+        </p:spPr>
+        <p:txBody>
+          <a:bodyPr wrap="square" lIns="0" tIns="0" rIns="0" bIns="0" rtlCol="0" anchor="ctr"/>
+          <a:lstStyle/>
+          <a:p>
+            <a:pPr algn="ctr" indent="0" marL="0">
+              <a:buNone/>
+            </a:pPr>
+            <a:r>
+              <a:rPr lang="en-US" sz="930" dirty="0">
+                <a:solidFill>
+                  <a:srgbClr val="1A2634"/>
+                </a:solidFill>
+                <a:latin typeface="Calibri" pitchFamily="34" charset="0"/>
+                <a:ea typeface="Calibri" pitchFamily="34" charset="-122"/>
+                <a:cs typeface="Calibri" pitchFamily="34" charset="-120"/>
+              </a:rPr>
+              <a:t>08.31</a:t>
+            </a:r>
+            <a:endParaRPr lang="en-US" sz="930" dirty="0"/>
+          </a:p>
+        </p:txBody>
+      </p:sp>
+      <p:sp>
+        <p:nvSpPr>
+          <p:cNvPr id="41" name="Shape 39"/>
+          <p:cNvSpPr/>
+          <p:nvPr/>
+        </p:nvSpPr>
+        <p:spPr>
+          <a:xfrm>
+            <a:off x="7735824" y="2747772"/>
+            <a:ext cx="859536" cy="256032"/>
+          </a:xfrm>
+          <a:prstGeom prst="roundRect">
+            <a:avLst>
+              <a:gd name="adj" fmla="val 17857"/>
+            </a:avLst>
+          </a:prstGeom>
+          <a:solidFill>
+            <a:srgbClr val="FFFFFF"/>
+          </a:solidFill>
+          <a:ln w="12700">
+            <a:solidFill>
+              <a:srgbClr val="1C7293"/>
+            </a:solidFill>
+            <a:prstDash val="solid"/>
+          </a:ln>
+        </p:spPr>
+      </p:sp>
+      <p:sp>
+        <p:nvSpPr>
+          <p:cNvPr id="42" name="Text 40"/>
+          <p:cNvSpPr/>
+          <p:nvPr/>
+        </p:nvSpPr>
+        <p:spPr>
+          <a:xfrm>
+            <a:off x="7735824" y="2747772"/>
+            <a:ext cx="859536" cy="256032"/>
+          </a:xfrm>
+          <a:prstGeom prst="rect">
+            <a:avLst/>
+          </a:prstGeom>
+          <a:noFill/>
+          <a:ln/>
+        </p:spPr>
+        <p:txBody>
+          <a:bodyPr wrap="square" lIns="0" tIns="0" rIns="0" bIns="0" rtlCol="0" anchor="ctr"/>
+          <a:lstStyle/>
+          <a:p>
+            <a:pPr algn="ctr" indent="0" marL="0">
+              <a:buNone/>
+            </a:pPr>
+            <a:r>
+              <a:rPr lang="en-US" sz="830" b="1" dirty="0">
+                <a:solidFill>
+                  <a:srgbClr val="1C7293"/>
+                </a:solidFill>
+                <a:latin typeface="Calibri" pitchFamily="34" charset="0"/>
+                <a:ea typeface="Calibri" pitchFamily="34" charset="-122"/>
+                <a:cs typeface="Calibri" pitchFamily="34" charset="-120"/>
+              </a:rPr>
+              <a:t>진행 중</a:t>
+            </a:r>
+            <a:endParaRPr lang="en-US" sz="830" dirty="0"/>
+          </a:p>
+        </p:txBody>
+      </p:sp>
+      <p:sp>
+        <p:nvSpPr>
+          <p:cNvPr id="43" name="Shape 41"/>
+          <p:cNvSpPr/>
+          <p:nvPr/>
+        </p:nvSpPr>
+        <p:spPr>
+          <a:xfrm>
+            <a:off x="457200" y="3072384"/>
+            <a:ext cx="8229600" cy="393192"/>
+          </a:xfrm>
+          <a:prstGeom prst="rect">
+            <a:avLst/>
+          </a:prstGeom>
+          <a:solidFill>
+            <a:srgbClr val="FAFBFC"/>
+          </a:solidFill>
+          <a:ln/>
+        </p:spPr>
+      </p:sp>
+      <p:sp>
+        <p:nvSpPr>
+          <p:cNvPr id="44" name="Text 42"/>
+          <p:cNvSpPr/>
+          <p:nvPr/>
+        </p:nvSpPr>
+        <p:spPr>
+          <a:xfrm>
+            <a:off x="457200" y="3072384"/>
+            <a:ext cx="475488" cy="393192"/>
+          </a:xfrm>
+          <a:prstGeom prst="rect">
+            <a:avLst/>
+          </a:prstGeom>
+          <a:noFill/>
+          <a:ln/>
+        </p:spPr>
+        <p:txBody>
+          <a:bodyPr wrap="square" lIns="0" tIns="0" rIns="0" bIns="0" rtlCol="0" anchor="ctr"/>
+          <a:lstStyle/>
+          <a:p>
+            <a:pPr algn="ctr" indent="0" marL="0">
+              <a:buNone/>
+            </a:pPr>
+            <a:r>
+              <a:rPr lang="en-US" sz="980" b="1" dirty="0">
+                <a:solidFill>
+                  <a:srgbClr val="1C7293"/>
+                </a:solidFill>
+                <a:latin typeface="Cambria" pitchFamily="34" charset="0"/>
+                <a:ea typeface="Cambria" pitchFamily="34" charset="-122"/>
+                <a:cs typeface="Cambria" pitchFamily="34" charset="-120"/>
+              </a:rPr>
+              <a:t>05</a:t>
+            </a:r>
+            <a:endParaRPr lang="en-US" sz="980" dirty="0"/>
+          </a:p>
+        </p:txBody>
+      </p:sp>
+      <p:sp>
+        <p:nvSpPr>
+          <p:cNvPr id="45" name="Text 43"/>
+          <p:cNvSpPr/>
+          <p:nvPr/>
+        </p:nvSpPr>
+        <p:spPr>
+          <a:xfrm>
+            <a:off x="987552" y="3072384"/>
+            <a:ext cx="2523744" cy="393192"/>
+          </a:xfrm>
+          <a:prstGeom prst="rect">
+            <a:avLst/>
+          </a:prstGeom>
+          <a:noFill/>
+          <a:ln/>
+        </p:spPr>
+        <p:txBody>
+          <a:bodyPr wrap="square" lIns="762" tIns="762" rIns="762" bIns="762" rtlCol="0" anchor="ctr"/>
+          <a:lstStyle/>
+          <a:p>
+            <a:pPr indent="0" marL="0">
+              <a:buNone/>
+            </a:pPr>
+            <a:r>
+              <a:rPr lang="en-US" sz="1030" b="1" dirty="0">
+                <a:solidFill>
+                  <a:srgbClr val="21295C"/>
+                </a:solidFill>
+                <a:latin typeface="Calibri" pitchFamily="34" charset="0"/>
+                <a:ea typeface="Calibri" pitchFamily="34" charset="-122"/>
+                <a:cs typeface="Calibri" pitchFamily="34" charset="-120"/>
+              </a:rPr>
+              <a:t>ERP 기반 모니터링</a:t>
+            </a:r>
+            <a:endParaRPr lang="en-US" sz="1030" dirty="0"/>
+          </a:p>
+        </p:txBody>
+      </p:sp>
+      <p:sp>
+        <p:nvSpPr>
+          <p:cNvPr id="46" name="Text 44"/>
+          <p:cNvSpPr/>
+          <p:nvPr/>
+        </p:nvSpPr>
+        <p:spPr>
+          <a:xfrm>
+            <a:off x="3566160" y="3072384"/>
+            <a:ext cx="2011680" cy="393192"/>
+          </a:xfrm>
+          <a:prstGeom prst="rect">
+            <a:avLst/>
+          </a:prstGeom>
+          <a:noFill/>
+          <a:ln/>
+        </p:spPr>
+        <p:txBody>
+          <a:bodyPr wrap="square" lIns="762" tIns="762" rIns="762" bIns="762" rtlCol="0" anchor="ctr"/>
+          <a:lstStyle/>
+          <a:p>
+            <a:pPr indent="0" marL="0">
+              <a:buNone/>
+            </a:pPr>
+            <a:r>
+              <a:rPr lang="en-US" sz="880" dirty="0">
+                <a:solidFill>
+                  <a:srgbClr val="5A6B7C"/>
+                </a:solidFill>
+                <a:latin typeface="Calibri" pitchFamily="34" charset="0"/>
+                <a:ea typeface="Calibri" pitchFamily="34" charset="-122"/>
+                <a:cs typeface="Calibri" pitchFamily="34" charset="-120"/>
+              </a:rPr>
+              <a:t>업무관리 시스템 · 실시간 현황</a:t>
+            </a:r>
+            <a:endParaRPr lang="en-US" sz="880" dirty="0"/>
+          </a:p>
+        </p:txBody>
+      </p:sp>
+      <p:sp>
+        <p:nvSpPr>
+          <p:cNvPr id="47" name="Text 45"/>
+          <p:cNvSpPr/>
+          <p:nvPr/>
+        </p:nvSpPr>
+        <p:spPr>
+          <a:xfrm>
+            <a:off x="5632704" y="3072384"/>
+            <a:ext cx="1207008" cy="393192"/>
+          </a:xfrm>
+          <a:prstGeom prst="rect">
+            <a:avLst/>
+          </a:prstGeom>
+          <a:noFill/>
+          <a:ln/>
+        </p:spPr>
+        <p:txBody>
+          <a:bodyPr wrap="square" lIns="0" tIns="0" rIns="0" bIns="0" rtlCol="0" anchor="ctr"/>
+          <a:lstStyle/>
+          <a:p>
+            <a:pPr algn="ctr" indent="0" marL="0">
+              <a:buNone/>
+            </a:pPr>
+            <a:r>
+              <a:rPr lang="en-US" sz="930" dirty="0">
+                <a:solidFill>
+                  <a:srgbClr val="1A2634"/>
+                </a:solidFill>
+                <a:latin typeface="Calibri" pitchFamily="34" charset="0"/>
+                <a:ea typeface="Calibri" pitchFamily="34" charset="-122"/>
+                <a:cs typeface="Calibri" pitchFamily="34" charset="-120"/>
+              </a:rPr>
+              <a:t>김양섭 이사</a:t>
+            </a:r>
+            <a:endParaRPr lang="en-US" sz="930" dirty="0"/>
+          </a:p>
+        </p:txBody>
+      </p:sp>
+      <p:sp>
+        <p:nvSpPr>
+          <p:cNvPr id="48" name="Text 46"/>
+          <p:cNvSpPr/>
+          <p:nvPr/>
+        </p:nvSpPr>
+        <p:spPr>
+          <a:xfrm>
+            <a:off x="6876288" y="3072384"/>
+            <a:ext cx="749808" cy="393192"/>
+          </a:xfrm>
+          <a:prstGeom prst="rect">
+            <a:avLst/>
+          </a:prstGeom>
+          <a:noFill/>
+          <a:ln/>
+        </p:spPr>
+        <p:txBody>
+          <a:bodyPr wrap="square" lIns="0" tIns="0" rIns="0" bIns="0" rtlCol="0" anchor="ctr"/>
+          <a:lstStyle/>
+          <a:p>
+            <a:pPr algn="ctr" indent="0" marL="0">
+              <a:buNone/>
+            </a:pPr>
+            <a:r>
+              <a:rPr lang="en-US" sz="930" dirty="0">
+                <a:solidFill>
+                  <a:srgbClr val="1A2634"/>
+                </a:solidFill>
+                <a:latin typeface="Calibri" pitchFamily="34" charset="0"/>
+                <a:ea typeface="Calibri" pitchFamily="34" charset="-122"/>
+                <a:cs typeface="Calibri" pitchFamily="34" charset="-120"/>
+              </a:rPr>
+              <a:t>08.31</a:t>
+            </a:r>
+            <a:endParaRPr lang="en-US" sz="930" dirty="0"/>
+          </a:p>
+        </p:txBody>
+      </p:sp>
+      <p:sp>
+        <p:nvSpPr>
+          <p:cNvPr id="49" name="Shape 47"/>
+          <p:cNvSpPr/>
+          <p:nvPr/>
+        </p:nvSpPr>
+        <p:spPr>
+          <a:xfrm>
+            <a:off x="7735824" y="3140964"/>
+            <a:ext cx="859536" cy="256032"/>
+          </a:xfrm>
+          <a:prstGeom prst="roundRect">
+            <a:avLst>
+              <a:gd name="adj" fmla="val 17857"/>
+            </a:avLst>
+          </a:prstGeom>
+          <a:solidFill>
+            <a:srgbClr val="FFFFFF"/>
+          </a:solidFill>
+          <a:ln w="12700">
+            <a:solidFill>
+              <a:srgbClr val="1C7293"/>
+            </a:solidFill>
+            <a:prstDash val="solid"/>
+          </a:ln>
+        </p:spPr>
+      </p:sp>
+      <p:sp>
+        <p:nvSpPr>
+          <p:cNvPr id="50" name="Text 48"/>
+          <p:cNvSpPr/>
+          <p:nvPr/>
+        </p:nvSpPr>
+        <p:spPr>
+          <a:xfrm>
+            <a:off x="7735824" y="3140964"/>
+            <a:ext cx="859536" cy="256032"/>
+          </a:xfrm>
+          <a:prstGeom prst="rect">
+            <a:avLst/>
+          </a:prstGeom>
+          <a:noFill/>
+          <a:ln/>
+        </p:spPr>
+        <p:txBody>
+          <a:bodyPr wrap="square" lIns="0" tIns="0" rIns="0" bIns="0" rtlCol="0" anchor="ctr"/>
+          <a:lstStyle/>
+          <a:p>
+            <a:pPr algn="ctr" indent="0" marL="0">
+              <a:buNone/>
+            </a:pPr>
+            <a:r>
+              <a:rPr lang="en-US" sz="830" b="1" dirty="0">
+                <a:solidFill>
+                  <a:srgbClr val="1C7293"/>
+                </a:solidFill>
+                <a:latin typeface="Calibri" pitchFamily="34" charset="0"/>
+                <a:ea typeface="Calibri" pitchFamily="34" charset="-122"/>
+                <a:cs typeface="Calibri" pitchFamily="34" charset="-120"/>
+              </a:rPr>
+              <a:t>진행 중</a:t>
+            </a:r>
+            <a:endParaRPr lang="en-US" sz="830" dirty="0"/>
+          </a:p>
+        </p:txBody>
+      </p:sp>
+      <p:sp>
+        <p:nvSpPr>
+          <p:cNvPr id="51" name="Text 49"/>
+          <p:cNvSpPr/>
+          <p:nvPr/>
+        </p:nvSpPr>
+        <p:spPr>
+          <a:xfrm>
+            <a:off x="457200" y="3465576"/>
+            <a:ext cx="475488" cy="393192"/>
+          </a:xfrm>
+          <a:prstGeom prst="rect">
+            <a:avLst/>
+          </a:prstGeom>
+          <a:noFill/>
+          <a:ln/>
+        </p:spPr>
+        <p:txBody>
+          <a:bodyPr wrap="square" lIns="0" tIns="0" rIns="0" bIns="0" rtlCol="0" anchor="ctr"/>
+          <a:lstStyle/>
+          <a:p>
+            <a:pPr algn="ctr" indent="0" marL="0">
+              <a:buNone/>
+            </a:pPr>
+            <a:r>
+              <a:rPr lang="en-US" sz="980" b="1" dirty="0">
+                <a:solidFill>
+                  <a:srgbClr val="1C7293"/>
+                </a:solidFill>
+                <a:latin typeface="Cambria" pitchFamily="34" charset="0"/>
+                <a:ea typeface="Cambria" pitchFamily="34" charset="-122"/>
+                <a:cs typeface="Cambria" pitchFamily="34" charset="-120"/>
+              </a:rPr>
+              <a:t>06</a:t>
+            </a:r>
+            <a:endParaRPr lang="en-US" sz="980" dirty="0"/>
+          </a:p>
+        </p:txBody>
+      </p:sp>
+      <p:sp>
+        <p:nvSpPr>
+          <p:cNvPr id="52" name="Text 50"/>
+          <p:cNvSpPr/>
+          <p:nvPr/>
+        </p:nvSpPr>
+        <p:spPr>
+          <a:xfrm>
+            <a:off x="987552" y="3465576"/>
+            <a:ext cx="2523744" cy="393192"/>
+          </a:xfrm>
+          <a:prstGeom prst="rect">
+            <a:avLst/>
+          </a:prstGeom>
+          <a:noFill/>
+          <a:ln/>
+        </p:spPr>
+        <p:txBody>
+          <a:bodyPr wrap="square" lIns="762" tIns="762" rIns="762" bIns="762" rtlCol="0" anchor="ctr"/>
+          <a:lstStyle/>
+          <a:p>
+            <a:pPr indent="0" marL="0">
+              <a:buNone/>
+            </a:pPr>
+            <a:r>
+              <a:rPr lang="en-US" sz="1030" b="1" dirty="0">
+                <a:solidFill>
+                  <a:srgbClr val="21295C"/>
+                </a:solidFill>
+                <a:latin typeface="Calibri" pitchFamily="34" charset="0"/>
+                <a:ea typeface="Calibri" pitchFamily="34" charset="-122"/>
+                <a:cs typeface="Calibri" pitchFamily="34" charset="-120"/>
+              </a:rPr>
+              <a:t>시스템 환경 구축</a:t>
+            </a:r>
+            <a:endParaRPr lang="en-US" sz="1030" dirty="0"/>
+          </a:p>
+        </p:txBody>
+      </p:sp>
+      <p:sp>
+        <p:nvSpPr>
+          <p:cNvPr id="53" name="Text 51"/>
+          <p:cNvSpPr/>
+          <p:nvPr/>
+        </p:nvSpPr>
+        <p:spPr>
+          <a:xfrm>
+            <a:off x="3566160" y="3465576"/>
+            <a:ext cx="2011680" cy="393192"/>
+          </a:xfrm>
+          <a:prstGeom prst="rect">
+            <a:avLst/>
+          </a:prstGeom>
+          <a:noFill/>
+          <a:ln/>
+        </p:spPr>
+        <p:txBody>
+          <a:bodyPr wrap="square" lIns="762" tIns="762" rIns="762" bIns="762" rtlCol="0" anchor="ctr"/>
+          <a:lstStyle/>
+          <a:p>
+            <a:pPr indent="0" marL="0">
+              <a:buNone/>
+            </a:pPr>
+            <a:r>
+              <a:rPr lang="en-US" sz="880" dirty="0">
+                <a:solidFill>
+                  <a:srgbClr val="5A6B7C"/>
+                </a:solidFill>
+                <a:latin typeface="Calibri" pitchFamily="34" charset="0"/>
+                <a:ea typeface="Calibri" pitchFamily="34" charset="-122"/>
+                <a:cs typeface="Calibri" pitchFamily="34" charset="-120"/>
+              </a:rPr>
+              <a:t>USIM 라우터 · 전용 노트북</a:t>
+            </a:r>
+            <a:endParaRPr lang="en-US" sz="880" dirty="0"/>
+          </a:p>
+        </p:txBody>
+      </p:sp>
+      <p:sp>
+        <p:nvSpPr>
+          <p:cNvPr id="54" name="Text 52"/>
+          <p:cNvSpPr/>
+          <p:nvPr/>
+        </p:nvSpPr>
+        <p:spPr>
+          <a:xfrm>
+            <a:off x="5632704" y="3465576"/>
+            <a:ext cx="1207008" cy="393192"/>
+          </a:xfrm>
+          <a:prstGeom prst="rect">
+            <a:avLst/>
+          </a:prstGeom>
+          <a:noFill/>
+          <a:ln/>
+        </p:spPr>
+        <p:txBody>
+          <a:bodyPr wrap="square" lIns="0" tIns="0" rIns="0" bIns="0" rtlCol="0" anchor="ctr"/>
+          <a:lstStyle/>
+          <a:p>
+            <a:pPr algn="ctr" indent="0" marL="0">
+              <a:buNone/>
+            </a:pPr>
+            <a:r>
+              <a:rPr lang="en-US" sz="930" dirty="0">
+                <a:solidFill>
+                  <a:srgbClr val="1A2634"/>
+                </a:solidFill>
+                <a:latin typeface="Calibri" pitchFamily="34" charset="0"/>
+                <a:ea typeface="Calibri" pitchFamily="34" charset="-122"/>
+                <a:cs typeface="Calibri" pitchFamily="34" charset="-120"/>
+              </a:rPr>
+              <a:t>김양섭 이사</a:t>
+            </a:r>
+            <a:endParaRPr lang="en-US" sz="930" dirty="0"/>
+          </a:p>
+        </p:txBody>
+      </p:sp>
+      <p:sp>
+        <p:nvSpPr>
+          <p:cNvPr id="55" name="Text 53"/>
+          <p:cNvSpPr/>
+          <p:nvPr/>
+        </p:nvSpPr>
+        <p:spPr>
+          <a:xfrm>
+            <a:off x="6876288" y="3465576"/>
+            <a:ext cx="749808" cy="393192"/>
+          </a:xfrm>
+          <a:prstGeom prst="rect">
+            <a:avLst/>
+          </a:prstGeom>
+          <a:noFill/>
+          <a:ln/>
+        </p:spPr>
+        <p:txBody>
+          <a:bodyPr wrap="square" lIns="0" tIns="0" rIns="0" bIns="0" rtlCol="0" anchor="ctr"/>
+          <a:lstStyle/>
+          <a:p>
+            <a:pPr algn="ctr" indent="0" marL="0">
+              <a:buNone/>
+            </a:pPr>
+            <a:r>
+              <a:rPr lang="en-US" sz="930" dirty="0">
+                <a:solidFill>
+                  <a:srgbClr val="1A2634"/>
+                </a:solidFill>
+                <a:latin typeface="Calibri" pitchFamily="34" charset="0"/>
+                <a:ea typeface="Calibri" pitchFamily="34" charset="-122"/>
+                <a:cs typeface="Calibri" pitchFamily="34" charset="-120"/>
+              </a:rPr>
+              <a:t>08.31</a:t>
+            </a:r>
+            <a:endParaRPr lang="en-US" sz="930" dirty="0"/>
+          </a:p>
+        </p:txBody>
+      </p:sp>
+      <p:sp>
+        <p:nvSpPr>
+          <p:cNvPr id="56" name="Shape 54"/>
+          <p:cNvSpPr/>
+          <p:nvPr/>
+        </p:nvSpPr>
+        <p:spPr>
+          <a:xfrm>
+            <a:off x="7735824" y="3534156"/>
+            <a:ext cx="859536" cy="256032"/>
+          </a:xfrm>
+          <a:prstGeom prst="roundRect">
+            <a:avLst>
+              <a:gd name="adj" fmla="val 17857"/>
+            </a:avLst>
+          </a:prstGeom>
+          <a:solidFill>
+            <a:srgbClr val="FFFFFF"/>
+          </a:solidFill>
+          <a:ln w="12700">
+            <a:solidFill>
+              <a:srgbClr val="1C7293"/>
+            </a:solidFill>
+            <a:prstDash val="solid"/>
+          </a:ln>
+        </p:spPr>
+      </p:sp>
+      <p:sp>
+        <p:nvSpPr>
+          <p:cNvPr id="57" name="Text 55"/>
+          <p:cNvSpPr/>
+          <p:nvPr/>
+        </p:nvSpPr>
+        <p:spPr>
+          <a:xfrm>
+            <a:off x="7735824" y="3534156"/>
+            <a:ext cx="859536" cy="256032"/>
+          </a:xfrm>
+          <a:prstGeom prst="rect">
+            <a:avLst/>
+          </a:prstGeom>
+          <a:noFill/>
+          <a:ln/>
+        </p:spPr>
+        <p:txBody>
+          <a:bodyPr wrap="square" lIns="0" tIns="0" rIns="0" bIns="0" rtlCol="0" anchor="ctr"/>
+          <a:lstStyle/>
+          <a:p>
+            <a:pPr algn="ctr" indent="0" marL="0">
+              <a:buNone/>
+            </a:pPr>
+            <a:r>
+              <a:rPr lang="en-US" sz="830" b="1" dirty="0">
+                <a:solidFill>
+                  <a:srgbClr val="1C7293"/>
+                </a:solidFill>
+                <a:latin typeface="Calibri" pitchFamily="34" charset="0"/>
+                <a:ea typeface="Calibri" pitchFamily="34" charset="-122"/>
+                <a:cs typeface="Calibri" pitchFamily="34" charset="-120"/>
+              </a:rPr>
+              <a:t>진행 중</a:t>
+            </a:r>
+            <a:endParaRPr lang="en-US" sz="830" dirty="0"/>
+          </a:p>
+        </p:txBody>
+      </p:sp>
+      <p:sp>
+        <p:nvSpPr>
+          <p:cNvPr id="58" name="Shape 56"/>
+          <p:cNvSpPr/>
+          <p:nvPr/>
+        </p:nvSpPr>
+        <p:spPr>
+          <a:xfrm>
+            <a:off x="457200" y="3858768"/>
+            <a:ext cx="8229600" cy="393192"/>
+          </a:xfrm>
+          <a:prstGeom prst="rect">
+            <a:avLst/>
+          </a:prstGeom>
+          <a:solidFill>
+            <a:srgbClr val="FAFBFC"/>
+          </a:solidFill>
+          <a:ln/>
+        </p:spPr>
+      </p:sp>
+      <p:sp>
+        <p:nvSpPr>
+          <p:cNvPr id="59" name="Text 57"/>
+          <p:cNvSpPr/>
+          <p:nvPr/>
+        </p:nvSpPr>
+        <p:spPr>
+          <a:xfrm>
+            <a:off x="457200" y="3858768"/>
+            <a:ext cx="475488" cy="393192"/>
+          </a:xfrm>
+          <a:prstGeom prst="rect">
+            <a:avLst/>
+          </a:prstGeom>
+          <a:noFill/>
+          <a:ln/>
+        </p:spPr>
+        <p:txBody>
+          <a:bodyPr wrap="square" lIns="0" tIns="0" rIns="0" bIns="0" rtlCol="0" anchor="ctr"/>
+          <a:lstStyle/>
+          <a:p>
+            <a:pPr algn="ctr" indent="0" marL="0">
+              <a:buNone/>
+            </a:pPr>
+            <a:r>
+              <a:rPr lang="en-US" sz="980" b="1" dirty="0">
+                <a:solidFill>
+                  <a:srgbClr val="1C7293"/>
+                </a:solidFill>
+                <a:latin typeface="Cambria" pitchFamily="34" charset="0"/>
+                <a:ea typeface="Cambria" pitchFamily="34" charset="-122"/>
+                <a:cs typeface="Cambria" pitchFamily="34" charset="-120"/>
+              </a:rPr>
+              <a:t>07</a:t>
+            </a:r>
+            <a:endParaRPr lang="en-US" sz="980" dirty="0"/>
+          </a:p>
+        </p:txBody>
+      </p:sp>
+      <p:sp>
+        <p:nvSpPr>
+          <p:cNvPr id="60" name="Text 58"/>
+          <p:cNvSpPr/>
+          <p:nvPr/>
+        </p:nvSpPr>
+        <p:spPr>
+          <a:xfrm>
+            <a:off x="987552" y="3858768"/>
+            <a:ext cx="2523744" cy="393192"/>
+          </a:xfrm>
+          <a:prstGeom prst="rect">
+            <a:avLst/>
+          </a:prstGeom>
+          <a:noFill/>
+          <a:ln/>
+        </p:spPr>
+        <p:txBody>
+          <a:bodyPr wrap="square" lIns="762" tIns="762" rIns="762" bIns="762" rtlCol="0" anchor="ctr"/>
+          <a:lstStyle/>
+          <a:p>
+            <a:pPr indent="0" marL="0">
+              <a:buNone/>
+            </a:pPr>
+            <a:r>
+              <a:rPr lang="en-US" sz="1030" b="1" dirty="0">
+                <a:solidFill>
+                  <a:srgbClr val="21295C"/>
+                </a:solidFill>
+                <a:latin typeface="Calibri" pitchFamily="34" charset="0"/>
+                <a:ea typeface="Calibri" pitchFamily="34" charset="-122"/>
+                <a:cs typeface="Calibri" pitchFamily="34" charset="-120"/>
+              </a:rPr>
+              <a:t>교육 · 면담 체계 운영</a:t>
+            </a:r>
+            <a:endParaRPr lang="en-US" sz="1030" dirty="0"/>
+          </a:p>
+        </p:txBody>
+      </p:sp>
+      <p:sp>
+        <p:nvSpPr>
+          <p:cNvPr id="61" name="Text 59"/>
+          <p:cNvSpPr/>
+          <p:nvPr/>
+        </p:nvSpPr>
+        <p:spPr>
+          <a:xfrm>
+            <a:off x="3566160" y="3858768"/>
+            <a:ext cx="2011680" cy="393192"/>
+          </a:xfrm>
+          <a:prstGeom prst="rect">
+            <a:avLst/>
+          </a:prstGeom>
+          <a:noFill/>
+          <a:ln/>
+        </p:spPr>
+        <p:txBody>
+          <a:bodyPr wrap="square" lIns="762" tIns="762" rIns="762" bIns="762" rtlCol="0" anchor="ctr"/>
+          <a:lstStyle/>
+          <a:p>
+            <a:pPr indent="0" marL="0">
+              <a:buNone/>
+            </a:pPr>
+            <a:r>
+              <a:rPr lang="en-US" sz="880" dirty="0">
+                <a:solidFill>
+                  <a:srgbClr val="5A6B7C"/>
+                </a:solidFill>
+                <a:latin typeface="Calibri" pitchFamily="34" charset="0"/>
+                <a:ea typeface="Calibri" pitchFamily="34" charset="-122"/>
+                <a:cs typeface="Calibri" pitchFamily="34" charset="-120"/>
+              </a:rPr>
+              <a:t>월 1회 방문 면담 · 역량평가</a:t>
+            </a:r>
+            <a:endParaRPr lang="en-US" sz="880" dirty="0"/>
+          </a:p>
+        </p:txBody>
+      </p:sp>
+      <p:sp>
+        <p:nvSpPr>
+          <p:cNvPr id="62" name="Text 60"/>
+          <p:cNvSpPr/>
+          <p:nvPr/>
+        </p:nvSpPr>
+        <p:spPr>
+          <a:xfrm>
+            <a:off x="5632704" y="3858768"/>
+            <a:ext cx="1207008" cy="393192"/>
+          </a:xfrm>
+          <a:prstGeom prst="rect">
+            <a:avLst/>
+          </a:prstGeom>
+          <a:noFill/>
+          <a:ln/>
+        </p:spPr>
+        <p:txBody>
+          <a:bodyPr wrap="square" lIns="0" tIns="0" rIns="0" bIns="0" rtlCol="0" anchor="ctr"/>
+          <a:lstStyle/>
+          <a:p>
+            <a:pPr algn="ctr" indent="0" marL="0">
+              <a:buNone/>
+            </a:pPr>
+            <a:r>
+              <a:rPr lang="en-US" sz="930" dirty="0">
+                <a:solidFill>
+                  <a:srgbClr val="1A2634"/>
+                </a:solidFill>
+                <a:latin typeface="Calibri" pitchFamily="34" charset="0"/>
+                <a:ea typeface="Calibri" pitchFamily="34" charset="-122"/>
+                <a:cs typeface="Calibri" pitchFamily="34" charset="-120"/>
+              </a:rPr>
+              <a:t>김양섭 이사</a:t>
+            </a:r>
+            <a:endParaRPr lang="en-US" sz="930" dirty="0"/>
+          </a:p>
+        </p:txBody>
+      </p:sp>
+      <p:sp>
+        <p:nvSpPr>
+          <p:cNvPr id="63" name="Text 61"/>
+          <p:cNvSpPr/>
+          <p:nvPr/>
+        </p:nvSpPr>
+        <p:spPr>
+          <a:xfrm>
+            <a:off x="6876288" y="3858768"/>
+            <a:ext cx="749808" cy="393192"/>
+          </a:xfrm>
+          <a:prstGeom prst="rect">
+            <a:avLst/>
+          </a:prstGeom>
+          <a:noFill/>
+          <a:ln/>
+        </p:spPr>
+        <p:txBody>
+          <a:bodyPr wrap="square" lIns="0" tIns="0" rIns="0" bIns="0" rtlCol="0" anchor="ctr"/>
+          <a:lstStyle/>
+          <a:p>
+            <a:pPr algn="ctr" indent="0" marL="0">
+              <a:buNone/>
+            </a:pPr>
+            <a:r>
+              <a:rPr lang="en-US" sz="930" dirty="0">
+                <a:solidFill>
+                  <a:srgbClr val="1A2634"/>
+                </a:solidFill>
+                <a:latin typeface="Calibri" pitchFamily="34" charset="0"/>
+                <a:ea typeface="Calibri" pitchFamily="34" charset="-122"/>
+                <a:cs typeface="Calibri" pitchFamily="34" charset="-120"/>
+              </a:rPr>
+              <a:t>08.31</a:t>
+            </a:r>
+            <a:endParaRPr lang="en-US" sz="930" dirty="0"/>
+          </a:p>
+        </p:txBody>
+      </p:sp>
+      <p:sp>
+        <p:nvSpPr>
+          <p:cNvPr id="64" name="Shape 62"/>
+          <p:cNvSpPr/>
+          <p:nvPr/>
+        </p:nvSpPr>
+        <p:spPr>
+          <a:xfrm>
+            <a:off x="7735824" y="3927348"/>
+            <a:ext cx="859536" cy="256032"/>
+          </a:xfrm>
+          <a:prstGeom prst="roundRect">
+            <a:avLst>
+              <a:gd name="adj" fmla="val 17857"/>
+            </a:avLst>
+          </a:prstGeom>
+          <a:solidFill>
+            <a:srgbClr val="FFFFFF"/>
+          </a:solidFill>
+          <a:ln w="12700">
+            <a:solidFill>
+              <a:srgbClr val="1C7293"/>
+            </a:solidFill>
+            <a:prstDash val="solid"/>
+          </a:ln>
+        </p:spPr>
+      </p:sp>
+      <p:sp>
+        <p:nvSpPr>
           <p:cNvPr id="65" name="Text 63"/>
           <p:cNvSpPr/>
           <p:nvPr/>
@@ -9317,7 +9317,7 @@
                 <a:ea typeface="Calibri" pitchFamily="34" charset="-122"/>
                 <a:cs typeface="Calibri" pitchFamily="34" charset="-120"/>
               </a:rPr>
-              <a:t>㈜인시스  ·  셰플러 이천공장 수입검사 실행계획서 v4.0</a:t>
+              <a:t>㈜인시스  ·  셰플러 이천공장 수입검사 실행계획서 v4.1</a:t>
             </a:r>
             <a:endParaRPr lang="en-US" sz="800" dirty="0"/>
           </a:p>
@@ -11488,7 +11488,7 @@
                 <a:ea typeface="Calibri" pitchFamily="34" charset="-122"/>
                 <a:cs typeface="Calibri" pitchFamily="34" charset="-120"/>
               </a:rPr>
-              <a:t>㈜인시스  ·  셰플러 이천공장 수입검사 실행계획서 v4.0</a:t>
+              <a:t>㈜인시스  ·  셰플러 이천공장 수입검사 실행계획서 v4.1</a:t>
             </a:r>
             <a:endParaRPr lang="en-US" sz="800" dirty="0"/>
           </a:p>
@@ -12971,7 +12971,7 @@
                 <a:ea typeface="Calibri" pitchFamily="34" charset="-122"/>
                 <a:cs typeface="Calibri" pitchFamily="34" charset="-120"/>
               </a:rPr>
-              <a:t>㈜인시스  ·  셰플러 이천공장 수입검사 실행계획서 v4.0</a:t>
+              <a:t>㈜인시스  ·  셰플러 이천공장 수입검사 실행계획서 v4.1</a:t>
             </a:r>
             <a:endParaRPr lang="en-US" sz="800" dirty="0"/>
           </a:p>
@@ -14138,7 +14138,7 @@
                 <a:ea typeface="Calibri" pitchFamily="34" charset="-122"/>
                 <a:cs typeface="Calibri" pitchFamily="34" charset="-120"/>
               </a:rPr>
-              <a:t>㈜인시스  ·  셰플러 이천공장 수입검사 실행계획서 v4.0</a:t>
+              <a:t>㈜인시스  ·  셰플러 이천공장 수입검사 실행계획서 v4.1</a:t>
             </a:r>
             <a:endParaRPr lang="en-US" sz="800" dirty="0"/>
           </a:p>
@@ -16191,7 +16191,7 @@
                 <a:ea typeface="Calibri" pitchFamily="34" charset="-122"/>
                 <a:cs typeface="Calibri" pitchFamily="34" charset="-120"/>
               </a:rPr>
-              <a:t>㈜인시스  ·  셰플러 이천공장 수입검사 실행계획서 v4.0</a:t>
+              <a:t>㈜인시스  ·  셰플러 이천공장 수입검사 실행계획서 v4.1</a:t>
             </a:r>
             <a:endParaRPr lang="en-US" sz="800" dirty="0"/>
           </a:p>
@@ -17758,7 +17758,7 @@
                 <a:ea typeface="Calibri" pitchFamily="34" charset="-122"/>
                 <a:cs typeface="Calibri" pitchFamily="34" charset="-120"/>
               </a:rPr>
-              <a:t>㈜인시스  ·  셰플러 이천공장 수입검사 실행계획서 v4.0</a:t>
+              <a:t>㈜인시스  ·  셰플러 이천공장 수입검사 실행계획서 v4.1</a:t>
             </a:r>
             <a:endParaRPr lang="en-US" sz="800" dirty="0"/>
           </a:p>
@@ -19286,7 +19286,7 @@
                 <a:ea typeface="Calibri" pitchFamily="34" charset="-122"/>
                 <a:cs typeface="Calibri" pitchFamily="34" charset="-120"/>
               </a:rPr>
-              <a:t>㈜인시스  ·  셰플러 이천공장 수입검사 실행계획서 v4.0</a:t>
+              <a:t>㈜인시스  ·  셰플러 이천공장 수입검사 실행계획서 v4.1</a:t>
             </a:r>
             <a:endParaRPr lang="en-US" sz="800" dirty="0"/>
           </a:p>
@@ -20993,7 +20993,7 @@
                 <a:ea typeface="Calibri" pitchFamily="34" charset="-122"/>
                 <a:cs typeface="Calibri" pitchFamily="34" charset="-120"/>
               </a:rPr>
-              <a:t>㈜인시스  ·  셰플러 이천공장 수입검사 실행계획서 v4.0</a:t>
+              <a:t>㈜인시스  ·  셰플러 이천공장 수입검사 실행계획서 v4.1</a:t>
             </a:r>
             <a:endParaRPr lang="en-US" sz="800" dirty="0"/>
           </a:p>
@@ -22422,7 +22422,7 @@
                 <a:ea typeface="Calibri" pitchFamily="34" charset="-122"/>
                 <a:cs typeface="Calibri" pitchFamily="34" charset="-120"/>
               </a:rPr>
-              <a:t>㈜인시스  ·  셰플러 이천공장 수입검사 실행계획서 v4.0</a:t>
+              <a:t>㈜인시스  ·  셰플러 이천공장 수입검사 실행계획서 v4.1</a:t>
             </a:r>
             <a:endParaRPr lang="en-US" sz="800" dirty="0"/>
           </a:p>

</xml_diff>

<commit_message>
action_plan.pptx v4.4 - add system/plan links, RACI web note, unify status to 진행 중
</commit_message>
<xml_diff>
--- a/action_plan.pptx
+++ b/action_plan.pptx
@@ -1131,7 +1131,7 @@
           <a:p>
             <a:r>
               <a:rPr lang="en-US" dirty="0"/>
-              <a:t>R&amp;R은 매핑표 등록 → RACI 매트릭스 작성 → 전자서명 확인의 3단계로 진행합니다.</a:t>
+              <a:t>R&amp;R은 매핑표 등록 → RACI 매트릭스 작성 → 전자서명 확인의 3단계로 진행합니다. RACI 매트릭스 작성은 웹버전 실행계획서에서 직접 수행합니다.</a:t>
             </a:r>
             <a:endParaRPr lang="en-US" dirty="0"/>
           </a:p>
@@ -2367,7 +2367,7 @@
                 <a:ea typeface="Calibri" pitchFamily="34" charset="-122"/>
                 <a:cs typeface="Calibri" pitchFamily="34" charset="-120"/>
               </a:rPr>
-              <a:t>2026. 08. 05   |   v4.1</a:t>
+              <a:t>2026. 08. 05   |   v4.4</a:t>
             </a:r>
             <a:endParaRPr lang="en-US" sz="1050" dirty="0"/>
           </a:p>
@@ -2844,7 +2844,7 @@
                 <a:ea typeface="Calibri" pitchFamily="34" charset="-122"/>
                 <a:cs typeface="Calibri" pitchFamily="34" charset="-120"/>
               </a:rPr>
-              <a:t>의뢰·완료일 · 소요시간</a:t>
+              <a:t>의뢰 등록 · 결과 연동</a:t>
             </a:r>
             <a:endParaRPr lang="en-US" sz="830" dirty="0"/>
           </a:p>
@@ -2969,7 +2969,7 @@
                 <a:ea typeface="Calibri" pitchFamily="34" charset="-122"/>
                 <a:cs typeface="Calibri" pitchFamily="34" charset="-120"/>
               </a:rPr>
-              <a:t>STEP 1~3 순차 진행</a:t>
+              <a:t>품목 선택 · 외관/치수/판정</a:t>
             </a:r>
             <a:endParaRPr lang="en-US" sz="830" dirty="0"/>
           </a:p>
@@ -3718,8 +3718,8 @@
         </p:nvSpPr>
         <p:spPr>
           <a:xfrm>
-            <a:off x="457200" y="3383280"/>
-            <a:ext cx="8229600" cy="365760"/>
+            <a:off x="457200" y="3346704"/>
+            <a:ext cx="8229600" cy="347472"/>
           </a:xfrm>
           <a:prstGeom prst="rect">
             <a:avLst/>
@@ -3738,8 +3738,8 @@
         </p:nvSpPr>
         <p:spPr>
           <a:xfrm>
-            <a:off x="457200" y="3383280"/>
-            <a:ext cx="1554480" cy="365760"/>
+            <a:off x="457200" y="3346704"/>
+            <a:ext cx="1554480" cy="347472"/>
           </a:xfrm>
           <a:prstGeom prst="rect">
             <a:avLst/>
@@ -3777,8 +3777,8 @@
         </p:nvSpPr>
         <p:spPr>
           <a:xfrm>
-            <a:off x="2011680" y="3383280"/>
-            <a:ext cx="3383280" cy="365760"/>
+            <a:off x="2011680" y="3346704"/>
+            <a:ext cx="3383280" cy="347472"/>
           </a:xfrm>
           <a:prstGeom prst="rect">
             <a:avLst/>
@@ -3802,7 +3802,7 @@
                 <a:ea typeface="Calibri" pitchFamily="34" charset="-122"/>
                 <a:cs typeface="Calibri" pitchFamily="34" charset="-120"/>
               </a:rPr>
-              <a:t>당일 검사 건수 · 평균 소요시간 · 합격률</a:t>
+              <a:t>당일 검사 건수 · 합격률 · 판정 현황</a:t>
             </a:r>
             <a:endParaRPr lang="en-US" sz="900" dirty="0"/>
           </a:p>
@@ -3816,8 +3816,8 @@
         </p:nvSpPr>
         <p:spPr>
           <a:xfrm>
-            <a:off x="5394960" y="3383280"/>
-            <a:ext cx="1554480" cy="365760"/>
+            <a:off x="5394960" y="3346704"/>
+            <a:ext cx="1554480" cy="347472"/>
           </a:xfrm>
           <a:prstGeom prst="rect">
             <a:avLst/>
@@ -3855,8 +3855,8 @@
         </p:nvSpPr>
         <p:spPr>
           <a:xfrm>
-            <a:off x="6949440" y="3383280"/>
-            <a:ext cx="1737360" cy="365760"/>
+            <a:off x="6949440" y="3346704"/>
+            <a:ext cx="1737360" cy="347472"/>
           </a:xfrm>
           <a:prstGeom prst="rect">
             <a:avLst/>
@@ -3894,8 +3894,8 @@
         </p:nvSpPr>
         <p:spPr>
           <a:xfrm>
-            <a:off x="457200" y="3749040"/>
-            <a:ext cx="1554480" cy="365760"/>
+            <a:off x="457200" y="3694176"/>
+            <a:ext cx="1554480" cy="347472"/>
           </a:xfrm>
           <a:prstGeom prst="rect">
             <a:avLst/>
@@ -3933,8 +3933,8 @@
         </p:nvSpPr>
         <p:spPr>
           <a:xfrm>
-            <a:off x="2011680" y="3749040"/>
-            <a:ext cx="3383280" cy="365760"/>
+            <a:off x="2011680" y="3694176"/>
+            <a:ext cx="3383280" cy="347472"/>
           </a:xfrm>
           <a:prstGeom prst="rect">
             <a:avLst/>
@@ -3972,8 +3972,8 @@
         </p:nvSpPr>
         <p:spPr>
           <a:xfrm>
-            <a:off x="5394960" y="3749040"/>
-            <a:ext cx="1554480" cy="365760"/>
+            <a:off x="5394960" y="3694176"/>
+            <a:ext cx="1554480" cy="347472"/>
           </a:xfrm>
           <a:prstGeom prst="rect">
             <a:avLst/>
@@ -4011,8 +4011,8 @@
         </p:nvSpPr>
         <p:spPr>
           <a:xfrm>
-            <a:off x="6949440" y="3749040"/>
-            <a:ext cx="1737360" cy="365760"/>
+            <a:off x="6949440" y="3694176"/>
+            <a:ext cx="1737360" cy="347472"/>
           </a:xfrm>
           <a:prstGeom prst="rect">
             <a:avLst/>
@@ -4050,8 +4050,8 @@
         </p:nvSpPr>
         <p:spPr>
           <a:xfrm>
-            <a:off x="457200" y="4114800"/>
-            <a:ext cx="8229600" cy="365760"/>
+            <a:off x="457200" y="4041648"/>
+            <a:ext cx="8229600" cy="347472"/>
           </a:xfrm>
           <a:prstGeom prst="rect">
             <a:avLst/>
@@ -4070,8 +4070,8 @@
         </p:nvSpPr>
         <p:spPr>
           <a:xfrm>
-            <a:off x="457200" y="4114800"/>
-            <a:ext cx="1554480" cy="365760"/>
+            <a:off x="457200" y="4041648"/>
+            <a:ext cx="1554480" cy="347472"/>
           </a:xfrm>
           <a:prstGeom prst="rect">
             <a:avLst/>
@@ -4109,8 +4109,8 @@
         </p:nvSpPr>
         <p:spPr>
           <a:xfrm>
-            <a:off x="2011680" y="4114800"/>
-            <a:ext cx="3383280" cy="365760"/>
+            <a:off x="2011680" y="4041648"/>
+            <a:ext cx="3383280" cy="347472"/>
           </a:xfrm>
           <a:prstGeom prst="rect">
             <a:avLst/>
@@ -4148,8 +4148,8 @@
         </p:nvSpPr>
         <p:spPr>
           <a:xfrm>
-            <a:off x="5394960" y="4114800"/>
-            <a:ext cx="1554480" cy="365760"/>
+            <a:off x="5394960" y="4041648"/>
+            <a:ext cx="1554480" cy="347472"/>
           </a:xfrm>
           <a:prstGeom prst="rect">
             <a:avLst/>
@@ -4187,8 +4187,8 @@
         </p:nvSpPr>
         <p:spPr>
           <a:xfrm>
-            <a:off x="6949440" y="4114800"/>
-            <a:ext cx="1737360" cy="365760"/>
+            <a:off x="6949440" y="4041648"/>
+            <a:ext cx="1737360" cy="347472"/>
           </a:xfrm>
           <a:prstGeom prst="rect">
             <a:avLst/>
@@ -4221,6 +4221,179 @@
       <p:sp>
         <p:nvSpPr>
           <p:cNvPr id="58" name="Shape 56"/>
+          <p:cNvSpPr/>
+          <p:nvPr/>
+        </p:nvSpPr>
+        <p:spPr>
+          <a:xfrm>
+            <a:off x="457200" y="4279392"/>
+            <a:ext cx="8229600" cy="329184"/>
+          </a:xfrm>
+          <a:prstGeom prst="roundRect">
+            <a:avLst>
+              <a:gd name="adj" fmla="val 13889"/>
+            </a:avLst>
+          </a:prstGeom>
+          <a:solidFill>
+            <a:srgbClr val="FAFBFC"/>
+          </a:solidFill>
+          <a:ln w="12700">
+            <a:solidFill>
+              <a:srgbClr val="1C7293"/>
+            </a:solidFill>
+            <a:prstDash val="solid"/>
+          </a:ln>
+        </p:spPr>
+      </p:sp>
+      <p:sp>
+        <p:nvSpPr>
+          <p:cNvPr id="59" name="Shape 57"/>
+          <p:cNvSpPr/>
+          <p:nvPr/>
+        </p:nvSpPr>
+        <p:spPr>
+          <a:xfrm>
+            <a:off x="457200" y="4279392"/>
+            <a:ext cx="45720" cy="329184"/>
+          </a:xfrm>
+          <a:prstGeom prst="rect">
+            <a:avLst/>
+          </a:prstGeom>
+          <a:solidFill>
+            <a:srgbClr val="1C7293"/>
+          </a:solidFill>
+          <a:ln/>
+        </p:spPr>
+      </p:sp>
+      <p:sp>
+        <p:nvSpPr>
+          <p:cNvPr id="60" name="Text 58"/>
+          <p:cNvSpPr/>
+          <p:nvPr/>
+        </p:nvSpPr>
+        <p:spPr>
+          <a:xfrm>
+            <a:off x="603504" y="4279392"/>
+            <a:ext cx="310896" cy="329184"/>
+          </a:xfrm>
+          <a:prstGeom prst="rect">
+            <a:avLst/>
+          </a:prstGeom>
+          <a:noFill/>
+          <a:ln/>
+        </p:spPr>
+        <p:txBody>
+          <a:bodyPr wrap="square" lIns="0" tIns="0" rIns="0" bIns="0" rtlCol="0" anchor="ctr"/>
+          <a:lstStyle/>
+          <a:p>
+            <a:pPr algn="ctr" indent="0" marL="0">
+              <a:buNone/>
+            </a:pPr>
+            <a:r>
+              <a:rPr lang="en-US" sz="1200" dirty="0">
+                <a:solidFill>
+                  <a:srgbClr val="000000"/>
+                </a:solidFill>
+                <a:latin typeface="Calibri" pitchFamily="34" charset="0"/>
+                <a:ea typeface="Calibri" pitchFamily="34" charset="-122"/>
+                <a:cs typeface="Calibri" pitchFamily="34" charset="-120"/>
+              </a:rPr>
+              <a:t>🔗</a:t>
+            </a:r>
+            <a:endParaRPr lang="en-US" sz="1200" dirty="0"/>
+          </a:p>
+        </p:txBody>
+      </p:sp>
+      <p:sp>
+        <p:nvSpPr>
+          <p:cNvPr id="61" name="Text 59"/>
+          <p:cNvSpPr/>
+          <p:nvPr/>
+        </p:nvSpPr>
+        <p:spPr>
+          <a:xfrm>
+            <a:off x="932688" y="4279392"/>
+            <a:ext cx="3200400" cy="329184"/>
+          </a:xfrm>
+          <a:prstGeom prst="rect">
+            <a:avLst/>
+          </a:prstGeom>
+          <a:noFill/>
+          <a:ln/>
+        </p:spPr>
+        <p:txBody>
+          <a:bodyPr wrap="square" lIns="0" tIns="0" rIns="0" bIns="0" rtlCol="0" anchor="ctr"/>
+          <a:lstStyle/>
+          <a:p>
+            <a:pPr indent="0" marL="0">
+              <a:buNone/>
+            </a:pPr>
+            <a:r>
+              <a:rPr lang="en-US" sz="1000" b="1" dirty="0">
+                <a:solidFill>
+                  <a:srgbClr val="1C7293"/>
+                </a:solidFill>
+                <a:latin typeface="Calibri" pitchFamily="34" charset="0"/>
+                <a:ea typeface="Calibri" pitchFamily="34" charset="-122"/>
+                <a:cs typeface="Calibri" pitchFamily="34" charset="-120"/>
+              </a:rPr>
+              <a:t>업무관리 시스템 — 실시간 현황 조회</a:t>
+            </a:r>
+            <a:endParaRPr lang="en-US" sz="1000" dirty="0"/>
+          </a:p>
+        </p:txBody>
+      </p:sp>
+      <p:sp>
+        <p:nvSpPr>
+          <p:cNvPr id="62" name="Text 60">
+            <a:hlinkClick r:id="rId1" tooltip=""/>
+          </p:cNvPr>
+          <p:cNvSpPr/>
+          <p:nvPr/>
+        </p:nvSpPr>
+        <p:spPr>
+          <a:xfrm>
+            <a:off x="4169664" y="4279392"/>
+            <a:ext cx="4389120" cy="329184"/>
+          </a:xfrm>
+          <a:prstGeom prst="rect">
+            <a:avLst/>
+          </a:prstGeom>
+          <a:noFill/>
+          <a:ln/>
+        </p:spPr>
+        <p:txBody>
+          <a:bodyPr wrap="square" lIns="0" tIns="0" rIns="0" bIns="0" rtlCol="0" anchor="ctr"/>
+          <a:lstStyle/>
+          <a:p>
+            <a:pPr indent="0" marL="0">
+              <a:buNone/>
+            </a:pPr>
+            <a:r>
+              <a:rPr lang="en-US" sz="950" u="sng" dirty="0">
+                <a:solidFill>
+                  <a:srgbClr val="5A6B7C"/>
+                </a:solidFill>
+                <a:latin typeface="Calibri" pitchFamily="34" charset="0"/>
+                <a:ea typeface="Calibri" pitchFamily="34" charset="-122"/>
+                <a:cs typeface="Calibri" pitchFamily="34" charset="-120"/>
+                <a:hlinkClick r:id="rId1" invalidUrl="" action="" tgtFrame="" tooltip="" history="1" highlightClick="0" endSnd="0">
+                  <a:extLst>
+                    <a:ext uri="{A12FA001-AC4F-418D-AE19-62706E023703}">
+                      <ahyp:hlinkClr xmlns:ahyp="http://schemas.microsoft.com/office/drawing/2018/hyperlinkcolor" val="tx"/>
+                    </a:ext>
+                  </a:extLst>
+                </a:hlinkClick>
+              </a:rPr>
+              <a:t>https://insys-hq.github.io/Insys-review/ims.html</a:t>
+            </a:r>
+            <a:endParaRPr lang="en-US" sz="950" dirty="0"/>
+          </a:p>
+        </p:txBody>
+      </p:sp>
+      <p:sp>
+        <p:nvSpPr>
+          <p:cNvPr id="63" name="Shape 61"/>
           <p:cNvSpPr/>
           <p:nvPr/>
         </p:nvSpPr>
@@ -4240,7 +4413,7 @@
       </p:sp>
       <p:sp>
         <p:nvSpPr>
-          <p:cNvPr id="59" name="Text 57"/>
+          <p:cNvPr id="64" name="Text 62"/>
           <p:cNvSpPr/>
           <p:nvPr/>
         </p:nvSpPr>
@@ -4271,7 +4444,7 @@
                 <a:ea typeface="Calibri" pitchFamily="34" charset="-122"/>
                 <a:cs typeface="Calibri" pitchFamily="34" charset="-120"/>
               </a:rPr>
-              <a:t>㈜인시스  ·  셰플러 이천공장 수입검사 실행계획서 v4.1</a:t>
+              <a:t>㈜인시스  ·  셰플러 이천공장 수입검사 실행계획서 v4.4</a:t>
             </a:r>
             <a:endParaRPr lang="en-US" sz="800" dirty="0"/>
           </a:p>
@@ -4279,7 +4452,7 @@
       </p:sp>
       <p:sp>
         <p:nvSpPr>
-          <p:cNvPr id="60" name="Text 58"/>
+          <p:cNvPr id="65" name="Text 63"/>
           <p:cNvSpPr/>
           <p:nvPr/>
         </p:nvSpPr>
@@ -4498,7 +4671,7 @@
                 <a:ea typeface="Cambria" pitchFamily="34" charset="-122"/>
                 <a:cs typeface="Cambria" pitchFamily="34" charset="-120"/>
               </a:rPr>
-              <a:t>접근 권한 및 공유 체계</a:t>
+              <a:t>계정 · 접근 권한 체계</a:t>
             </a:r>
             <a:endParaRPr lang="en-US" sz="2200" dirty="0"/>
           </a:p>
@@ -4537,7 +4710,7 @@
                 <a:ea typeface="Calibri" pitchFamily="34" charset="-122"/>
                 <a:cs typeface="Calibri" pitchFamily="34" charset="-120"/>
               </a:rPr>
-              <a:t>작성 · 승인 · 열람 권한 구분</a:t>
+              <a:t>소속별 권한 구분 — ㈜인시스 전체 권한 / 셰플러 부분 권한</a:t>
             </a:r>
             <a:endParaRPr lang="en-US" sz="1050" dirty="0"/>
           </a:p>
@@ -4551,12 +4724,12 @@
         </p:nvSpPr>
         <p:spPr>
           <a:xfrm>
-            <a:off x="457200" y="1133856"/>
-            <a:ext cx="8229600" cy="621792"/>
+            <a:off x="457200" y="1097280"/>
+            <a:ext cx="8229600" cy="548640"/>
           </a:xfrm>
           <a:prstGeom prst="roundRect">
             <a:avLst>
-              <a:gd name="adj" fmla="val 5882"/>
+              <a:gd name="adj" fmla="val 6667"/>
             </a:avLst>
           </a:prstGeom>
           <a:solidFill>
@@ -4578,7 +4751,7 @@
         </p:nvSpPr>
         <p:spPr>
           <a:xfrm>
-            <a:off x="658368" y="1298448"/>
+            <a:off x="658368" y="1225296"/>
             <a:ext cx="658368" cy="292608"/>
           </a:xfrm>
           <a:prstGeom prst="roundRect">
@@ -4600,7 +4773,7 @@
         </p:nvSpPr>
         <p:spPr>
           <a:xfrm>
-            <a:off x="658368" y="1298448"/>
+            <a:off x="658368" y="1225296"/>
             <a:ext cx="658368" cy="292608"/>
           </a:xfrm>
           <a:prstGeom prst="rect">
@@ -4639,7 +4812,7 @@
         </p:nvSpPr>
         <p:spPr>
           <a:xfrm>
-            <a:off x="1481328" y="1225296"/>
+            <a:off x="1481328" y="1170432"/>
             <a:ext cx="3108960" cy="237744"/>
           </a:xfrm>
           <a:prstGeom prst="rect">
@@ -4664,7 +4837,7 @@
                 <a:ea typeface="Calibri" pitchFamily="34" charset="-122"/>
                 <a:cs typeface="Calibri" pitchFamily="34" charset="-120"/>
               </a:rPr>
-              <a:t>인시스 검사원 (김종선 · 이석봉)</a:t>
+              <a:t>㈜인시스 계정</a:t>
             </a:r>
             <a:endParaRPr lang="en-US" sz="1100" dirty="0"/>
           </a:p>
@@ -4678,7 +4851,7 @@
         </p:nvSpPr>
         <p:spPr>
           <a:xfrm>
-            <a:off x="1481328" y="1463040"/>
+            <a:off x="1481328" y="1399032"/>
             <a:ext cx="6949440" cy="219456"/>
           </a:xfrm>
           <a:prstGeom prst="rect">
@@ -4703,7 +4876,7 @@
                 <a:ea typeface="Calibri" pitchFamily="34" charset="-122"/>
                 <a:cs typeface="Calibri" pitchFamily="34" charset="-120"/>
               </a:rPr>
-              <a:t>검사·측정의뢰·부적합·업무일지 입력 및 수정</a:t>
+              <a:t>전 메뉴 등록·수정·삭제 (품목·측정의뢰·수입검사·부적합·보고서 등)</a:t>
             </a:r>
             <a:endParaRPr lang="en-US" sz="930" dirty="0"/>
           </a:p>
@@ -4717,12 +4890,12 @@
         </p:nvSpPr>
         <p:spPr>
           <a:xfrm>
-            <a:off x="457200" y="1847088"/>
-            <a:ext cx="8229600" cy="621792"/>
+            <a:off x="457200" y="1737360"/>
+            <a:ext cx="8229600" cy="548640"/>
           </a:xfrm>
           <a:prstGeom prst="roundRect">
             <a:avLst>
-              <a:gd name="adj" fmla="val 5882"/>
+              <a:gd name="adj" fmla="val 6667"/>
             </a:avLst>
           </a:prstGeom>
           <a:solidFill>
@@ -4744,7 +4917,7 @@
         </p:nvSpPr>
         <p:spPr>
           <a:xfrm>
-            <a:off x="658368" y="2011680"/>
+            <a:off x="658368" y="1865376"/>
             <a:ext cx="658368" cy="292608"/>
           </a:xfrm>
           <a:prstGeom prst="roundRect">
@@ -4766,7 +4939,7 @@
         </p:nvSpPr>
         <p:spPr>
           <a:xfrm>
-            <a:off x="658368" y="2011680"/>
+            <a:off x="658368" y="1865376"/>
             <a:ext cx="658368" cy="292608"/>
           </a:xfrm>
           <a:prstGeom prst="rect">
@@ -4805,7 +4978,7 @@
         </p:nvSpPr>
         <p:spPr>
           <a:xfrm>
-            <a:off x="1481328" y="1938528"/>
+            <a:off x="1481328" y="1810512"/>
             <a:ext cx="3108960" cy="237744"/>
           </a:xfrm>
           <a:prstGeom prst="rect">
@@ -4844,7 +5017,7 @@
         </p:nvSpPr>
         <p:spPr>
           <a:xfrm>
-            <a:off x="1481328" y="2176272"/>
+            <a:off x="1481328" y="2039112"/>
             <a:ext cx="6949440" cy="219456"/>
           </a:xfrm>
           <a:prstGeom prst="rect">
@@ -4869,7 +5042,7 @@
                 <a:ea typeface="Calibri" pitchFamily="34" charset="-122"/>
                 <a:cs typeface="Calibri" pitchFamily="34" charset="-120"/>
               </a:rPr>
-              <a:t>업무일지·보고서 확인 및 승인</a:t>
+              <a:t>일일 업무보고 확인 및 승인</a:t>
             </a:r>
             <a:endParaRPr lang="en-US" sz="930" dirty="0"/>
           </a:p>
@@ -4883,12 +5056,12 @@
         </p:nvSpPr>
         <p:spPr>
           <a:xfrm>
-            <a:off x="457200" y="2560320"/>
-            <a:ext cx="8229600" cy="621792"/>
+            <a:off x="457200" y="2377440"/>
+            <a:ext cx="8229600" cy="548640"/>
           </a:xfrm>
           <a:prstGeom prst="roundRect">
             <a:avLst>
-              <a:gd name="adj" fmla="val 5882"/>
+              <a:gd name="adj" fmla="val 6667"/>
             </a:avLst>
           </a:prstGeom>
           <a:solidFill>
@@ -4910,7 +5083,7 @@
         </p:nvSpPr>
         <p:spPr>
           <a:xfrm>
-            <a:off x="658368" y="2724912"/>
+            <a:off x="658368" y="2505456"/>
             <a:ext cx="658368" cy="292608"/>
           </a:xfrm>
           <a:prstGeom prst="roundRect">
@@ -4932,7 +5105,7 @@
         </p:nvSpPr>
         <p:spPr>
           <a:xfrm>
-            <a:off x="658368" y="2724912"/>
+            <a:off x="658368" y="2505456"/>
             <a:ext cx="658368" cy="292608"/>
           </a:xfrm>
           <a:prstGeom prst="rect">
@@ -4971,7 +5144,7 @@
         </p:nvSpPr>
         <p:spPr>
           <a:xfrm>
-            <a:off x="1481328" y="2651760"/>
+            <a:off x="1481328" y="2450592"/>
             <a:ext cx="3108960" cy="237744"/>
           </a:xfrm>
           <a:prstGeom prst="rect">
@@ -4996,7 +5169,7 @@
                 <a:ea typeface="Calibri" pitchFamily="34" charset="-122"/>
                 <a:cs typeface="Calibri" pitchFamily="34" charset="-120"/>
               </a:rPr>
-              <a:t>셰플러 SQM팀장 · 수입검사 관련자</a:t>
+              <a:t>셰플러 계정</a:t>
             </a:r>
             <a:endParaRPr lang="en-US" sz="1100" dirty="0"/>
           </a:p>
@@ -5010,7 +5183,7 @@
         </p:nvSpPr>
         <p:spPr>
           <a:xfrm>
-            <a:off x="1481328" y="2889504"/>
+            <a:off x="1481328" y="2679192"/>
             <a:ext cx="6949440" cy="219456"/>
           </a:xfrm>
           <a:prstGeom prst="rect">
@@ -5035,7 +5208,7 @@
                 <a:ea typeface="Calibri" pitchFamily="34" charset="-122"/>
                 <a:cs typeface="Calibri" pitchFamily="34" charset="-120"/>
               </a:rPr>
-              <a:t>업무 현황 및 보고서 조회</a:t>
+              <a:t>품목관리·측정의뢰 전체 권한 / 그 외 메뉴 열람만 가능</a:t>
             </a:r>
             <a:endParaRPr lang="en-US" sz="930" dirty="0"/>
           </a:p>
@@ -5049,12 +5222,12 @@
         </p:nvSpPr>
         <p:spPr>
           <a:xfrm>
-            <a:off x="457200" y="3273552"/>
-            <a:ext cx="8229600" cy="621792"/>
+            <a:off x="457200" y="3017520"/>
+            <a:ext cx="8229600" cy="548640"/>
           </a:xfrm>
           <a:prstGeom prst="roundRect">
             <a:avLst>
-              <a:gd name="adj" fmla="val 5882"/>
+              <a:gd name="adj" fmla="val 6667"/>
             </a:avLst>
           </a:prstGeom>
           <a:solidFill>
@@ -5076,7 +5249,7 @@
         </p:nvSpPr>
         <p:spPr>
           <a:xfrm>
-            <a:off x="658368" y="3438144"/>
+            <a:off x="658368" y="3145536"/>
             <a:ext cx="658368" cy="292608"/>
           </a:xfrm>
           <a:prstGeom prst="roundRect">
@@ -5085,7 +5258,7 @@
             </a:avLst>
           </a:prstGeom>
           <a:solidFill>
-            <a:srgbClr val="5A6B7C"/>
+            <a:srgbClr val="B8860B"/>
           </a:solidFill>
           <a:ln/>
         </p:spPr>
@@ -5098,7 +5271,7 @@
         </p:nvSpPr>
         <p:spPr>
           <a:xfrm>
-            <a:off x="658368" y="3438144"/>
+            <a:off x="658368" y="3145536"/>
             <a:ext cx="658368" cy="292608"/>
           </a:xfrm>
           <a:prstGeom prst="rect">
@@ -5123,7 +5296,7 @@
                 <a:ea typeface="Calibri" pitchFamily="34" charset="-122"/>
                 <a:cs typeface="Calibri" pitchFamily="34" charset="-120"/>
               </a:rPr>
-              <a:t>열람</a:t>
+              <a:t>가입</a:t>
             </a:r>
             <a:endParaRPr lang="en-US" sz="1000" dirty="0"/>
           </a:p>
@@ -5137,7 +5310,7 @@
         </p:nvSpPr>
         <p:spPr>
           <a:xfrm>
-            <a:off x="1481328" y="3364992"/>
+            <a:off x="1481328" y="3090672"/>
             <a:ext cx="3108960" cy="237744"/>
           </a:xfrm>
           <a:prstGeom prst="rect">
@@ -5162,7 +5335,7 @@
                 <a:ea typeface="Calibri" pitchFamily="34" charset="-122"/>
                 <a:cs typeface="Calibri" pitchFamily="34" charset="-120"/>
               </a:rPr>
-              <a:t>인시스 본사 관련 인원</a:t>
+              <a:t>이메일 계정 등록 요청</a:t>
             </a:r>
             <a:endParaRPr lang="en-US" sz="1100" dirty="0"/>
           </a:p>
@@ -5176,7 +5349,7 @@
         </p:nvSpPr>
         <p:spPr>
           <a:xfrm>
-            <a:off x="1481328" y="3602736"/>
+            <a:off x="1481328" y="3319272"/>
             <a:ext cx="6949440" cy="219456"/>
           </a:xfrm>
           <a:prstGeom prst="rect">
@@ -5201,7 +5374,7 @@
                 <a:ea typeface="Calibri" pitchFamily="34" charset="-122"/>
                 <a:cs typeface="Calibri" pitchFamily="34" charset="-120"/>
               </a:rPr>
-              <a:t>인력 운영 현황 조회</a:t>
+              <a:t>임시 비밀번호 메일 발송 → 로그인 후 소속 선택 및 비밀번호 변경</a:t>
             </a:r>
             <a:endParaRPr lang="en-US" sz="930" dirty="0"/>
           </a:p>
@@ -5215,12 +5388,12 @@
         </p:nvSpPr>
         <p:spPr>
           <a:xfrm>
-            <a:off x="457200" y="4041648"/>
-            <a:ext cx="8229600" cy="512064"/>
+            <a:off x="457200" y="3712464"/>
+            <a:ext cx="8229600" cy="475488"/>
           </a:xfrm>
           <a:prstGeom prst="roundRect">
             <a:avLst>
-              <a:gd name="adj" fmla="val 7143"/>
+              <a:gd name="adj" fmla="val 7692"/>
             </a:avLst>
           </a:prstGeom>
           <a:solidFill>
@@ -5242,7 +5415,7 @@
         </p:nvSpPr>
         <p:spPr>
           <a:xfrm>
-            <a:off x="658368" y="4114800"/>
+            <a:off x="658368" y="3758184"/>
             <a:ext cx="1645920" cy="219456"/>
           </a:xfrm>
           <a:prstGeom prst="rect">
@@ -5281,7 +5454,7 @@
         </p:nvSpPr>
         <p:spPr>
           <a:xfrm>
-            <a:off x="658368" y="4315968"/>
+            <a:off x="658368" y="3959352"/>
             <a:ext cx="7863840" cy="219456"/>
           </a:xfrm>
           <a:prstGeom prst="rect">
@@ -5315,6 +5488,179 @@
       <p:sp>
         <p:nvSpPr>
           <p:cNvPr id="32" name="Shape 30"/>
+          <p:cNvSpPr/>
+          <p:nvPr/>
+        </p:nvSpPr>
+        <p:spPr>
+          <a:xfrm>
+            <a:off x="457200" y="4297680"/>
+            <a:ext cx="8229600" cy="329184"/>
+          </a:xfrm>
+          <a:prstGeom prst="roundRect">
+            <a:avLst>
+              <a:gd name="adj" fmla="val 13889"/>
+            </a:avLst>
+          </a:prstGeom>
+          <a:solidFill>
+            <a:srgbClr val="FAFBFC"/>
+          </a:solidFill>
+          <a:ln w="12700">
+            <a:solidFill>
+              <a:srgbClr val="1C7293"/>
+            </a:solidFill>
+            <a:prstDash val="solid"/>
+          </a:ln>
+        </p:spPr>
+      </p:sp>
+      <p:sp>
+        <p:nvSpPr>
+          <p:cNvPr id="33" name="Shape 31"/>
+          <p:cNvSpPr/>
+          <p:nvPr/>
+        </p:nvSpPr>
+        <p:spPr>
+          <a:xfrm>
+            <a:off x="457200" y="4297680"/>
+            <a:ext cx="45720" cy="329184"/>
+          </a:xfrm>
+          <a:prstGeom prst="rect">
+            <a:avLst/>
+          </a:prstGeom>
+          <a:solidFill>
+            <a:srgbClr val="1C7293"/>
+          </a:solidFill>
+          <a:ln/>
+        </p:spPr>
+      </p:sp>
+      <p:sp>
+        <p:nvSpPr>
+          <p:cNvPr id="34" name="Text 32"/>
+          <p:cNvSpPr/>
+          <p:nvPr/>
+        </p:nvSpPr>
+        <p:spPr>
+          <a:xfrm>
+            <a:off x="603504" y="4297680"/>
+            <a:ext cx="310896" cy="329184"/>
+          </a:xfrm>
+          <a:prstGeom prst="rect">
+            <a:avLst/>
+          </a:prstGeom>
+          <a:noFill/>
+          <a:ln/>
+        </p:spPr>
+        <p:txBody>
+          <a:bodyPr wrap="square" lIns="0" tIns="0" rIns="0" bIns="0" rtlCol="0" anchor="ctr"/>
+          <a:lstStyle/>
+          <a:p>
+            <a:pPr algn="ctr" indent="0" marL="0">
+              <a:buNone/>
+            </a:pPr>
+            <a:r>
+              <a:rPr lang="en-US" sz="1200" dirty="0">
+                <a:solidFill>
+                  <a:srgbClr val="000000"/>
+                </a:solidFill>
+                <a:latin typeface="Calibri" pitchFamily="34" charset="0"/>
+                <a:ea typeface="Calibri" pitchFamily="34" charset="-122"/>
+                <a:cs typeface="Calibri" pitchFamily="34" charset="-120"/>
+              </a:rPr>
+              <a:t>🔗</a:t>
+            </a:r>
+            <a:endParaRPr lang="en-US" sz="1200" dirty="0"/>
+          </a:p>
+        </p:txBody>
+      </p:sp>
+      <p:sp>
+        <p:nvSpPr>
+          <p:cNvPr id="35" name="Text 33"/>
+          <p:cNvSpPr/>
+          <p:nvPr/>
+        </p:nvSpPr>
+        <p:spPr>
+          <a:xfrm>
+            <a:off x="932688" y="4297680"/>
+            <a:ext cx="3200400" cy="329184"/>
+          </a:xfrm>
+          <a:prstGeom prst="rect">
+            <a:avLst/>
+          </a:prstGeom>
+          <a:noFill/>
+          <a:ln/>
+        </p:spPr>
+        <p:txBody>
+          <a:bodyPr wrap="square" lIns="0" tIns="0" rIns="0" bIns="0" rtlCol="0" anchor="ctr"/>
+          <a:lstStyle/>
+          <a:p>
+            <a:pPr indent="0" marL="0">
+              <a:buNone/>
+            </a:pPr>
+            <a:r>
+              <a:rPr lang="en-US" sz="1000" b="1" dirty="0">
+                <a:solidFill>
+                  <a:srgbClr val="1C7293"/>
+                </a:solidFill>
+                <a:latin typeface="Calibri" pitchFamily="34" charset="0"/>
+                <a:ea typeface="Calibri" pitchFamily="34" charset="-122"/>
+                <a:cs typeface="Calibri" pitchFamily="34" charset="-120"/>
+              </a:rPr>
+              <a:t>업무관리 시스템 접속</a:t>
+            </a:r>
+            <a:endParaRPr lang="en-US" sz="1000" dirty="0"/>
+          </a:p>
+        </p:txBody>
+      </p:sp>
+      <p:sp>
+        <p:nvSpPr>
+          <p:cNvPr id="36" name="Text 34">
+            <a:hlinkClick r:id="rId1" tooltip=""/>
+          </p:cNvPr>
+          <p:cNvSpPr/>
+          <p:nvPr/>
+        </p:nvSpPr>
+        <p:spPr>
+          <a:xfrm>
+            <a:off x="4169664" y="4297680"/>
+            <a:ext cx="4389120" cy="329184"/>
+          </a:xfrm>
+          <a:prstGeom prst="rect">
+            <a:avLst/>
+          </a:prstGeom>
+          <a:noFill/>
+          <a:ln/>
+        </p:spPr>
+        <p:txBody>
+          <a:bodyPr wrap="square" lIns="0" tIns="0" rIns="0" bIns="0" rtlCol="0" anchor="ctr"/>
+          <a:lstStyle/>
+          <a:p>
+            <a:pPr indent="0" marL="0">
+              <a:buNone/>
+            </a:pPr>
+            <a:r>
+              <a:rPr lang="en-US" sz="950" u="sng" dirty="0">
+                <a:solidFill>
+                  <a:srgbClr val="5A6B7C"/>
+                </a:solidFill>
+                <a:latin typeface="Calibri" pitchFamily="34" charset="0"/>
+                <a:ea typeface="Calibri" pitchFamily="34" charset="-122"/>
+                <a:cs typeface="Calibri" pitchFamily="34" charset="-120"/>
+                <a:hlinkClick r:id="rId1" invalidUrl="" action="" tgtFrame="" tooltip="" history="1" highlightClick="0" endSnd="0">
+                  <a:extLst>
+                    <a:ext uri="{A12FA001-AC4F-418D-AE19-62706E023703}">
+                      <ahyp:hlinkClr xmlns:ahyp="http://schemas.microsoft.com/office/drawing/2018/hyperlinkcolor" val="tx"/>
+                    </a:ext>
+                  </a:extLst>
+                </a:hlinkClick>
+              </a:rPr>
+              <a:t>https://insys-hq.github.io/Insys-review/ims.html</a:t>
+            </a:r>
+            <a:endParaRPr lang="en-US" sz="950" dirty="0"/>
+          </a:p>
+        </p:txBody>
+      </p:sp>
+      <p:sp>
+        <p:nvSpPr>
+          <p:cNvPr id="37" name="Shape 35"/>
           <p:cNvSpPr/>
           <p:nvPr/>
         </p:nvSpPr>
@@ -5334,7 +5680,7 @@
       </p:sp>
       <p:sp>
         <p:nvSpPr>
-          <p:cNvPr id="33" name="Text 31"/>
+          <p:cNvPr id="38" name="Text 36"/>
           <p:cNvSpPr/>
           <p:nvPr/>
         </p:nvSpPr>
@@ -5365,7 +5711,7 @@
                 <a:ea typeface="Calibri" pitchFamily="34" charset="-122"/>
                 <a:cs typeface="Calibri" pitchFamily="34" charset="-120"/>
               </a:rPr>
-              <a:t>㈜인시스  ·  셰플러 이천공장 수입검사 실행계획서 v4.1</a:t>
+              <a:t>㈜인시스  ·  셰플러 이천공장 수입검사 실행계획서 v4.4</a:t>
             </a:r>
             <a:endParaRPr lang="en-US" sz="800" dirty="0"/>
           </a:p>
@@ -5373,7 +5719,7 @@
       </p:sp>
       <p:sp>
         <p:nvSpPr>
-          <p:cNvPr id="34" name="Text 32"/>
+          <p:cNvPr id="39" name="Text 37"/>
           <p:cNvSpPr/>
           <p:nvPr/>
         </p:nvSpPr>
@@ -6849,7 +7195,7 @@
                 <a:ea typeface="Calibri" pitchFamily="34" charset="-122"/>
                 <a:cs typeface="Calibri" pitchFamily="34" charset="-120"/>
               </a:rPr>
-              <a:t>㈜인시스  ·  셰플러 이천공장 수입검사 실행계획서 v4.1</a:t>
+              <a:t>㈜인시스  ·  셰플러 이천공장 수입검사 실행계획서 v4.4</a:t>
             </a:r>
             <a:endParaRPr lang="en-US" sz="800" dirty="0"/>
           </a:p>
@@ -7299,8 +7645,8 @@
         </p:nvSpPr>
         <p:spPr>
           <a:xfrm>
-            <a:off x="457200" y="1499616"/>
-            <a:ext cx="8229600" cy="393192"/>
+            <a:off x="457200" y="1481328"/>
+            <a:ext cx="8229600" cy="347472"/>
           </a:xfrm>
           <a:prstGeom prst="rect">
             <a:avLst/>
@@ -7319,8 +7665,8 @@
         </p:nvSpPr>
         <p:spPr>
           <a:xfrm>
-            <a:off x="457200" y="1499616"/>
-            <a:ext cx="475488" cy="393192"/>
+            <a:off x="457200" y="1481328"/>
+            <a:ext cx="475488" cy="347472"/>
           </a:xfrm>
           <a:prstGeom prst="rect">
             <a:avLst/>
@@ -7358,8 +7704,8 @@
         </p:nvSpPr>
         <p:spPr>
           <a:xfrm>
-            <a:off x="987552" y="1499616"/>
-            <a:ext cx="2523744" cy="393192"/>
+            <a:off x="987552" y="1481328"/>
+            <a:ext cx="2523744" cy="347472"/>
           </a:xfrm>
           <a:prstGeom prst="rect">
             <a:avLst/>
@@ -7397,8 +7743,8 @@
         </p:nvSpPr>
         <p:spPr>
           <a:xfrm>
-            <a:off x="3566160" y="1499616"/>
-            <a:ext cx="2011680" cy="393192"/>
+            <a:off x="3566160" y="1481328"/>
+            <a:ext cx="2011680" cy="347472"/>
           </a:xfrm>
           <a:prstGeom prst="rect">
             <a:avLst/>
@@ -7436,8 +7782,8 @@
         </p:nvSpPr>
         <p:spPr>
           <a:xfrm>
-            <a:off x="5632704" y="1499616"/>
-            <a:ext cx="1207008" cy="393192"/>
+            <a:off x="5632704" y="1481328"/>
+            <a:ext cx="1207008" cy="347472"/>
           </a:xfrm>
           <a:prstGeom prst="rect">
             <a:avLst/>
@@ -7475,8 +7821,8 @@
         </p:nvSpPr>
         <p:spPr>
           <a:xfrm>
-            <a:off x="6876288" y="1499616"/>
-            <a:ext cx="749808" cy="393192"/>
+            <a:off x="6876288" y="1481328"/>
+            <a:ext cx="749808" cy="347472"/>
           </a:xfrm>
           <a:prstGeom prst="rect">
             <a:avLst/>
@@ -7514,7 +7860,7 @@
         </p:nvSpPr>
         <p:spPr>
           <a:xfrm>
-            <a:off x="7735824" y="1568196"/>
+            <a:off x="7735824" y="1527048"/>
             <a:ext cx="859536" cy="256032"/>
           </a:xfrm>
           <a:prstGeom prst="roundRect">
@@ -7541,7 +7887,7 @@
         </p:nvSpPr>
         <p:spPr>
           <a:xfrm>
-            <a:off x="7735824" y="1568196"/>
+            <a:off x="7735824" y="1527048"/>
             <a:ext cx="859536" cy="256032"/>
           </a:xfrm>
           <a:prstGeom prst="rect">
@@ -7580,8 +7926,8 @@
         </p:nvSpPr>
         <p:spPr>
           <a:xfrm>
-            <a:off x="457200" y="1892808"/>
-            <a:ext cx="475488" cy="393192"/>
+            <a:off x="457200" y="1828800"/>
+            <a:ext cx="475488" cy="347472"/>
           </a:xfrm>
           <a:prstGeom prst="rect">
             <a:avLst/>
@@ -7619,8 +7965,8 @@
         </p:nvSpPr>
         <p:spPr>
           <a:xfrm>
-            <a:off x="987552" y="1892808"/>
-            <a:ext cx="2523744" cy="393192"/>
+            <a:off x="987552" y="1828800"/>
+            <a:ext cx="2523744" cy="347472"/>
           </a:xfrm>
           <a:prstGeom prst="rect">
             <a:avLst/>
@@ -7658,8 +8004,8 @@
         </p:nvSpPr>
         <p:spPr>
           <a:xfrm>
-            <a:off x="3566160" y="1892808"/>
-            <a:ext cx="2011680" cy="393192"/>
+            <a:off x="3566160" y="1828800"/>
+            <a:ext cx="2011680" cy="347472"/>
           </a:xfrm>
           <a:prstGeom prst="rect">
             <a:avLst/>
@@ -7697,8 +8043,8 @@
         </p:nvSpPr>
         <p:spPr>
           <a:xfrm>
-            <a:off x="5632704" y="1892808"/>
-            <a:ext cx="1207008" cy="393192"/>
+            <a:off x="5632704" y="1828800"/>
+            <a:ext cx="1207008" cy="347472"/>
           </a:xfrm>
           <a:prstGeom prst="rect">
             <a:avLst/>
@@ -7736,8 +8082,8 @@
         </p:nvSpPr>
         <p:spPr>
           <a:xfrm>
-            <a:off x="6876288" y="1892808"/>
-            <a:ext cx="749808" cy="393192"/>
+            <a:off x="6876288" y="1828800"/>
+            <a:ext cx="749808" cy="347472"/>
           </a:xfrm>
           <a:prstGeom prst="rect">
             <a:avLst/>
@@ -7775,7 +8121,7 @@
         </p:nvSpPr>
         <p:spPr>
           <a:xfrm>
-            <a:off x="7735824" y="1961388"/>
+            <a:off x="7735824" y="1874520"/>
             <a:ext cx="859536" cy="256032"/>
           </a:xfrm>
           <a:prstGeom prst="roundRect">
@@ -7802,7 +8148,7 @@
         </p:nvSpPr>
         <p:spPr>
           <a:xfrm>
-            <a:off x="7735824" y="1961388"/>
+            <a:off x="7735824" y="1874520"/>
             <a:ext cx="859536" cy="256032"/>
           </a:xfrm>
           <a:prstGeom prst="rect">
@@ -7841,8 +8187,8 @@
         </p:nvSpPr>
         <p:spPr>
           <a:xfrm>
-            <a:off x="457200" y="2286000"/>
-            <a:ext cx="8229600" cy="393192"/>
+            <a:off x="457200" y="2176272"/>
+            <a:ext cx="8229600" cy="347472"/>
           </a:xfrm>
           <a:prstGeom prst="rect">
             <a:avLst/>
@@ -7861,8 +8207,8 @@
         </p:nvSpPr>
         <p:spPr>
           <a:xfrm>
-            <a:off x="457200" y="2286000"/>
-            <a:ext cx="475488" cy="393192"/>
+            <a:off x="457200" y="2176272"/>
+            <a:ext cx="475488" cy="347472"/>
           </a:xfrm>
           <a:prstGeom prst="rect">
             <a:avLst/>
@@ -7900,8 +8246,8 @@
         </p:nvSpPr>
         <p:spPr>
           <a:xfrm>
-            <a:off x="987552" y="2286000"/>
-            <a:ext cx="2523744" cy="393192"/>
+            <a:off x="987552" y="2176272"/>
+            <a:ext cx="2523744" cy="347472"/>
           </a:xfrm>
           <a:prstGeom prst="rect">
             <a:avLst/>
@@ -7939,8 +8285,8 @@
         </p:nvSpPr>
         <p:spPr>
           <a:xfrm>
-            <a:off x="3566160" y="2286000"/>
-            <a:ext cx="2011680" cy="393192"/>
+            <a:off x="3566160" y="2176272"/>
+            <a:ext cx="2011680" cy="347472"/>
           </a:xfrm>
           <a:prstGeom prst="rect">
             <a:avLst/>
@@ -7978,8 +8324,8 @@
         </p:nvSpPr>
         <p:spPr>
           <a:xfrm>
-            <a:off x="5632704" y="2286000"/>
-            <a:ext cx="1207008" cy="393192"/>
+            <a:off x="5632704" y="2176272"/>
+            <a:ext cx="1207008" cy="347472"/>
           </a:xfrm>
           <a:prstGeom prst="rect">
             <a:avLst/>
@@ -8017,8 +8363,8 @@
         </p:nvSpPr>
         <p:spPr>
           <a:xfrm>
-            <a:off x="6876288" y="2286000"/>
-            <a:ext cx="749808" cy="393192"/>
+            <a:off x="6876288" y="2176272"/>
+            <a:ext cx="749808" cy="347472"/>
           </a:xfrm>
           <a:prstGeom prst="rect">
             <a:avLst/>
@@ -8056,7 +8402,7 @@
         </p:nvSpPr>
         <p:spPr>
           <a:xfrm>
-            <a:off x="7735824" y="2354580"/>
+            <a:off x="7735824" y="2221992"/>
             <a:ext cx="859536" cy="256032"/>
           </a:xfrm>
           <a:prstGeom prst="roundRect">
@@ -8083,7 +8429,7 @@
         </p:nvSpPr>
         <p:spPr>
           <a:xfrm>
-            <a:off x="7735824" y="2354580"/>
+            <a:off x="7735824" y="2221992"/>
             <a:ext cx="859536" cy="256032"/>
           </a:xfrm>
           <a:prstGeom prst="rect">
@@ -8122,8 +8468,8 @@
         </p:nvSpPr>
         <p:spPr>
           <a:xfrm>
-            <a:off x="457200" y="2679192"/>
-            <a:ext cx="475488" cy="393192"/>
+            <a:off x="457200" y="2523744"/>
+            <a:ext cx="475488" cy="347472"/>
           </a:xfrm>
           <a:prstGeom prst="rect">
             <a:avLst/>
@@ -8161,8 +8507,8 @@
         </p:nvSpPr>
         <p:spPr>
           <a:xfrm>
-            <a:off x="987552" y="2679192"/>
-            <a:ext cx="2523744" cy="393192"/>
+            <a:off x="987552" y="2523744"/>
+            <a:ext cx="2523744" cy="347472"/>
           </a:xfrm>
           <a:prstGeom prst="rect">
             <a:avLst/>
@@ -8200,8 +8546,8 @@
         </p:nvSpPr>
         <p:spPr>
           <a:xfrm>
-            <a:off x="3566160" y="2679192"/>
-            <a:ext cx="2011680" cy="393192"/>
+            <a:off x="3566160" y="2523744"/>
+            <a:ext cx="2011680" cy="347472"/>
           </a:xfrm>
           <a:prstGeom prst="rect">
             <a:avLst/>
@@ -8239,8 +8585,8 @@
         </p:nvSpPr>
         <p:spPr>
           <a:xfrm>
-            <a:off x="5632704" y="2679192"/>
-            <a:ext cx="1207008" cy="393192"/>
+            <a:off x="5632704" y="2523744"/>
+            <a:ext cx="1207008" cy="347472"/>
           </a:xfrm>
           <a:prstGeom prst="rect">
             <a:avLst/>
@@ -8278,8 +8624,8 @@
         </p:nvSpPr>
         <p:spPr>
           <a:xfrm>
-            <a:off x="6876288" y="2679192"/>
-            <a:ext cx="749808" cy="393192"/>
+            <a:off x="6876288" y="2523744"/>
+            <a:ext cx="749808" cy="347472"/>
           </a:xfrm>
           <a:prstGeom prst="rect">
             <a:avLst/>
@@ -8317,7 +8663,7 @@
         </p:nvSpPr>
         <p:spPr>
           <a:xfrm>
-            <a:off x="7735824" y="2747772"/>
+            <a:off x="7735824" y="2569464"/>
             <a:ext cx="859536" cy="256032"/>
           </a:xfrm>
           <a:prstGeom prst="roundRect">
@@ -8344,7 +8690,7 @@
         </p:nvSpPr>
         <p:spPr>
           <a:xfrm>
-            <a:off x="7735824" y="2747772"/>
+            <a:off x="7735824" y="2569464"/>
             <a:ext cx="859536" cy="256032"/>
           </a:xfrm>
           <a:prstGeom prst="rect">
@@ -8383,8 +8729,8 @@
         </p:nvSpPr>
         <p:spPr>
           <a:xfrm>
-            <a:off x="457200" y="3072384"/>
-            <a:ext cx="8229600" cy="393192"/>
+            <a:off x="457200" y="2871216"/>
+            <a:ext cx="8229600" cy="347472"/>
           </a:xfrm>
           <a:prstGeom prst="rect">
             <a:avLst/>
@@ -8403,8 +8749,8 @@
         </p:nvSpPr>
         <p:spPr>
           <a:xfrm>
-            <a:off x="457200" y="3072384"/>
-            <a:ext cx="475488" cy="393192"/>
+            <a:off x="457200" y="2871216"/>
+            <a:ext cx="475488" cy="347472"/>
           </a:xfrm>
           <a:prstGeom prst="rect">
             <a:avLst/>
@@ -8442,8 +8788,8 @@
         </p:nvSpPr>
         <p:spPr>
           <a:xfrm>
-            <a:off x="987552" y="3072384"/>
-            <a:ext cx="2523744" cy="393192"/>
+            <a:off x="987552" y="2871216"/>
+            <a:ext cx="2523744" cy="347472"/>
           </a:xfrm>
           <a:prstGeom prst="rect">
             <a:avLst/>
@@ -8481,8 +8827,8 @@
         </p:nvSpPr>
         <p:spPr>
           <a:xfrm>
-            <a:off x="3566160" y="3072384"/>
-            <a:ext cx="2011680" cy="393192"/>
+            <a:off x="3566160" y="2871216"/>
+            <a:ext cx="2011680" cy="347472"/>
           </a:xfrm>
           <a:prstGeom prst="rect">
             <a:avLst/>
@@ -8520,8 +8866,8 @@
         </p:nvSpPr>
         <p:spPr>
           <a:xfrm>
-            <a:off x="5632704" y="3072384"/>
-            <a:ext cx="1207008" cy="393192"/>
+            <a:off x="5632704" y="2871216"/>
+            <a:ext cx="1207008" cy="347472"/>
           </a:xfrm>
           <a:prstGeom prst="rect">
             <a:avLst/>
@@ -8559,8 +8905,8 @@
         </p:nvSpPr>
         <p:spPr>
           <a:xfrm>
-            <a:off x="6876288" y="3072384"/>
-            <a:ext cx="749808" cy="393192"/>
+            <a:off x="6876288" y="2871216"/>
+            <a:ext cx="749808" cy="347472"/>
           </a:xfrm>
           <a:prstGeom prst="rect">
             <a:avLst/>
@@ -8598,7 +8944,7 @@
         </p:nvSpPr>
         <p:spPr>
           <a:xfrm>
-            <a:off x="7735824" y="3140964"/>
+            <a:off x="7735824" y="2916936"/>
             <a:ext cx="859536" cy="256032"/>
           </a:xfrm>
           <a:prstGeom prst="roundRect">
@@ -8625,7 +8971,7 @@
         </p:nvSpPr>
         <p:spPr>
           <a:xfrm>
-            <a:off x="7735824" y="3140964"/>
+            <a:off x="7735824" y="2916936"/>
             <a:ext cx="859536" cy="256032"/>
           </a:xfrm>
           <a:prstGeom prst="rect">
@@ -8664,8 +9010,8 @@
         </p:nvSpPr>
         <p:spPr>
           <a:xfrm>
-            <a:off x="457200" y="3465576"/>
-            <a:ext cx="475488" cy="393192"/>
+            <a:off x="457200" y="3218688"/>
+            <a:ext cx="475488" cy="347472"/>
           </a:xfrm>
           <a:prstGeom prst="rect">
             <a:avLst/>
@@ -8703,8 +9049,8 @@
         </p:nvSpPr>
         <p:spPr>
           <a:xfrm>
-            <a:off x="987552" y="3465576"/>
-            <a:ext cx="2523744" cy="393192"/>
+            <a:off x="987552" y="3218688"/>
+            <a:ext cx="2523744" cy="347472"/>
           </a:xfrm>
           <a:prstGeom prst="rect">
             <a:avLst/>
@@ -8742,8 +9088,8 @@
         </p:nvSpPr>
         <p:spPr>
           <a:xfrm>
-            <a:off x="3566160" y="3465576"/>
-            <a:ext cx="2011680" cy="393192"/>
+            <a:off x="3566160" y="3218688"/>
+            <a:ext cx="2011680" cy="347472"/>
           </a:xfrm>
           <a:prstGeom prst="rect">
             <a:avLst/>
@@ -8781,8 +9127,8 @@
         </p:nvSpPr>
         <p:spPr>
           <a:xfrm>
-            <a:off x="5632704" y="3465576"/>
-            <a:ext cx="1207008" cy="393192"/>
+            <a:off x="5632704" y="3218688"/>
+            <a:ext cx="1207008" cy="347472"/>
           </a:xfrm>
           <a:prstGeom prst="rect">
             <a:avLst/>
@@ -8820,8 +9166,8 @@
         </p:nvSpPr>
         <p:spPr>
           <a:xfrm>
-            <a:off x="6876288" y="3465576"/>
-            <a:ext cx="749808" cy="393192"/>
+            <a:off x="6876288" y="3218688"/>
+            <a:ext cx="749808" cy="347472"/>
           </a:xfrm>
           <a:prstGeom prst="rect">
             <a:avLst/>
@@ -8859,7 +9205,7 @@
         </p:nvSpPr>
         <p:spPr>
           <a:xfrm>
-            <a:off x="7735824" y="3534156"/>
+            <a:off x="7735824" y="3264408"/>
             <a:ext cx="859536" cy="256032"/>
           </a:xfrm>
           <a:prstGeom prst="roundRect">
@@ -8886,7 +9232,7 @@
         </p:nvSpPr>
         <p:spPr>
           <a:xfrm>
-            <a:off x="7735824" y="3534156"/>
+            <a:off x="7735824" y="3264408"/>
             <a:ext cx="859536" cy="256032"/>
           </a:xfrm>
           <a:prstGeom prst="rect">
@@ -8925,8 +9271,8 @@
         </p:nvSpPr>
         <p:spPr>
           <a:xfrm>
-            <a:off x="457200" y="3858768"/>
-            <a:ext cx="8229600" cy="393192"/>
+            <a:off x="457200" y="3566160"/>
+            <a:ext cx="8229600" cy="347472"/>
           </a:xfrm>
           <a:prstGeom prst="rect">
             <a:avLst/>
@@ -8945,8 +9291,8 @@
         </p:nvSpPr>
         <p:spPr>
           <a:xfrm>
-            <a:off x="457200" y="3858768"/>
-            <a:ext cx="475488" cy="393192"/>
+            <a:off x="457200" y="3566160"/>
+            <a:ext cx="475488" cy="347472"/>
           </a:xfrm>
           <a:prstGeom prst="rect">
             <a:avLst/>
@@ -8984,8 +9330,8 @@
         </p:nvSpPr>
         <p:spPr>
           <a:xfrm>
-            <a:off x="987552" y="3858768"/>
-            <a:ext cx="2523744" cy="393192"/>
+            <a:off x="987552" y="3566160"/>
+            <a:ext cx="2523744" cy="347472"/>
           </a:xfrm>
           <a:prstGeom prst="rect">
             <a:avLst/>
@@ -9023,8 +9369,8 @@
         </p:nvSpPr>
         <p:spPr>
           <a:xfrm>
-            <a:off x="3566160" y="3858768"/>
-            <a:ext cx="2011680" cy="393192"/>
+            <a:off x="3566160" y="3566160"/>
+            <a:ext cx="2011680" cy="347472"/>
           </a:xfrm>
           <a:prstGeom prst="rect">
             <a:avLst/>
@@ -9062,8 +9408,8 @@
         </p:nvSpPr>
         <p:spPr>
           <a:xfrm>
-            <a:off x="5632704" y="3858768"/>
-            <a:ext cx="1207008" cy="393192"/>
+            <a:off x="5632704" y="3566160"/>
+            <a:ext cx="1207008" cy="347472"/>
           </a:xfrm>
           <a:prstGeom prst="rect">
             <a:avLst/>
@@ -9101,8 +9447,8 @@
         </p:nvSpPr>
         <p:spPr>
           <a:xfrm>
-            <a:off x="6876288" y="3858768"/>
-            <a:ext cx="749808" cy="393192"/>
+            <a:off x="6876288" y="3566160"/>
+            <a:ext cx="749808" cy="347472"/>
           </a:xfrm>
           <a:prstGeom prst="rect">
             <a:avLst/>
@@ -9140,7 +9486,7 @@
         </p:nvSpPr>
         <p:spPr>
           <a:xfrm>
-            <a:off x="7735824" y="3927348"/>
+            <a:off x="7735824" y="3611880"/>
             <a:ext cx="859536" cy="256032"/>
           </a:xfrm>
           <a:prstGeom prst="roundRect">
@@ -9167,7 +9513,7 @@
         </p:nvSpPr>
         <p:spPr>
           <a:xfrm>
-            <a:off x="7735824" y="3927348"/>
+            <a:off x="7735824" y="3611880"/>
             <a:ext cx="859536" cy="256032"/>
           </a:xfrm>
           <a:prstGeom prst="rect">
@@ -9206,12 +9552,12 @@
         </p:nvSpPr>
         <p:spPr>
           <a:xfrm>
-            <a:off x="457200" y="4279392"/>
-            <a:ext cx="8229600" cy="365760"/>
+            <a:off x="457200" y="3968496"/>
+            <a:ext cx="8229600" cy="329184"/>
           </a:xfrm>
           <a:prstGeom prst="roundRect">
             <a:avLst>
-              <a:gd name="adj" fmla="val 10000"/>
+              <a:gd name="adj" fmla="val 11111"/>
             </a:avLst>
           </a:prstGeom>
           <a:solidFill>
@@ -9233,8 +9579,8 @@
         </p:nvSpPr>
         <p:spPr>
           <a:xfrm>
-            <a:off x="658368" y="4279392"/>
-            <a:ext cx="7863840" cy="365760"/>
+            <a:off x="658368" y="3968496"/>
+            <a:ext cx="7863840" cy="329184"/>
           </a:xfrm>
           <a:prstGeom prst="rect">
             <a:avLst/>
@@ -9258,7 +9604,7 @@
                 <a:ea typeface="Calibri" pitchFamily="34" charset="-122"/>
                 <a:cs typeface="Calibri" pitchFamily="34" charset="-120"/>
               </a:rPr>
-              <a:t>진행 현황 공유  —  주간: 매주 금요일 이메일 보고   |   월간: 월말 방문 면담 시 대면 보고   |   수시: 시스템 실시간 조회</a:t>
+              <a:t>진행 현황 공유  —  주간: 금요일 이메일   |   월간: 방문 면담 시 대면   |   수시: 시스템 실시간 조회</a:t>
             </a:r>
             <a:endParaRPr lang="en-US" sz="900" dirty="0"/>
           </a:p>
@@ -9267,6 +9613,179 @@
       <p:sp>
         <p:nvSpPr>
           <p:cNvPr id="68" name="Shape 66"/>
+          <p:cNvSpPr/>
+          <p:nvPr/>
+        </p:nvSpPr>
+        <p:spPr>
+          <a:xfrm>
+            <a:off x="457200" y="4297680"/>
+            <a:ext cx="8229600" cy="329184"/>
+          </a:xfrm>
+          <a:prstGeom prst="roundRect">
+            <a:avLst>
+              <a:gd name="adj" fmla="val 13889"/>
+            </a:avLst>
+          </a:prstGeom>
+          <a:solidFill>
+            <a:srgbClr val="FAFBFC"/>
+          </a:solidFill>
+          <a:ln w="12700">
+            <a:solidFill>
+              <a:srgbClr val="0B4F6C"/>
+            </a:solidFill>
+            <a:prstDash val="solid"/>
+          </a:ln>
+        </p:spPr>
+      </p:sp>
+      <p:sp>
+        <p:nvSpPr>
+          <p:cNvPr id="69" name="Shape 67"/>
+          <p:cNvSpPr/>
+          <p:nvPr/>
+        </p:nvSpPr>
+        <p:spPr>
+          <a:xfrm>
+            <a:off x="457200" y="4297680"/>
+            <a:ext cx="45720" cy="329184"/>
+          </a:xfrm>
+          <a:prstGeom prst="rect">
+            <a:avLst/>
+          </a:prstGeom>
+          <a:solidFill>
+            <a:srgbClr val="0B4F6C"/>
+          </a:solidFill>
+          <a:ln/>
+        </p:spPr>
+      </p:sp>
+      <p:sp>
+        <p:nvSpPr>
+          <p:cNvPr id="70" name="Text 68"/>
+          <p:cNvSpPr/>
+          <p:nvPr/>
+        </p:nvSpPr>
+        <p:spPr>
+          <a:xfrm>
+            <a:off x="603504" y="4297680"/>
+            <a:ext cx="310896" cy="329184"/>
+          </a:xfrm>
+          <a:prstGeom prst="rect">
+            <a:avLst/>
+          </a:prstGeom>
+          <a:noFill/>
+          <a:ln/>
+        </p:spPr>
+        <p:txBody>
+          <a:bodyPr wrap="square" lIns="0" tIns="0" rIns="0" bIns="0" rtlCol="0" anchor="ctr"/>
+          <a:lstStyle/>
+          <a:p>
+            <a:pPr algn="ctr" indent="0" marL="0">
+              <a:buNone/>
+            </a:pPr>
+            <a:r>
+              <a:rPr lang="en-US" sz="1200" dirty="0">
+                <a:solidFill>
+                  <a:srgbClr val="000000"/>
+                </a:solidFill>
+                <a:latin typeface="Calibri" pitchFamily="34" charset="0"/>
+                <a:ea typeface="Calibri" pitchFamily="34" charset="-122"/>
+                <a:cs typeface="Calibri" pitchFamily="34" charset="-120"/>
+              </a:rPr>
+              <a:t>🔗</a:t>
+            </a:r>
+            <a:endParaRPr lang="en-US" sz="1200" dirty="0"/>
+          </a:p>
+        </p:txBody>
+      </p:sp>
+      <p:sp>
+        <p:nvSpPr>
+          <p:cNvPr id="71" name="Text 69"/>
+          <p:cNvSpPr/>
+          <p:nvPr/>
+        </p:nvSpPr>
+        <p:spPr>
+          <a:xfrm>
+            <a:off x="932688" y="4297680"/>
+            <a:ext cx="3200400" cy="329184"/>
+          </a:xfrm>
+          <a:prstGeom prst="rect">
+            <a:avLst/>
+          </a:prstGeom>
+          <a:noFill/>
+          <a:ln/>
+        </p:spPr>
+        <p:txBody>
+          <a:bodyPr wrap="square" lIns="0" tIns="0" rIns="0" bIns="0" rtlCol="0" anchor="ctr"/>
+          <a:lstStyle/>
+          <a:p>
+            <a:pPr indent="0" marL="0">
+              <a:buNone/>
+            </a:pPr>
+            <a:r>
+              <a:rPr lang="en-US" sz="1000" b="1" dirty="0">
+                <a:solidFill>
+                  <a:srgbClr val="0B4F6C"/>
+                </a:solidFill>
+                <a:latin typeface="Calibri" pitchFamily="34" charset="0"/>
+                <a:ea typeface="Calibri" pitchFamily="34" charset="-122"/>
+                <a:cs typeface="Calibri" pitchFamily="34" charset="-120"/>
+              </a:rPr>
+              <a:t>업무관리 시스템</a:t>
+            </a:r>
+            <a:endParaRPr lang="en-US" sz="1000" dirty="0"/>
+          </a:p>
+        </p:txBody>
+      </p:sp>
+      <p:sp>
+        <p:nvSpPr>
+          <p:cNvPr id="72" name="Text 70">
+            <a:hlinkClick r:id="rId1" tooltip=""/>
+          </p:cNvPr>
+          <p:cNvSpPr/>
+          <p:nvPr/>
+        </p:nvSpPr>
+        <p:spPr>
+          <a:xfrm>
+            <a:off x="4169664" y="4297680"/>
+            <a:ext cx="4389120" cy="329184"/>
+          </a:xfrm>
+          <a:prstGeom prst="rect">
+            <a:avLst/>
+          </a:prstGeom>
+          <a:noFill/>
+          <a:ln/>
+        </p:spPr>
+        <p:txBody>
+          <a:bodyPr wrap="square" lIns="0" tIns="0" rIns="0" bIns="0" rtlCol="0" anchor="ctr"/>
+          <a:lstStyle/>
+          <a:p>
+            <a:pPr indent="0" marL="0">
+              <a:buNone/>
+            </a:pPr>
+            <a:r>
+              <a:rPr lang="en-US" sz="950" u="sng" dirty="0">
+                <a:solidFill>
+                  <a:srgbClr val="5A6B7C"/>
+                </a:solidFill>
+                <a:latin typeface="Calibri" pitchFamily="34" charset="0"/>
+                <a:ea typeface="Calibri" pitchFamily="34" charset="-122"/>
+                <a:cs typeface="Calibri" pitchFamily="34" charset="-120"/>
+                <a:hlinkClick r:id="rId1" invalidUrl="" action="" tgtFrame="" tooltip="" history="1" highlightClick="0" endSnd="0">
+                  <a:extLst>
+                    <a:ext uri="{A12FA001-AC4F-418D-AE19-62706E023703}">
+                      <ahyp:hlinkClr xmlns:ahyp="http://schemas.microsoft.com/office/drawing/2018/hyperlinkcolor" val="tx"/>
+                    </a:ext>
+                  </a:extLst>
+                </a:hlinkClick>
+              </a:rPr>
+              <a:t>https://insys-hq.github.io/Insys-review/ims.html</a:t>
+            </a:r>
+            <a:endParaRPr lang="en-US" sz="950" dirty="0"/>
+          </a:p>
+        </p:txBody>
+      </p:sp>
+      <p:sp>
+        <p:nvSpPr>
+          <p:cNvPr id="73" name="Shape 71"/>
           <p:cNvSpPr/>
           <p:nvPr/>
         </p:nvSpPr>
@@ -9286,7 +9805,7 @@
       </p:sp>
       <p:sp>
         <p:nvSpPr>
-          <p:cNvPr id="69" name="Text 67"/>
+          <p:cNvPr id="74" name="Text 72"/>
           <p:cNvSpPr/>
           <p:nvPr/>
         </p:nvSpPr>
@@ -9317,7 +9836,7 @@
                 <a:ea typeface="Calibri" pitchFamily="34" charset="-122"/>
                 <a:cs typeface="Calibri" pitchFamily="34" charset="-120"/>
               </a:rPr>
-              <a:t>㈜인시스  ·  셰플러 이천공장 수입검사 실행계획서 v4.1</a:t>
+              <a:t>㈜인시스  ·  셰플러 이천공장 수입검사 실행계획서 v4.4</a:t>
             </a:r>
             <a:endParaRPr lang="en-US" sz="800" dirty="0"/>
           </a:p>
@@ -9325,7 +9844,7 @@
       </p:sp>
       <p:sp>
         <p:nvSpPr>
-          <p:cNvPr id="70" name="Text 68"/>
+          <p:cNvPr id="75" name="Text 73"/>
           <p:cNvSpPr/>
           <p:nvPr/>
         </p:nvSpPr>
@@ -9937,12 +10456,12 @@
         </p:nvSpPr>
         <p:spPr>
           <a:xfrm>
-            <a:off x="457200" y="1243584"/>
-            <a:ext cx="2624328" cy="1481328"/>
+            <a:off x="457200" y="1207008"/>
+            <a:ext cx="2624328" cy="1426464"/>
           </a:xfrm>
           <a:prstGeom prst="roundRect">
             <a:avLst>
-              <a:gd name="adj" fmla="val 2469"/>
+              <a:gd name="adj" fmla="val 2564"/>
             </a:avLst>
           </a:prstGeom>
           <a:solidFill>
@@ -9964,8 +10483,8 @@
         </p:nvSpPr>
         <p:spPr>
           <a:xfrm>
-            <a:off x="457200" y="1243584"/>
-            <a:ext cx="50292" cy="1481328"/>
+            <a:off x="457200" y="1207008"/>
+            <a:ext cx="50292" cy="1426464"/>
           </a:xfrm>
           <a:prstGeom prst="rect">
             <a:avLst/>
@@ -9984,7 +10503,7 @@
         </p:nvSpPr>
         <p:spPr>
           <a:xfrm>
-            <a:off x="640080" y="1389888"/>
+            <a:off x="640080" y="1353312"/>
             <a:ext cx="365760" cy="365760"/>
           </a:xfrm>
           <a:prstGeom prst="ellipse">
@@ -10009,7 +10528,7 @@
         </p:nvSpPr>
         <p:spPr>
           <a:xfrm>
-            <a:off x="640080" y="1389888"/>
+            <a:off x="640080" y="1353312"/>
             <a:ext cx="365760" cy="365760"/>
           </a:xfrm>
           <a:prstGeom prst="rect">
@@ -10048,7 +10567,7 @@
         </p:nvSpPr>
         <p:spPr>
           <a:xfrm>
-            <a:off x="2286000" y="1426464"/>
+            <a:off x="2286000" y="1389888"/>
             <a:ext cx="658368" cy="201168"/>
           </a:xfrm>
           <a:prstGeom prst="rect">
@@ -10087,7 +10606,7 @@
         </p:nvSpPr>
         <p:spPr>
           <a:xfrm>
-            <a:off x="640080" y="1828800"/>
+            <a:off x="640080" y="1792224"/>
             <a:ext cx="2286000" cy="256032"/>
           </a:xfrm>
           <a:prstGeom prst="rect">
@@ -10126,7 +10645,7 @@
         </p:nvSpPr>
         <p:spPr>
           <a:xfrm>
-            <a:off x="640080" y="2103120"/>
+            <a:off x="640080" y="2066544"/>
             <a:ext cx="2286000" cy="493776"/>
           </a:xfrm>
           <a:prstGeom prst="rect">
@@ -10188,12 +10707,12 @@
         </p:nvSpPr>
         <p:spPr>
           <a:xfrm>
-            <a:off x="3264408" y="1243584"/>
-            <a:ext cx="2624328" cy="1481328"/>
+            <a:off x="3264408" y="1207008"/>
+            <a:ext cx="2624328" cy="1426464"/>
           </a:xfrm>
           <a:prstGeom prst="roundRect">
             <a:avLst>
-              <a:gd name="adj" fmla="val 2469"/>
+              <a:gd name="adj" fmla="val 2564"/>
             </a:avLst>
           </a:prstGeom>
           <a:solidFill>
@@ -10215,8 +10734,8 @@
         </p:nvSpPr>
         <p:spPr>
           <a:xfrm>
-            <a:off x="3264408" y="1243584"/>
-            <a:ext cx="50292" cy="1481328"/>
+            <a:off x="3264408" y="1207008"/>
+            <a:ext cx="50292" cy="1426464"/>
           </a:xfrm>
           <a:prstGeom prst="rect">
             <a:avLst/>
@@ -10235,7 +10754,7 @@
         </p:nvSpPr>
         <p:spPr>
           <a:xfrm>
-            <a:off x="3447288" y="1389888"/>
+            <a:off x="3447288" y="1353312"/>
             <a:ext cx="365760" cy="365760"/>
           </a:xfrm>
           <a:prstGeom prst="ellipse">
@@ -10260,7 +10779,7 @@
         </p:nvSpPr>
         <p:spPr>
           <a:xfrm>
-            <a:off x="3447288" y="1389888"/>
+            <a:off x="3447288" y="1353312"/>
             <a:ext cx="365760" cy="365760"/>
           </a:xfrm>
           <a:prstGeom prst="rect">
@@ -10299,7 +10818,7 @@
         </p:nvSpPr>
         <p:spPr>
           <a:xfrm>
-            <a:off x="5093208" y="1426464"/>
+            <a:off x="5093208" y="1389888"/>
             <a:ext cx="658368" cy="201168"/>
           </a:xfrm>
           <a:prstGeom prst="rect">
@@ -10338,7 +10857,7 @@
         </p:nvSpPr>
         <p:spPr>
           <a:xfrm>
-            <a:off x="3447288" y="1828800"/>
+            <a:off x="3447288" y="1792224"/>
             <a:ext cx="2286000" cy="256032"/>
           </a:xfrm>
           <a:prstGeom prst="rect">
@@ -10377,7 +10896,7 @@
         </p:nvSpPr>
         <p:spPr>
           <a:xfrm>
-            <a:off x="3447288" y="2103120"/>
+            <a:off x="3447288" y="2066544"/>
             <a:ext cx="2286000" cy="493776"/>
           </a:xfrm>
           <a:prstGeom prst="rect">
@@ -10439,12 +10958,12 @@
         </p:nvSpPr>
         <p:spPr>
           <a:xfrm>
-            <a:off x="6071616" y="1243584"/>
-            <a:ext cx="2624328" cy="1481328"/>
+            <a:off x="6071616" y="1207008"/>
+            <a:ext cx="2624328" cy="1426464"/>
           </a:xfrm>
           <a:prstGeom prst="roundRect">
             <a:avLst>
-              <a:gd name="adj" fmla="val 2469"/>
+              <a:gd name="adj" fmla="val 2564"/>
             </a:avLst>
           </a:prstGeom>
           <a:solidFill>
@@ -10466,8 +10985,8 @@
         </p:nvSpPr>
         <p:spPr>
           <a:xfrm>
-            <a:off x="6071616" y="1243584"/>
-            <a:ext cx="50292" cy="1481328"/>
+            <a:off x="6071616" y="1207008"/>
+            <a:ext cx="50292" cy="1426464"/>
           </a:xfrm>
           <a:prstGeom prst="rect">
             <a:avLst/>
@@ -10486,7 +11005,7 @@
         </p:nvSpPr>
         <p:spPr>
           <a:xfrm>
-            <a:off x="6254496" y="1389888"/>
+            <a:off x="6254496" y="1353312"/>
             <a:ext cx="365760" cy="365760"/>
           </a:xfrm>
           <a:prstGeom prst="ellipse">
@@ -10511,7 +11030,7 @@
         </p:nvSpPr>
         <p:spPr>
           <a:xfrm>
-            <a:off x="6254496" y="1389888"/>
+            <a:off x="6254496" y="1353312"/>
             <a:ext cx="365760" cy="365760"/>
           </a:xfrm>
           <a:prstGeom prst="rect">
@@ -10550,7 +11069,7 @@
         </p:nvSpPr>
         <p:spPr>
           <a:xfrm>
-            <a:off x="7900416" y="1426464"/>
+            <a:off x="7900416" y="1389888"/>
             <a:ext cx="658368" cy="201168"/>
           </a:xfrm>
           <a:prstGeom prst="rect">
@@ -10589,7 +11108,7 @@
         </p:nvSpPr>
         <p:spPr>
           <a:xfrm>
-            <a:off x="6254496" y="1828800"/>
+            <a:off x="6254496" y="1792224"/>
             <a:ext cx="2286000" cy="256032"/>
           </a:xfrm>
           <a:prstGeom prst="rect">
@@ -10628,7 +11147,7 @@
         </p:nvSpPr>
         <p:spPr>
           <a:xfrm>
-            <a:off x="6254496" y="2103120"/>
+            <a:off x="6254496" y="2066544"/>
             <a:ext cx="2286000" cy="493776"/>
           </a:xfrm>
           <a:prstGeom prst="rect">
@@ -10690,12 +11209,12 @@
         </p:nvSpPr>
         <p:spPr>
           <a:xfrm>
-            <a:off x="457200" y="2907792"/>
-            <a:ext cx="2624328" cy="1481328"/>
+            <a:off x="457200" y="2779776"/>
+            <a:ext cx="2624328" cy="1426464"/>
           </a:xfrm>
           <a:prstGeom prst="roundRect">
             <a:avLst>
-              <a:gd name="adj" fmla="val 2469"/>
+              <a:gd name="adj" fmla="val 2564"/>
             </a:avLst>
           </a:prstGeom>
           <a:solidFill>
@@ -10717,8 +11236,8 @@
         </p:nvSpPr>
         <p:spPr>
           <a:xfrm>
-            <a:off x="457200" y="2907792"/>
-            <a:ext cx="50292" cy="1481328"/>
+            <a:off x="457200" y="2779776"/>
+            <a:ext cx="50292" cy="1426464"/>
           </a:xfrm>
           <a:prstGeom prst="rect">
             <a:avLst/>
@@ -10737,7 +11256,7 @@
         </p:nvSpPr>
         <p:spPr>
           <a:xfrm>
-            <a:off x="640080" y="3054096"/>
+            <a:off x="640080" y="2926080"/>
             <a:ext cx="365760" cy="365760"/>
           </a:xfrm>
           <a:prstGeom prst="ellipse">
@@ -10762,7 +11281,7 @@
         </p:nvSpPr>
         <p:spPr>
           <a:xfrm>
-            <a:off x="640080" y="3054096"/>
+            <a:off x="640080" y="2926080"/>
             <a:ext cx="365760" cy="365760"/>
           </a:xfrm>
           <a:prstGeom prst="rect">
@@ -10801,7 +11320,7 @@
         </p:nvSpPr>
         <p:spPr>
           <a:xfrm>
-            <a:off x="2286000" y="3090672"/>
+            <a:off x="2286000" y="2962656"/>
             <a:ext cx="658368" cy="201168"/>
           </a:xfrm>
           <a:prstGeom prst="rect">
@@ -10840,7 +11359,7 @@
         </p:nvSpPr>
         <p:spPr>
           <a:xfrm>
-            <a:off x="640080" y="3493008"/>
+            <a:off x="640080" y="3364992"/>
             <a:ext cx="2286000" cy="256032"/>
           </a:xfrm>
           <a:prstGeom prst="rect">
@@ -10879,7 +11398,7 @@
         </p:nvSpPr>
         <p:spPr>
           <a:xfrm>
-            <a:off x="640080" y="3767328"/>
+            <a:off x="640080" y="3639312"/>
             <a:ext cx="2286000" cy="493776"/>
           </a:xfrm>
           <a:prstGeom prst="rect">
@@ -10941,12 +11460,12 @@
         </p:nvSpPr>
         <p:spPr>
           <a:xfrm>
-            <a:off x="3264408" y="2907792"/>
-            <a:ext cx="2624328" cy="1481328"/>
+            <a:off x="3264408" y="2779776"/>
+            <a:ext cx="2624328" cy="1426464"/>
           </a:xfrm>
           <a:prstGeom prst="roundRect">
             <a:avLst>
-              <a:gd name="adj" fmla="val 2469"/>
+              <a:gd name="adj" fmla="val 2564"/>
             </a:avLst>
           </a:prstGeom>
           <a:solidFill>
@@ -10968,8 +11487,8 @@
         </p:nvSpPr>
         <p:spPr>
           <a:xfrm>
-            <a:off x="3264408" y="2907792"/>
-            <a:ext cx="50292" cy="1481328"/>
+            <a:off x="3264408" y="2779776"/>
+            <a:ext cx="50292" cy="1426464"/>
           </a:xfrm>
           <a:prstGeom prst="rect">
             <a:avLst/>
@@ -10988,7 +11507,7 @@
         </p:nvSpPr>
         <p:spPr>
           <a:xfrm>
-            <a:off x="3447288" y="3054096"/>
+            <a:off x="3447288" y="2926080"/>
             <a:ext cx="365760" cy="365760"/>
           </a:xfrm>
           <a:prstGeom prst="ellipse">
@@ -11013,7 +11532,7 @@
         </p:nvSpPr>
         <p:spPr>
           <a:xfrm>
-            <a:off x="3447288" y="3054096"/>
+            <a:off x="3447288" y="2926080"/>
             <a:ext cx="365760" cy="365760"/>
           </a:xfrm>
           <a:prstGeom prst="rect">
@@ -11052,7 +11571,7 @@
         </p:nvSpPr>
         <p:spPr>
           <a:xfrm>
-            <a:off x="5093208" y="3090672"/>
+            <a:off x="5093208" y="2962656"/>
             <a:ext cx="658368" cy="201168"/>
           </a:xfrm>
           <a:prstGeom prst="rect">
@@ -11091,7 +11610,7 @@
         </p:nvSpPr>
         <p:spPr>
           <a:xfrm>
-            <a:off x="3447288" y="3493008"/>
+            <a:off x="3447288" y="3364992"/>
             <a:ext cx="2286000" cy="256032"/>
           </a:xfrm>
           <a:prstGeom prst="rect">
@@ -11130,7 +11649,7 @@
         </p:nvSpPr>
         <p:spPr>
           <a:xfrm>
-            <a:off x="3447288" y="3767328"/>
+            <a:off x="3447288" y="3639312"/>
             <a:ext cx="2286000" cy="493776"/>
           </a:xfrm>
           <a:prstGeom prst="rect">
@@ -11192,12 +11711,12 @@
         </p:nvSpPr>
         <p:spPr>
           <a:xfrm>
-            <a:off x="6071616" y="2907792"/>
-            <a:ext cx="2624328" cy="1481328"/>
+            <a:off x="6071616" y="2779776"/>
+            <a:ext cx="2624328" cy="1426464"/>
           </a:xfrm>
           <a:prstGeom prst="roundRect">
             <a:avLst>
-              <a:gd name="adj" fmla="val 2469"/>
+              <a:gd name="adj" fmla="val 2564"/>
             </a:avLst>
           </a:prstGeom>
           <a:solidFill>
@@ -11219,8 +11738,8 @@
         </p:nvSpPr>
         <p:spPr>
           <a:xfrm>
-            <a:off x="6071616" y="2907792"/>
-            <a:ext cx="50292" cy="1481328"/>
+            <a:off x="6071616" y="2779776"/>
+            <a:ext cx="50292" cy="1426464"/>
           </a:xfrm>
           <a:prstGeom prst="rect">
             <a:avLst/>
@@ -11239,7 +11758,7 @@
         </p:nvSpPr>
         <p:spPr>
           <a:xfrm>
-            <a:off x="6254496" y="3054096"/>
+            <a:off x="6254496" y="2926080"/>
             <a:ext cx="365760" cy="365760"/>
           </a:xfrm>
           <a:prstGeom prst="ellipse">
@@ -11264,7 +11783,7 @@
         </p:nvSpPr>
         <p:spPr>
           <a:xfrm>
-            <a:off x="6254496" y="3054096"/>
+            <a:off x="6254496" y="2926080"/>
             <a:ext cx="365760" cy="365760"/>
           </a:xfrm>
           <a:prstGeom prst="rect">
@@ -11303,7 +11822,7 @@
         </p:nvSpPr>
         <p:spPr>
           <a:xfrm>
-            <a:off x="7900416" y="3090672"/>
+            <a:off x="7900416" y="2962656"/>
             <a:ext cx="658368" cy="201168"/>
           </a:xfrm>
           <a:prstGeom prst="rect">
@@ -11342,7 +11861,7 @@
         </p:nvSpPr>
         <p:spPr>
           <a:xfrm>
-            <a:off x="6254496" y="3493008"/>
+            <a:off x="6254496" y="3364992"/>
             <a:ext cx="2286000" cy="256032"/>
           </a:xfrm>
           <a:prstGeom prst="rect">
@@ -11381,7 +11900,7 @@
         </p:nvSpPr>
         <p:spPr>
           <a:xfrm>
-            <a:off x="6254496" y="3767328"/>
+            <a:off x="6254496" y="3639312"/>
             <a:ext cx="2286000" cy="493776"/>
           </a:xfrm>
           <a:prstGeom prst="rect">
@@ -11443,6 +11962,179 @@
         </p:nvSpPr>
         <p:spPr>
           <a:xfrm>
+            <a:off x="457200" y="4279392"/>
+            <a:ext cx="8229600" cy="329184"/>
+          </a:xfrm>
+          <a:prstGeom prst="roundRect">
+            <a:avLst>
+              <a:gd name="adj" fmla="val 13889"/>
+            </a:avLst>
+          </a:prstGeom>
+          <a:solidFill>
+            <a:srgbClr val="FAFBFC"/>
+          </a:solidFill>
+          <a:ln w="12700">
+            <a:solidFill>
+              <a:srgbClr val="1C7293"/>
+            </a:solidFill>
+            <a:prstDash val="solid"/>
+          </a:ln>
+        </p:spPr>
+      </p:sp>
+      <p:sp>
+        <p:nvSpPr>
+          <p:cNvPr id="49" name="Shape 47"/>
+          <p:cNvSpPr/>
+          <p:nvPr/>
+        </p:nvSpPr>
+        <p:spPr>
+          <a:xfrm>
+            <a:off x="457200" y="4279392"/>
+            <a:ext cx="45720" cy="329184"/>
+          </a:xfrm>
+          <a:prstGeom prst="rect">
+            <a:avLst/>
+          </a:prstGeom>
+          <a:solidFill>
+            <a:srgbClr val="1C7293"/>
+          </a:solidFill>
+          <a:ln/>
+        </p:spPr>
+      </p:sp>
+      <p:sp>
+        <p:nvSpPr>
+          <p:cNvPr id="50" name="Text 48"/>
+          <p:cNvSpPr/>
+          <p:nvPr/>
+        </p:nvSpPr>
+        <p:spPr>
+          <a:xfrm>
+            <a:off x="603504" y="4279392"/>
+            <a:ext cx="310896" cy="329184"/>
+          </a:xfrm>
+          <a:prstGeom prst="rect">
+            <a:avLst/>
+          </a:prstGeom>
+          <a:noFill/>
+          <a:ln/>
+        </p:spPr>
+        <p:txBody>
+          <a:bodyPr wrap="square" lIns="0" tIns="0" rIns="0" bIns="0" rtlCol="0" anchor="ctr"/>
+          <a:lstStyle/>
+          <a:p>
+            <a:pPr algn="ctr" indent="0" marL="0">
+              <a:buNone/>
+            </a:pPr>
+            <a:r>
+              <a:rPr lang="en-US" sz="1200" dirty="0">
+                <a:solidFill>
+                  <a:srgbClr val="000000"/>
+                </a:solidFill>
+                <a:latin typeface="Calibri" pitchFamily="34" charset="0"/>
+                <a:ea typeface="Calibri" pitchFamily="34" charset="-122"/>
+                <a:cs typeface="Calibri" pitchFamily="34" charset="-120"/>
+              </a:rPr>
+              <a:t>🔗</a:t>
+            </a:r>
+            <a:endParaRPr lang="en-US" sz="1200" dirty="0"/>
+          </a:p>
+        </p:txBody>
+      </p:sp>
+      <p:sp>
+        <p:nvSpPr>
+          <p:cNvPr id="51" name="Text 49"/>
+          <p:cNvSpPr/>
+          <p:nvPr/>
+        </p:nvSpPr>
+        <p:spPr>
+          <a:xfrm>
+            <a:off x="932688" y="4279392"/>
+            <a:ext cx="3200400" cy="329184"/>
+          </a:xfrm>
+          <a:prstGeom prst="rect">
+            <a:avLst/>
+          </a:prstGeom>
+          <a:noFill/>
+          <a:ln/>
+        </p:spPr>
+        <p:txBody>
+          <a:bodyPr wrap="square" lIns="0" tIns="0" rIns="0" bIns="0" rtlCol="0" anchor="ctr"/>
+          <a:lstStyle/>
+          <a:p>
+            <a:pPr indent="0" marL="0">
+              <a:buNone/>
+            </a:pPr>
+            <a:r>
+              <a:rPr lang="en-US" sz="1000" b="1" dirty="0">
+                <a:solidFill>
+                  <a:srgbClr val="1C7293"/>
+                </a:solidFill>
+                <a:latin typeface="Calibri" pitchFamily="34" charset="0"/>
+                <a:ea typeface="Calibri" pitchFamily="34" charset="-122"/>
+                <a:cs typeface="Calibri" pitchFamily="34" charset="-120"/>
+              </a:rPr>
+              <a:t>수입검사 업무관리 시스템</a:t>
+            </a:r>
+            <a:endParaRPr lang="en-US" sz="1000" dirty="0"/>
+          </a:p>
+        </p:txBody>
+      </p:sp>
+      <p:sp>
+        <p:nvSpPr>
+          <p:cNvPr id="52" name="Text 50">
+            <a:hlinkClick r:id="rId1" tooltip=""/>
+          </p:cNvPr>
+          <p:cNvSpPr/>
+          <p:nvPr/>
+        </p:nvSpPr>
+        <p:spPr>
+          <a:xfrm>
+            <a:off x="4169664" y="4279392"/>
+            <a:ext cx="4389120" cy="329184"/>
+          </a:xfrm>
+          <a:prstGeom prst="rect">
+            <a:avLst/>
+          </a:prstGeom>
+          <a:noFill/>
+          <a:ln/>
+        </p:spPr>
+        <p:txBody>
+          <a:bodyPr wrap="square" lIns="0" tIns="0" rIns="0" bIns="0" rtlCol="0" anchor="ctr"/>
+          <a:lstStyle/>
+          <a:p>
+            <a:pPr indent="0" marL="0">
+              <a:buNone/>
+            </a:pPr>
+            <a:r>
+              <a:rPr lang="en-US" sz="950" u="sng" dirty="0">
+                <a:solidFill>
+                  <a:srgbClr val="5A6B7C"/>
+                </a:solidFill>
+                <a:latin typeface="Calibri" pitchFamily="34" charset="0"/>
+                <a:ea typeface="Calibri" pitchFamily="34" charset="-122"/>
+                <a:cs typeface="Calibri" pitchFamily="34" charset="-120"/>
+                <a:hlinkClick r:id="rId1" invalidUrl="" action="" tgtFrame="" tooltip="" history="1" highlightClick="0" endSnd="0">
+                  <a:extLst>
+                    <a:ext uri="{A12FA001-AC4F-418D-AE19-62706E023703}">
+                      <ahyp:hlinkClr xmlns:ahyp="http://schemas.microsoft.com/office/drawing/2018/hyperlinkcolor" val="tx"/>
+                    </a:ext>
+                  </a:extLst>
+                </a:hlinkClick>
+              </a:rPr>
+              <a:t>https://insys-hq.github.io/Insys-review/ims.html</a:t>
+            </a:r>
+            <a:endParaRPr lang="en-US" sz="950" dirty="0"/>
+          </a:p>
+        </p:txBody>
+      </p:sp>
+      <p:sp>
+        <p:nvSpPr>
+          <p:cNvPr id="53" name="Shape 51"/>
+          <p:cNvSpPr/>
+          <p:nvPr/>
+        </p:nvSpPr>
+        <p:spPr>
+          <a:xfrm>
             <a:off x="457200" y="4718304"/>
             <a:ext cx="8229600" cy="10973"/>
           </a:xfrm>
@@ -11457,7 +12149,7 @@
       </p:sp>
       <p:sp>
         <p:nvSpPr>
-          <p:cNvPr id="49" name="Text 47"/>
+          <p:cNvPr id="54" name="Text 52"/>
           <p:cNvSpPr/>
           <p:nvPr/>
         </p:nvSpPr>
@@ -11488,7 +12180,7 @@
                 <a:ea typeface="Calibri" pitchFamily="34" charset="-122"/>
                 <a:cs typeface="Calibri" pitchFamily="34" charset="-120"/>
               </a:rPr>
-              <a:t>㈜인시스  ·  셰플러 이천공장 수입검사 실행계획서 v4.1</a:t>
+              <a:t>㈜인시스  ·  셰플러 이천공장 수입검사 실행계획서 v4.4</a:t>
             </a:r>
             <a:endParaRPr lang="en-US" sz="800" dirty="0"/>
           </a:p>
@@ -11496,7 +12188,7 @@
       </p:sp>
       <p:sp>
         <p:nvSpPr>
-          <p:cNvPr id="50" name="Text 48"/>
+          <p:cNvPr id="55" name="Text 53"/>
           <p:cNvSpPr/>
           <p:nvPr/>
         </p:nvSpPr>
@@ -11769,11 +12461,11 @@
         <p:spPr>
           <a:xfrm>
             <a:off x="457200" y="1133856"/>
-            <a:ext cx="4663440" cy="950976"/>
+            <a:ext cx="4663440" cy="841248"/>
           </a:xfrm>
           <a:prstGeom prst="roundRect">
             <a:avLst>
-              <a:gd name="adj" fmla="val 3846"/>
+              <a:gd name="adj" fmla="val 4348"/>
             </a:avLst>
           </a:prstGeom>
           <a:solidFill>
@@ -11795,8 +12487,8 @@
         </p:nvSpPr>
         <p:spPr>
           <a:xfrm>
-            <a:off x="658368" y="1298448"/>
-            <a:ext cx="310896" cy="310896"/>
+            <a:off x="658368" y="1280160"/>
+            <a:ext cx="292608" cy="292608"/>
           </a:xfrm>
           <a:prstGeom prst="ellipse">
             <a:avLst/>
@@ -11820,8 +12512,8 @@
         </p:nvSpPr>
         <p:spPr>
           <a:xfrm>
-            <a:off x="658368" y="1298448"/>
-            <a:ext cx="310896" cy="310896"/>
+            <a:off x="658368" y="1280160"/>
+            <a:ext cx="292608" cy="292608"/>
           </a:xfrm>
           <a:prstGeom prst="rect">
             <a:avLst/>
@@ -11859,8 +12551,8 @@
         </p:nvSpPr>
         <p:spPr>
           <a:xfrm>
-            <a:off x="1078992" y="1261872"/>
-            <a:ext cx="3840480" cy="256032"/>
+            <a:off x="1060704" y="1225296"/>
+            <a:ext cx="3840480" cy="237744"/>
           </a:xfrm>
           <a:prstGeom prst="rect">
             <a:avLst/>
@@ -11898,8 +12590,8 @@
         </p:nvSpPr>
         <p:spPr>
           <a:xfrm>
-            <a:off x="1078992" y="1554480"/>
-            <a:ext cx="3840480" cy="402336"/>
+            <a:off x="1060704" y="1499616"/>
+            <a:ext cx="3840480" cy="384048"/>
           </a:xfrm>
           <a:prstGeom prst="rect">
             <a:avLst/>
@@ -11940,12 +12632,12 @@
         </p:nvSpPr>
         <p:spPr>
           <a:xfrm>
-            <a:off x="457200" y="2249424"/>
-            <a:ext cx="4663440" cy="950976"/>
+            <a:off x="457200" y="2103120"/>
+            <a:ext cx="4663440" cy="841248"/>
           </a:xfrm>
           <a:prstGeom prst="roundRect">
             <a:avLst>
-              <a:gd name="adj" fmla="val 3846"/>
+              <a:gd name="adj" fmla="val 4348"/>
             </a:avLst>
           </a:prstGeom>
           <a:solidFill>
@@ -11967,8 +12659,8 @@
         </p:nvSpPr>
         <p:spPr>
           <a:xfrm>
-            <a:off x="658368" y="2414016"/>
-            <a:ext cx="310896" cy="310896"/>
+            <a:off x="658368" y="2249424"/>
+            <a:ext cx="292608" cy="292608"/>
           </a:xfrm>
           <a:prstGeom prst="ellipse">
             <a:avLst/>
@@ -11992,8 +12684,8 @@
         </p:nvSpPr>
         <p:spPr>
           <a:xfrm>
-            <a:off x="658368" y="2414016"/>
-            <a:ext cx="310896" cy="310896"/>
+            <a:off x="658368" y="2249424"/>
+            <a:ext cx="292608" cy="292608"/>
           </a:xfrm>
           <a:prstGeom prst="rect">
             <a:avLst/>
@@ -12031,8 +12723,8 @@
         </p:nvSpPr>
         <p:spPr>
           <a:xfrm>
-            <a:off x="1078992" y="2377440"/>
-            <a:ext cx="3840480" cy="256032"/>
+            <a:off x="1060704" y="2194560"/>
+            <a:ext cx="3840480" cy="237744"/>
           </a:xfrm>
           <a:prstGeom prst="rect">
             <a:avLst/>
@@ -12070,8 +12762,8 @@
         </p:nvSpPr>
         <p:spPr>
           <a:xfrm>
-            <a:off x="1078992" y="2670048"/>
-            <a:ext cx="3840480" cy="402336"/>
+            <a:off x="1060704" y="2468880"/>
+            <a:ext cx="3840480" cy="384048"/>
           </a:xfrm>
           <a:prstGeom prst="rect">
             <a:avLst/>
@@ -12112,12 +12804,12 @@
         </p:nvSpPr>
         <p:spPr>
           <a:xfrm>
-            <a:off x="457200" y="3364992"/>
-            <a:ext cx="4663440" cy="950976"/>
+            <a:off x="457200" y="3072384"/>
+            <a:ext cx="4663440" cy="841248"/>
           </a:xfrm>
           <a:prstGeom prst="roundRect">
             <a:avLst>
-              <a:gd name="adj" fmla="val 3846"/>
+              <a:gd name="adj" fmla="val 4348"/>
             </a:avLst>
           </a:prstGeom>
           <a:solidFill>
@@ -12139,8 +12831,8 @@
         </p:nvSpPr>
         <p:spPr>
           <a:xfrm>
-            <a:off x="658368" y="3529584"/>
-            <a:ext cx="310896" cy="310896"/>
+            <a:off x="658368" y="3218688"/>
+            <a:ext cx="292608" cy="292608"/>
           </a:xfrm>
           <a:prstGeom prst="ellipse">
             <a:avLst/>
@@ -12164,8 +12856,8 @@
         </p:nvSpPr>
         <p:spPr>
           <a:xfrm>
-            <a:off x="658368" y="3529584"/>
-            <a:ext cx="310896" cy="310896"/>
+            <a:off x="658368" y="3218688"/>
+            <a:ext cx="292608" cy="292608"/>
           </a:xfrm>
           <a:prstGeom prst="rect">
             <a:avLst/>
@@ -12203,8 +12895,8 @@
         </p:nvSpPr>
         <p:spPr>
           <a:xfrm>
-            <a:off x="1078992" y="3493008"/>
-            <a:ext cx="3840480" cy="256032"/>
+            <a:off x="1060704" y="3163824"/>
+            <a:ext cx="3840480" cy="237744"/>
           </a:xfrm>
           <a:prstGeom prst="rect">
             <a:avLst/>
@@ -12242,8 +12934,8 @@
         </p:nvSpPr>
         <p:spPr>
           <a:xfrm>
-            <a:off x="1078992" y="3785616"/>
-            <a:ext cx="3840480" cy="402336"/>
+            <a:off x="1060704" y="3438144"/>
+            <a:ext cx="3840480" cy="384048"/>
           </a:xfrm>
           <a:prstGeom prst="rect">
             <a:avLst/>
@@ -12285,11 +12977,11 @@
         <p:spPr>
           <a:xfrm>
             <a:off x="5358384" y="1133856"/>
-            <a:ext cx="3328416" cy="2743200"/>
+            <a:ext cx="3328416" cy="2157984"/>
           </a:xfrm>
           <a:prstGeom prst="roundRect">
             <a:avLst>
-              <a:gd name="adj" fmla="val 1333"/>
+              <a:gd name="adj" fmla="val 1695"/>
             </a:avLst>
           </a:prstGeom>
           <a:solidFill>
@@ -12370,7 +13062,7 @@
         </p:nvSpPr>
         <p:spPr>
           <a:xfrm>
-            <a:off x="5541264" y="1627632"/>
+            <a:off x="5541264" y="1554480"/>
             <a:ext cx="310896" cy="310896"/>
           </a:xfrm>
           <a:prstGeom prst="roundRect">
@@ -12392,7 +13084,7 @@
         </p:nvSpPr>
         <p:spPr>
           <a:xfrm>
-            <a:off x="5541264" y="1627632"/>
+            <a:off x="5541264" y="1554480"/>
             <a:ext cx="310896" cy="310896"/>
           </a:xfrm>
           <a:prstGeom prst="rect">
@@ -12431,7 +13123,7 @@
         </p:nvSpPr>
         <p:spPr>
           <a:xfrm>
-            <a:off x="5961888" y="1609344"/>
+            <a:off x="5961888" y="1536192"/>
             <a:ext cx="2560320" cy="201168"/>
           </a:xfrm>
           <a:prstGeom prst="rect">
@@ -12470,7 +13162,7 @@
         </p:nvSpPr>
         <p:spPr>
           <a:xfrm>
-            <a:off x="5961888" y="1792224"/>
+            <a:off x="5961888" y="1719072"/>
             <a:ext cx="2560320" cy="182880"/>
           </a:xfrm>
           <a:prstGeom prst="rect">
@@ -12509,7 +13201,7 @@
         </p:nvSpPr>
         <p:spPr>
           <a:xfrm>
-            <a:off x="5541264" y="2139696"/>
+            <a:off x="5541264" y="2011680"/>
             <a:ext cx="310896" cy="310896"/>
           </a:xfrm>
           <a:prstGeom prst="roundRect">
@@ -12531,7 +13223,7 @@
         </p:nvSpPr>
         <p:spPr>
           <a:xfrm>
-            <a:off x="5541264" y="2139696"/>
+            <a:off x="5541264" y="2011680"/>
             <a:ext cx="310896" cy="310896"/>
           </a:xfrm>
           <a:prstGeom prst="rect">
@@ -12570,7 +13262,7 @@
         </p:nvSpPr>
         <p:spPr>
           <a:xfrm>
-            <a:off x="5961888" y="2121408"/>
+            <a:off x="5961888" y="1993392"/>
             <a:ext cx="2560320" cy="201168"/>
           </a:xfrm>
           <a:prstGeom prst="rect">
@@ -12609,7 +13301,7 @@
         </p:nvSpPr>
         <p:spPr>
           <a:xfrm>
-            <a:off x="5961888" y="2304288"/>
+            <a:off x="5961888" y="2176272"/>
             <a:ext cx="2560320" cy="182880"/>
           </a:xfrm>
           <a:prstGeom prst="rect">
@@ -12648,7 +13340,7 @@
         </p:nvSpPr>
         <p:spPr>
           <a:xfrm>
-            <a:off x="5541264" y="2651760"/>
+            <a:off x="5541264" y="2468880"/>
             <a:ext cx="310896" cy="310896"/>
           </a:xfrm>
           <a:prstGeom prst="roundRect">
@@ -12670,7 +13362,7 @@
         </p:nvSpPr>
         <p:spPr>
           <a:xfrm>
-            <a:off x="5541264" y="2651760"/>
+            <a:off x="5541264" y="2468880"/>
             <a:ext cx="310896" cy="310896"/>
           </a:xfrm>
           <a:prstGeom prst="rect">
@@ -12709,8 +13401,47 @@
         </p:nvSpPr>
         <p:spPr>
           <a:xfrm>
+            <a:off x="5961888" y="2450592"/>
+            <a:ext cx="2560320" cy="201168"/>
+          </a:xfrm>
+          <a:prstGeom prst="rect">
+            <a:avLst/>
+          </a:prstGeom>
+          <a:noFill/>
+          <a:ln/>
+        </p:spPr>
+        <p:txBody>
+          <a:bodyPr wrap="square" lIns="0" tIns="0" rIns="0" bIns="0" rtlCol="0" anchor="ctr"/>
+          <a:lstStyle/>
+          <a:p>
+            <a:pPr indent="0" marL="0">
+              <a:buNone/>
+            </a:pPr>
+            <a:r>
+              <a:rPr lang="en-US" sz="1050" b="1" dirty="0">
+                <a:solidFill>
+                  <a:srgbClr val="21295C"/>
+                </a:solidFill>
+                <a:latin typeface="Calibri" pitchFamily="34" charset="0"/>
+                <a:ea typeface="Calibri" pitchFamily="34" charset="-122"/>
+                <a:cs typeface="Calibri" pitchFamily="34" charset="-120"/>
+              </a:rPr>
+              <a:t>Consulted</a:t>
+            </a:r>
+            <a:endParaRPr lang="en-US" sz="1050" dirty="0"/>
+          </a:p>
+        </p:txBody>
+      </p:sp>
+      <p:sp>
+        <p:nvSpPr>
+          <p:cNvPr id="38" name="Text 36"/>
+          <p:cNvSpPr/>
+          <p:nvPr/>
+        </p:nvSpPr>
+        <p:spPr>
+          <a:xfrm>
             <a:off x="5961888" y="2633472"/>
-            <a:ext cx="2560320" cy="201168"/>
+            <a:ext cx="2560320" cy="182880"/>
           </a:xfrm>
           <a:prstGeom prst="rect">
             <a:avLst/>
@@ -12726,45 +13457,6 @@
               <a:buNone/>
             </a:pPr>
             <a:r>
-              <a:rPr lang="en-US" sz="1050" b="1" dirty="0">
-                <a:solidFill>
-                  <a:srgbClr val="21295C"/>
-                </a:solidFill>
-                <a:latin typeface="Calibri" pitchFamily="34" charset="0"/>
-                <a:ea typeface="Calibri" pitchFamily="34" charset="-122"/>
-                <a:cs typeface="Calibri" pitchFamily="34" charset="-120"/>
-              </a:rPr>
-              <a:t>Consulted</a:t>
-            </a:r>
-            <a:endParaRPr lang="en-US" sz="1050" dirty="0"/>
-          </a:p>
-        </p:txBody>
-      </p:sp>
-      <p:sp>
-        <p:nvSpPr>
-          <p:cNvPr id="38" name="Text 36"/>
-          <p:cNvSpPr/>
-          <p:nvPr/>
-        </p:nvSpPr>
-        <p:spPr>
-          <a:xfrm>
-            <a:off x="5961888" y="2816352"/>
-            <a:ext cx="2560320" cy="182880"/>
-          </a:xfrm>
-          <a:prstGeom prst="rect">
-            <a:avLst/>
-          </a:prstGeom>
-          <a:noFill/>
-          <a:ln/>
-        </p:spPr>
-        <p:txBody>
-          <a:bodyPr wrap="square" lIns="0" tIns="0" rIns="0" bIns="0" rtlCol="0" anchor="ctr"/>
-          <a:lstStyle/>
-          <a:p>
-            <a:pPr indent="0" marL="0">
-              <a:buNone/>
-            </a:pPr>
-            <a:r>
               <a:rPr lang="en-US" sz="850" dirty="0">
                 <a:solidFill>
                   <a:srgbClr val="5A6B7C"/>
@@ -12787,7 +13479,7 @@
         </p:nvSpPr>
         <p:spPr>
           <a:xfrm>
-            <a:off x="5541264" y="3163824"/>
+            <a:off x="5541264" y="2926080"/>
             <a:ext cx="310896" cy="310896"/>
           </a:xfrm>
           <a:prstGeom prst="roundRect">
@@ -12809,7 +13501,7 @@
         </p:nvSpPr>
         <p:spPr>
           <a:xfrm>
-            <a:off x="5541264" y="3163824"/>
+            <a:off x="5541264" y="2926080"/>
             <a:ext cx="310896" cy="310896"/>
           </a:xfrm>
           <a:prstGeom prst="rect">
@@ -12848,7 +13540,7 @@
         </p:nvSpPr>
         <p:spPr>
           <a:xfrm>
-            <a:off x="5961888" y="3145536"/>
+            <a:off x="5961888" y="2907792"/>
             <a:ext cx="2560320" cy="201168"/>
           </a:xfrm>
           <a:prstGeom prst="rect">
@@ -12887,7 +13579,7 @@
         </p:nvSpPr>
         <p:spPr>
           <a:xfrm>
-            <a:off x="5961888" y="3328416"/>
+            <a:off x="5961888" y="3090672"/>
             <a:ext cx="2560320" cy="182880"/>
           </a:xfrm>
           <a:prstGeom prst="rect">
@@ -12921,6 +13613,245 @@
       <p:sp>
         <p:nvSpPr>
           <p:cNvPr id="43" name="Shape 41"/>
+          <p:cNvSpPr/>
+          <p:nvPr/>
+        </p:nvSpPr>
+        <p:spPr>
+          <a:xfrm>
+            <a:off x="5358384" y="3401568"/>
+            <a:ext cx="3328416" cy="310896"/>
+          </a:xfrm>
+          <a:prstGeom prst="roundRect">
+            <a:avLst>
+              <a:gd name="adj" fmla="val 11765"/>
+            </a:avLst>
+          </a:prstGeom>
+          <a:solidFill>
+            <a:srgbClr val="FFF7E6"/>
+          </a:solidFill>
+          <a:ln w="12700">
+            <a:solidFill>
+              <a:srgbClr val="B8860B"/>
+            </a:solidFill>
+            <a:prstDash val="solid"/>
+          </a:ln>
+        </p:spPr>
+      </p:sp>
+      <p:sp>
+        <p:nvSpPr>
+          <p:cNvPr id="44" name="Text 42"/>
+          <p:cNvSpPr/>
+          <p:nvPr/>
+        </p:nvSpPr>
+        <p:spPr>
+          <a:xfrm>
+            <a:off x="5358384" y="3401568"/>
+            <a:ext cx="3328416" cy="310896"/>
+          </a:xfrm>
+          <a:prstGeom prst="rect">
+            <a:avLst/>
+          </a:prstGeom>
+          <a:noFill/>
+          <a:ln/>
+        </p:spPr>
+        <p:txBody>
+          <a:bodyPr wrap="square" lIns="0" tIns="0" rIns="0" bIns="0" rtlCol="0" anchor="ctr"/>
+          <a:lstStyle/>
+          <a:p>
+            <a:pPr algn="ctr" indent="0" marL="0">
+              <a:buNone/>
+            </a:pPr>
+            <a:r>
+              <a:rPr lang="en-US" sz="1000" b="1" dirty="0">
+                <a:solidFill>
+                  <a:srgbClr val="B8860B"/>
+                </a:solidFill>
+                <a:latin typeface="Calibri" pitchFamily="34" charset="0"/>
+                <a:ea typeface="Calibri" pitchFamily="34" charset="-122"/>
+                <a:cs typeface="Calibri" pitchFamily="34" charset="-120"/>
+              </a:rPr>
+              <a:t>※ RACI 매트릭스는 웹버전에서 처리</a:t>
+            </a:r>
+            <a:endParaRPr lang="en-US" sz="1000" dirty="0"/>
+          </a:p>
+        </p:txBody>
+      </p:sp>
+      <p:sp>
+        <p:nvSpPr>
+          <p:cNvPr id="45" name="Shape 43"/>
+          <p:cNvSpPr/>
+          <p:nvPr/>
+        </p:nvSpPr>
+        <p:spPr>
+          <a:xfrm>
+            <a:off x="457200" y="4114800"/>
+            <a:ext cx="8229600" cy="329184"/>
+          </a:xfrm>
+          <a:prstGeom prst="roundRect">
+            <a:avLst>
+              <a:gd name="adj" fmla="val 13889"/>
+            </a:avLst>
+          </a:prstGeom>
+          <a:solidFill>
+            <a:srgbClr val="FAFBFC"/>
+          </a:solidFill>
+          <a:ln w="12700">
+            <a:solidFill>
+              <a:srgbClr val="0B4F6C"/>
+            </a:solidFill>
+            <a:prstDash val="solid"/>
+          </a:ln>
+        </p:spPr>
+      </p:sp>
+      <p:sp>
+        <p:nvSpPr>
+          <p:cNvPr id="46" name="Shape 44"/>
+          <p:cNvSpPr/>
+          <p:nvPr/>
+        </p:nvSpPr>
+        <p:spPr>
+          <a:xfrm>
+            <a:off x="457200" y="4114800"/>
+            <a:ext cx="45720" cy="329184"/>
+          </a:xfrm>
+          <a:prstGeom prst="rect">
+            <a:avLst/>
+          </a:prstGeom>
+          <a:solidFill>
+            <a:srgbClr val="0B4F6C"/>
+          </a:solidFill>
+          <a:ln/>
+        </p:spPr>
+      </p:sp>
+      <p:sp>
+        <p:nvSpPr>
+          <p:cNvPr id="47" name="Text 45"/>
+          <p:cNvSpPr/>
+          <p:nvPr/>
+        </p:nvSpPr>
+        <p:spPr>
+          <a:xfrm>
+            <a:off x="603504" y="4114800"/>
+            <a:ext cx="310896" cy="329184"/>
+          </a:xfrm>
+          <a:prstGeom prst="rect">
+            <a:avLst/>
+          </a:prstGeom>
+          <a:noFill/>
+          <a:ln/>
+        </p:spPr>
+        <p:txBody>
+          <a:bodyPr wrap="square" lIns="0" tIns="0" rIns="0" bIns="0" rtlCol="0" anchor="ctr"/>
+          <a:lstStyle/>
+          <a:p>
+            <a:pPr algn="ctr" indent="0" marL="0">
+              <a:buNone/>
+            </a:pPr>
+            <a:r>
+              <a:rPr lang="en-US" sz="1200" dirty="0">
+                <a:solidFill>
+                  <a:srgbClr val="000000"/>
+                </a:solidFill>
+                <a:latin typeface="Calibri" pitchFamily="34" charset="0"/>
+                <a:ea typeface="Calibri" pitchFamily="34" charset="-122"/>
+                <a:cs typeface="Calibri" pitchFamily="34" charset="-120"/>
+              </a:rPr>
+              <a:t>🔗</a:t>
+            </a:r>
+            <a:endParaRPr lang="en-US" sz="1200" dirty="0"/>
+          </a:p>
+        </p:txBody>
+      </p:sp>
+      <p:sp>
+        <p:nvSpPr>
+          <p:cNvPr id="48" name="Text 46"/>
+          <p:cNvSpPr/>
+          <p:nvPr/>
+        </p:nvSpPr>
+        <p:spPr>
+          <a:xfrm>
+            <a:off x="932688" y="4114800"/>
+            <a:ext cx="3200400" cy="329184"/>
+          </a:xfrm>
+          <a:prstGeom prst="rect">
+            <a:avLst/>
+          </a:prstGeom>
+          <a:noFill/>
+          <a:ln/>
+        </p:spPr>
+        <p:txBody>
+          <a:bodyPr wrap="square" lIns="0" tIns="0" rIns="0" bIns="0" rtlCol="0" anchor="ctr"/>
+          <a:lstStyle/>
+          <a:p>
+            <a:pPr indent="0" marL="0">
+              <a:buNone/>
+            </a:pPr>
+            <a:r>
+              <a:rPr lang="en-US" sz="1000" b="1" dirty="0">
+                <a:solidFill>
+                  <a:srgbClr val="0B4F6C"/>
+                </a:solidFill>
+                <a:latin typeface="Calibri" pitchFamily="34" charset="0"/>
+                <a:ea typeface="Calibri" pitchFamily="34" charset="-122"/>
+                <a:cs typeface="Calibri" pitchFamily="34" charset="-120"/>
+              </a:rPr>
+              <a:t>실행계획서 웹버전 — RACI 매트릭스 작성</a:t>
+            </a:r>
+            <a:endParaRPr lang="en-US" sz="1000" dirty="0"/>
+          </a:p>
+        </p:txBody>
+      </p:sp>
+      <p:sp>
+        <p:nvSpPr>
+          <p:cNvPr id="49" name="Text 47">
+            <a:hlinkClick r:id="rId1" tooltip=""/>
+          </p:cNvPr>
+          <p:cNvSpPr/>
+          <p:nvPr/>
+        </p:nvSpPr>
+        <p:spPr>
+          <a:xfrm>
+            <a:off x="4169664" y="4114800"/>
+            <a:ext cx="4389120" cy="329184"/>
+          </a:xfrm>
+          <a:prstGeom prst="rect">
+            <a:avLst/>
+          </a:prstGeom>
+          <a:noFill/>
+          <a:ln/>
+        </p:spPr>
+        <p:txBody>
+          <a:bodyPr wrap="square" lIns="0" tIns="0" rIns="0" bIns="0" rtlCol="0" anchor="ctr"/>
+          <a:lstStyle/>
+          <a:p>
+            <a:pPr indent="0" marL="0">
+              <a:buNone/>
+            </a:pPr>
+            <a:r>
+              <a:rPr lang="en-US" sz="950" u="sng" dirty="0">
+                <a:solidFill>
+                  <a:srgbClr val="5A6B7C"/>
+                </a:solidFill>
+                <a:latin typeface="Calibri" pitchFamily="34" charset="0"/>
+                <a:ea typeface="Calibri" pitchFamily="34" charset="-122"/>
+                <a:cs typeface="Calibri" pitchFamily="34" charset="-120"/>
+                <a:hlinkClick r:id="rId1" invalidUrl="" action="" tgtFrame="" tooltip="" history="1" highlightClick="0" endSnd="0">
+                  <a:extLst>
+                    <a:ext uri="{A12FA001-AC4F-418D-AE19-62706E023703}">
+                      <ahyp:hlinkClr xmlns:ahyp="http://schemas.microsoft.com/office/drawing/2018/hyperlinkcolor" val="tx"/>
+                    </a:ext>
+                  </a:extLst>
+                </a:hlinkClick>
+              </a:rPr>
+              <a:t>https://insys-hq.github.io/Insys-review/action_plan.html</a:t>
+            </a:r>
+            <a:endParaRPr lang="en-US" sz="950" dirty="0"/>
+          </a:p>
+        </p:txBody>
+      </p:sp>
+      <p:sp>
+        <p:nvSpPr>
+          <p:cNvPr id="50" name="Shape 48"/>
           <p:cNvSpPr/>
           <p:nvPr/>
         </p:nvSpPr>
@@ -12940,7 +13871,7 @@
       </p:sp>
       <p:sp>
         <p:nvSpPr>
-          <p:cNvPr id="44" name="Text 42"/>
+          <p:cNvPr id="51" name="Text 49"/>
           <p:cNvSpPr/>
           <p:nvPr/>
         </p:nvSpPr>
@@ -12971,7 +13902,7 @@
                 <a:ea typeface="Calibri" pitchFamily="34" charset="-122"/>
                 <a:cs typeface="Calibri" pitchFamily="34" charset="-120"/>
               </a:rPr>
-              <a:t>㈜인시스  ·  셰플러 이천공장 수입검사 실행계획서 v4.1</a:t>
+              <a:t>㈜인시스  ·  셰플러 이천공장 수입검사 실행계획서 v4.4</a:t>
             </a:r>
             <a:endParaRPr lang="en-US" sz="800" dirty="0"/>
           </a:p>
@@ -12979,7 +13910,7 @@
       </p:sp>
       <p:sp>
         <p:nvSpPr>
-          <p:cNvPr id="45" name="Text 43"/>
+          <p:cNvPr id="52" name="Text 50"/>
           <p:cNvSpPr/>
           <p:nvPr/>
         </p:nvSpPr>
@@ -14138,7 +15069,7 @@
                 <a:ea typeface="Calibri" pitchFamily="34" charset="-122"/>
                 <a:cs typeface="Calibri" pitchFamily="34" charset="-120"/>
               </a:rPr>
-              <a:t>㈜인시스  ·  셰플러 이천공장 수입검사 실행계획서 v4.1</a:t>
+              <a:t>㈜인시스  ·  셰플러 이천공장 수입검사 실행계획서 v4.4</a:t>
             </a:r>
             <a:endParaRPr lang="en-US" sz="800" dirty="0"/>
           </a:p>
@@ -14726,7 +15657,7 @@
                 <a:ea typeface="Calibri" pitchFamily="34" charset="-122"/>
                 <a:cs typeface="Calibri" pitchFamily="34" charset="-120"/>
               </a:rPr>
-              <a:t>성적서 확인</a:t>
+              <a:t>기준서 확인</a:t>
             </a:r>
             <a:endParaRPr lang="en-US" sz="1050" dirty="0"/>
           </a:p>
@@ -14768,7 +15699,7 @@
                 <a:ea typeface="Calibri" pitchFamily="34" charset="-122"/>
                 <a:cs typeface="Calibri" pitchFamily="34" charset="-120"/>
               </a:rPr>
-              <a:t>SAP 유무·내용 검토</a:t>
+              <a:t>주기 도래 시 실시</a:t>
             </a:r>
             <a:endParaRPr lang="en-US" sz="800" dirty="0"/>
           </a:p>
@@ -14918,7 +15849,7 @@
                 <a:ea typeface="Calibri" pitchFamily="34" charset="-122"/>
                 <a:cs typeface="Calibri" pitchFamily="34" charset="-120"/>
               </a:rPr>
-              <a:t>기준서 확인</a:t>
+              <a:t>품목 선택</a:t>
             </a:r>
             <a:endParaRPr lang="en-US" sz="1050" dirty="0"/>
           </a:p>
@@ -14960,7 +15891,7 @@
                 <a:ea typeface="Calibri" pitchFamily="34" charset="-122"/>
                 <a:cs typeface="Calibri" pitchFamily="34" charset="-120"/>
               </a:rPr>
-              <a:t>주기 도래 시 실시</a:t>
+              <a:t>등록 품목 드롭다운</a:t>
             </a:r>
             <a:endParaRPr lang="en-US" sz="800" dirty="0"/>
           </a:p>
@@ -16191,7 +17122,7 @@
                 <a:ea typeface="Calibri" pitchFamily="34" charset="-122"/>
                 <a:cs typeface="Calibri" pitchFamily="34" charset="-120"/>
               </a:rPr>
-              <a:t>㈜인시스  ·  셰플러 이천공장 수입검사 실행계획서 v4.1</a:t>
+              <a:t>㈜인시스  ·  셰플러 이천공장 수입검사 실행계획서 v4.4</a:t>
             </a:r>
             <a:endParaRPr lang="en-US" sz="800" dirty="0"/>
           </a:p>
@@ -17758,7 +18689,7 @@
                 <a:ea typeface="Calibri" pitchFamily="34" charset="-122"/>
                 <a:cs typeface="Calibri" pitchFamily="34" charset="-120"/>
               </a:rPr>
-              <a:t>㈜인시스  ·  셰플러 이천공장 수입검사 실행계획서 v4.1</a:t>
+              <a:t>㈜인시스  ·  셰플러 이천공장 수입검사 실행계획서 v4.4</a:t>
             </a:r>
             <a:endParaRPr lang="en-US" sz="800" dirty="0"/>
           </a:p>
@@ -19286,7 +20217,7 @@
                 <a:ea typeface="Calibri" pitchFamily="34" charset="-122"/>
                 <a:cs typeface="Calibri" pitchFamily="34" charset="-120"/>
               </a:rPr>
-              <a:t>㈜인시스  ·  셰플러 이천공장 수입검사 실행계획서 v4.1</a:t>
+              <a:t>㈜인시스  ·  셰플러 이천공장 수입검사 실행계획서 v4.4</a:t>
             </a:r>
             <a:endParaRPr lang="en-US" sz="800" dirty="0"/>
           </a:p>
@@ -20993,7 +21924,7 @@
                 <a:ea typeface="Calibri" pitchFamily="34" charset="-122"/>
                 <a:cs typeface="Calibri" pitchFamily="34" charset="-120"/>
               </a:rPr>
-              <a:t>㈜인시스  ·  셰플러 이천공장 수입검사 실행계획서 v4.1</a:t>
+              <a:t>㈜인시스  ·  셰플러 이천공장 수입검사 실행계획서 v4.4</a:t>
             </a:r>
             <a:endParaRPr lang="en-US" sz="800" dirty="0"/>
           </a:p>
@@ -21443,7 +22374,7 @@
                 <a:ea typeface="Calibri" pitchFamily="34" charset="-122"/>
                 <a:cs typeface="Calibri" pitchFamily="34" charset="-120"/>
               </a:rPr>
-              <a:t>품목·소요시간·성적서 검토·판정</a:t>
+              <a:t>품목 · 외관 · 치수 · 판정</a:t>
             </a:r>
             <a:endParaRPr lang="en-US" sz="850" dirty="0"/>
           </a:p>
@@ -21568,7 +22499,7 @@
                 <a:ea typeface="Calibri" pitchFamily="34" charset="-122"/>
                 <a:cs typeface="Calibri" pitchFamily="34" charset="-120"/>
               </a:rPr>
-              <a:t>의뢰 내용·소요시간·결과</a:t>
+              <a:t>의뢰 내용 (결과는 검사 시 입력)</a:t>
             </a:r>
             <a:endParaRPr lang="en-US" sz="850" dirty="0"/>
           </a:p>
@@ -22028,7 +22959,7 @@
                 <a:ea typeface="Calibri" pitchFamily="34" charset="-122"/>
                 <a:cs typeface="Calibri" pitchFamily="34" charset="-120"/>
               </a:rPr>
-              <a:t>건수·소요시간·합격률</a:t>
+              <a:t>검사 건수 · 합격률</a:t>
             </a:r>
             <a:endParaRPr lang="en-US" sz="820" dirty="0"/>
           </a:p>
@@ -22252,12 +23183,12 @@
         </p:nvSpPr>
         <p:spPr>
           <a:xfrm>
-            <a:off x="457200" y="3602736"/>
-            <a:ext cx="8229600" cy="640080"/>
+            <a:off x="457200" y="3529584"/>
+            <a:ext cx="8229600" cy="585216"/>
           </a:xfrm>
           <a:prstGeom prst="roundRect">
             <a:avLst>
-              <a:gd name="adj" fmla="val 5714"/>
+              <a:gd name="adj" fmla="val 6250"/>
             </a:avLst>
           </a:prstGeom>
           <a:solidFill>
@@ -22279,7 +23210,7 @@
         </p:nvSpPr>
         <p:spPr>
           <a:xfrm>
-            <a:off x="658368" y="3721608"/>
+            <a:off x="658368" y="3630168"/>
             <a:ext cx="45720" cy="219456"/>
           </a:xfrm>
           <a:prstGeom prst="rect">
@@ -22299,7 +23230,7 @@
         </p:nvSpPr>
         <p:spPr>
           <a:xfrm>
-            <a:off x="786384" y="3694176"/>
+            <a:off x="786384" y="3602736"/>
             <a:ext cx="2615184" cy="274320"/>
           </a:xfrm>
           <a:prstGeom prst="rect">
@@ -22338,7 +23269,7 @@
         </p:nvSpPr>
         <p:spPr>
           <a:xfrm>
-            <a:off x="658368" y="3950208"/>
+            <a:off x="658368" y="3840480"/>
             <a:ext cx="7863840" cy="237744"/>
           </a:xfrm>
           <a:prstGeom prst="rect">
@@ -22372,6 +23303,179 @@
       <p:sp>
         <p:nvSpPr>
           <p:cNvPr id="43" name="Shape 41"/>
+          <p:cNvSpPr/>
+          <p:nvPr/>
+        </p:nvSpPr>
+        <p:spPr>
+          <a:xfrm>
+            <a:off x="457200" y="4133088"/>
+            <a:ext cx="8229600" cy="329184"/>
+          </a:xfrm>
+          <a:prstGeom prst="roundRect">
+            <a:avLst>
+              <a:gd name="adj" fmla="val 13889"/>
+            </a:avLst>
+          </a:prstGeom>
+          <a:solidFill>
+            <a:srgbClr val="FAFBFC"/>
+          </a:solidFill>
+          <a:ln w="12700">
+            <a:solidFill>
+              <a:srgbClr val="1C7293"/>
+            </a:solidFill>
+            <a:prstDash val="solid"/>
+          </a:ln>
+        </p:spPr>
+      </p:sp>
+      <p:sp>
+        <p:nvSpPr>
+          <p:cNvPr id="44" name="Shape 42"/>
+          <p:cNvSpPr/>
+          <p:nvPr/>
+        </p:nvSpPr>
+        <p:spPr>
+          <a:xfrm>
+            <a:off x="457200" y="4133088"/>
+            <a:ext cx="45720" cy="329184"/>
+          </a:xfrm>
+          <a:prstGeom prst="rect">
+            <a:avLst/>
+          </a:prstGeom>
+          <a:solidFill>
+            <a:srgbClr val="1C7293"/>
+          </a:solidFill>
+          <a:ln/>
+        </p:spPr>
+      </p:sp>
+      <p:sp>
+        <p:nvSpPr>
+          <p:cNvPr id="45" name="Text 43"/>
+          <p:cNvSpPr/>
+          <p:nvPr/>
+        </p:nvSpPr>
+        <p:spPr>
+          <a:xfrm>
+            <a:off x="603504" y="4133088"/>
+            <a:ext cx="310896" cy="329184"/>
+          </a:xfrm>
+          <a:prstGeom prst="rect">
+            <a:avLst/>
+          </a:prstGeom>
+          <a:noFill/>
+          <a:ln/>
+        </p:spPr>
+        <p:txBody>
+          <a:bodyPr wrap="square" lIns="0" tIns="0" rIns="0" bIns="0" rtlCol="0" anchor="ctr"/>
+          <a:lstStyle/>
+          <a:p>
+            <a:pPr algn="ctr" indent="0" marL="0">
+              <a:buNone/>
+            </a:pPr>
+            <a:r>
+              <a:rPr lang="en-US" sz="1200" dirty="0">
+                <a:solidFill>
+                  <a:srgbClr val="000000"/>
+                </a:solidFill>
+                <a:latin typeface="Calibri" pitchFamily="34" charset="0"/>
+                <a:ea typeface="Calibri" pitchFamily="34" charset="-122"/>
+                <a:cs typeface="Calibri" pitchFamily="34" charset="-120"/>
+              </a:rPr>
+              <a:t>🔗</a:t>
+            </a:r>
+            <a:endParaRPr lang="en-US" sz="1200" dirty="0"/>
+          </a:p>
+        </p:txBody>
+      </p:sp>
+      <p:sp>
+        <p:nvSpPr>
+          <p:cNvPr id="46" name="Text 44"/>
+          <p:cNvSpPr/>
+          <p:nvPr/>
+        </p:nvSpPr>
+        <p:spPr>
+          <a:xfrm>
+            <a:off x="932688" y="4133088"/>
+            <a:ext cx="3200400" cy="329184"/>
+          </a:xfrm>
+          <a:prstGeom prst="rect">
+            <a:avLst/>
+          </a:prstGeom>
+          <a:noFill/>
+          <a:ln/>
+        </p:spPr>
+        <p:txBody>
+          <a:bodyPr wrap="square" lIns="0" tIns="0" rIns="0" bIns="0" rtlCol="0" anchor="ctr"/>
+          <a:lstStyle/>
+          <a:p>
+            <a:pPr indent="0" marL="0">
+              <a:buNone/>
+            </a:pPr>
+            <a:r>
+              <a:rPr lang="en-US" sz="1000" b="1" dirty="0">
+                <a:solidFill>
+                  <a:srgbClr val="1C7293"/>
+                </a:solidFill>
+                <a:latin typeface="Calibri" pitchFamily="34" charset="0"/>
+                <a:ea typeface="Calibri" pitchFamily="34" charset="-122"/>
+                <a:cs typeface="Calibri" pitchFamily="34" charset="-120"/>
+              </a:rPr>
+              <a:t>업무관리 시스템 — 일일 업무보고</a:t>
+            </a:r>
+            <a:endParaRPr lang="en-US" sz="1000" dirty="0"/>
+          </a:p>
+        </p:txBody>
+      </p:sp>
+      <p:sp>
+        <p:nvSpPr>
+          <p:cNvPr id="47" name="Text 45">
+            <a:hlinkClick r:id="rId1" tooltip=""/>
+          </p:cNvPr>
+          <p:cNvSpPr/>
+          <p:nvPr/>
+        </p:nvSpPr>
+        <p:spPr>
+          <a:xfrm>
+            <a:off x="4169664" y="4133088"/>
+            <a:ext cx="4389120" cy="329184"/>
+          </a:xfrm>
+          <a:prstGeom prst="rect">
+            <a:avLst/>
+          </a:prstGeom>
+          <a:noFill/>
+          <a:ln/>
+        </p:spPr>
+        <p:txBody>
+          <a:bodyPr wrap="square" lIns="0" tIns="0" rIns="0" bIns="0" rtlCol="0" anchor="ctr"/>
+          <a:lstStyle/>
+          <a:p>
+            <a:pPr indent="0" marL="0">
+              <a:buNone/>
+            </a:pPr>
+            <a:r>
+              <a:rPr lang="en-US" sz="950" u="sng" dirty="0">
+                <a:solidFill>
+                  <a:srgbClr val="5A6B7C"/>
+                </a:solidFill>
+                <a:latin typeface="Calibri" pitchFamily="34" charset="0"/>
+                <a:ea typeface="Calibri" pitchFamily="34" charset="-122"/>
+                <a:cs typeface="Calibri" pitchFamily="34" charset="-120"/>
+                <a:hlinkClick r:id="rId1" invalidUrl="" action="" tgtFrame="" tooltip="" history="1" highlightClick="0" endSnd="0">
+                  <a:extLst>
+                    <a:ext uri="{A12FA001-AC4F-418D-AE19-62706E023703}">
+                      <ahyp:hlinkClr xmlns:ahyp="http://schemas.microsoft.com/office/drawing/2018/hyperlinkcolor" val="tx"/>
+                    </a:ext>
+                  </a:extLst>
+                </a:hlinkClick>
+              </a:rPr>
+              <a:t>https://insys-hq.github.io/Insys-review/ims.html</a:t>
+            </a:r>
+            <a:endParaRPr lang="en-US" sz="950" dirty="0"/>
+          </a:p>
+        </p:txBody>
+      </p:sp>
+      <p:sp>
+        <p:nvSpPr>
+          <p:cNvPr id="48" name="Shape 46"/>
           <p:cNvSpPr/>
           <p:nvPr/>
         </p:nvSpPr>
@@ -22391,7 +23495,7 @@
       </p:sp>
       <p:sp>
         <p:nvSpPr>
-          <p:cNvPr id="44" name="Text 42"/>
+          <p:cNvPr id="49" name="Text 47"/>
           <p:cNvSpPr/>
           <p:nvPr/>
         </p:nvSpPr>
@@ -22422,7 +23526,7 @@
                 <a:ea typeface="Calibri" pitchFamily="34" charset="-122"/>
                 <a:cs typeface="Calibri" pitchFamily="34" charset="-120"/>
               </a:rPr>
-              <a:t>㈜인시스  ·  셰플러 이천공장 수입검사 실행계획서 v4.1</a:t>
+              <a:t>㈜인시스  ·  셰플러 이천공장 수입검사 실행계획서 v4.4</a:t>
             </a:r>
             <a:endParaRPr lang="en-US" sz="800" dirty="0"/>
           </a:p>
@@ -22430,7 +23534,7 @@
       </p:sp>
       <p:sp>
         <p:nvSpPr>
-          <p:cNvPr id="45" name="Text 43"/>
+          <p:cNvPr id="50" name="Text 48"/>
           <p:cNvSpPr/>
           <p:nvPr/>
         </p:nvSpPr>

</xml_diff>

<commit_message>
action_plan.pptx v4.6 - version sync
</commit_message>
<xml_diff>
--- a/action_plan.pptx
+++ b/action_plan.pptx
@@ -2367,7 +2367,7 @@
                 <a:ea typeface="Calibri" pitchFamily="34" charset="-122"/>
                 <a:cs typeface="Calibri" pitchFamily="34" charset="-120"/>
               </a:rPr>
-              <a:t>2026. 08. 05   |   v4.4</a:t>
+              <a:t>2026. 08. 05   |   v4.6</a:t>
             </a:r>
             <a:endParaRPr lang="en-US" sz="1050" dirty="0"/>
           </a:p>
@@ -4444,7 +4444,7 @@
                 <a:ea typeface="Calibri" pitchFamily="34" charset="-122"/>
                 <a:cs typeface="Calibri" pitchFamily="34" charset="-120"/>
               </a:rPr>
-              <a:t>㈜인시스  ·  셰플러 이천공장 수입검사 실행계획서 v4.4</a:t>
+              <a:t>㈜인시스  ·  셰플러 이천공장 수입검사 실행계획서 v4.6</a:t>
             </a:r>
             <a:endParaRPr lang="en-US" sz="800" dirty="0"/>
           </a:p>
@@ -5711,7 +5711,7 @@
                 <a:ea typeface="Calibri" pitchFamily="34" charset="-122"/>
                 <a:cs typeface="Calibri" pitchFamily="34" charset="-120"/>
               </a:rPr>
-              <a:t>㈜인시스  ·  셰플러 이천공장 수입검사 실행계획서 v4.4</a:t>
+              <a:t>㈜인시스  ·  셰플러 이천공장 수입검사 실행계획서 v4.6</a:t>
             </a:r>
             <a:endParaRPr lang="en-US" sz="800" dirty="0"/>
           </a:p>
@@ -7195,7 +7195,7 @@
                 <a:ea typeface="Calibri" pitchFamily="34" charset="-122"/>
                 <a:cs typeface="Calibri" pitchFamily="34" charset="-120"/>
               </a:rPr>
-              <a:t>㈜인시스  ·  셰플러 이천공장 수입검사 실행계획서 v4.4</a:t>
+              <a:t>㈜인시스  ·  셰플러 이천공장 수입검사 실행계획서 v4.6</a:t>
             </a:r>
             <a:endParaRPr lang="en-US" sz="800" dirty="0"/>
           </a:p>
@@ -9836,7 +9836,7 @@
                 <a:ea typeface="Calibri" pitchFamily="34" charset="-122"/>
                 <a:cs typeface="Calibri" pitchFamily="34" charset="-120"/>
               </a:rPr>
-              <a:t>㈜인시스  ·  셰플러 이천공장 수입검사 실행계획서 v4.4</a:t>
+              <a:t>㈜인시스  ·  셰플러 이천공장 수입검사 실행계획서 v4.6</a:t>
             </a:r>
             <a:endParaRPr lang="en-US" sz="800" dirty="0"/>
           </a:p>
@@ -12180,7 +12180,7 @@
                 <a:ea typeface="Calibri" pitchFamily="34" charset="-122"/>
                 <a:cs typeface="Calibri" pitchFamily="34" charset="-120"/>
               </a:rPr>
-              <a:t>㈜인시스  ·  셰플러 이천공장 수입검사 실행계획서 v4.4</a:t>
+              <a:t>㈜인시스  ·  셰플러 이천공장 수입검사 실행계획서 v4.6</a:t>
             </a:r>
             <a:endParaRPr lang="en-US" sz="800" dirty="0"/>
           </a:p>
@@ -13902,7 +13902,7 @@
                 <a:ea typeface="Calibri" pitchFamily="34" charset="-122"/>
                 <a:cs typeface="Calibri" pitchFamily="34" charset="-120"/>
               </a:rPr>
-              <a:t>㈜인시스  ·  셰플러 이천공장 수입검사 실행계획서 v4.4</a:t>
+              <a:t>㈜인시스  ·  셰플러 이천공장 수입검사 실행계획서 v4.6</a:t>
             </a:r>
             <a:endParaRPr lang="en-US" sz="800" dirty="0"/>
           </a:p>
@@ -15069,7 +15069,7 @@
                 <a:ea typeface="Calibri" pitchFamily="34" charset="-122"/>
                 <a:cs typeface="Calibri" pitchFamily="34" charset="-120"/>
               </a:rPr>
-              <a:t>㈜인시스  ·  셰플러 이천공장 수입검사 실행계획서 v4.4</a:t>
+              <a:t>㈜인시스  ·  셰플러 이천공장 수입검사 실행계획서 v4.6</a:t>
             </a:r>
             <a:endParaRPr lang="en-US" sz="800" dirty="0"/>
           </a:p>
@@ -17122,7 +17122,7 @@
                 <a:ea typeface="Calibri" pitchFamily="34" charset="-122"/>
                 <a:cs typeface="Calibri" pitchFamily="34" charset="-120"/>
               </a:rPr>
-              <a:t>㈜인시스  ·  셰플러 이천공장 수입검사 실행계획서 v4.4</a:t>
+              <a:t>㈜인시스  ·  셰플러 이천공장 수입검사 실행계획서 v4.6</a:t>
             </a:r>
             <a:endParaRPr lang="en-US" sz="800" dirty="0"/>
           </a:p>
@@ -18689,7 +18689,7 @@
                 <a:ea typeface="Calibri" pitchFamily="34" charset="-122"/>
                 <a:cs typeface="Calibri" pitchFamily="34" charset="-120"/>
               </a:rPr>
-              <a:t>㈜인시스  ·  셰플러 이천공장 수입검사 실행계획서 v4.4</a:t>
+              <a:t>㈜인시스  ·  셰플러 이천공장 수입검사 실행계획서 v4.6</a:t>
             </a:r>
             <a:endParaRPr lang="en-US" sz="800" dirty="0"/>
           </a:p>
@@ -20217,7 +20217,7 @@
                 <a:ea typeface="Calibri" pitchFamily="34" charset="-122"/>
                 <a:cs typeface="Calibri" pitchFamily="34" charset="-120"/>
               </a:rPr>
-              <a:t>㈜인시스  ·  셰플러 이천공장 수입검사 실행계획서 v4.4</a:t>
+              <a:t>㈜인시스  ·  셰플러 이천공장 수입검사 실행계획서 v4.6</a:t>
             </a:r>
             <a:endParaRPr lang="en-US" sz="800" dirty="0"/>
           </a:p>
@@ -21924,7 +21924,7 @@
                 <a:ea typeface="Calibri" pitchFamily="34" charset="-122"/>
                 <a:cs typeface="Calibri" pitchFamily="34" charset="-120"/>
               </a:rPr>
-              <a:t>㈜인시스  ·  셰플러 이천공장 수입검사 실행계획서 v4.4</a:t>
+              <a:t>㈜인시스  ·  셰플러 이천공장 수입검사 실행계획서 v4.6</a:t>
             </a:r>
             <a:endParaRPr lang="en-US" sz="800" dirty="0"/>
           </a:p>
@@ -23526,7 +23526,7 @@
                 <a:ea typeface="Calibri" pitchFamily="34" charset="-122"/>
                 <a:cs typeface="Calibri" pitchFamily="34" charset="-120"/>
               </a:rPr>
-              <a:t>㈜인시스  ·  셰플러 이천공장 수입검사 실행계획서 v4.4</a:t>
+              <a:t>㈜인시스  ·  셰플러 이천공장 수입검사 실행계획서 v4.6</a:t>
             </a:r>
             <a:endParaRPr lang="en-US" sz="800" dirty="0"/>
           </a:p>

</xml_diff>

<commit_message>
action_plan.pptx v4.6 - keep links only on slides 2-3, update date to 08.07
</commit_message>
<xml_diff>
--- a/action_plan.pptx
+++ b/action_plan.pptx
@@ -2367,7 +2367,7 @@
                 <a:ea typeface="Calibri" pitchFamily="34" charset="-122"/>
                 <a:cs typeface="Calibri" pitchFamily="34" charset="-120"/>
               </a:rPr>
-              <a:t>2026. 08. 05   |   v4.6</a:t>
+              <a:t>2026. 08. 07   |   v4.6</a:t>
             </a:r>
             <a:endParaRPr lang="en-US" sz="1050" dirty="0"/>
           </a:p>
@@ -3718,8 +3718,8 @@
         </p:nvSpPr>
         <p:spPr>
           <a:xfrm>
-            <a:off x="457200" y="3346704"/>
-            <a:ext cx="8229600" cy="347472"/>
+            <a:off x="457200" y="3383280"/>
+            <a:ext cx="8229600" cy="384048"/>
           </a:xfrm>
           <a:prstGeom prst="rect">
             <a:avLst/>
@@ -3738,8 +3738,8 @@
         </p:nvSpPr>
         <p:spPr>
           <a:xfrm>
-            <a:off x="457200" y="3346704"/>
-            <a:ext cx="1554480" cy="347472"/>
+            <a:off x="457200" y="3383280"/>
+            <a:ext cx="1554480" cy="384048"/>
           </a:xfrm>
           <a:prstGeom prst="rect">
             <a:avLst/>
@@ -3777,8 +3777,8 @@
         </p:nvSpPr>
         <p:spPr>
           <a:xfrm>
-            <a:off x="2011680" y="3346704"/>
-            <a:ext cx="3383280" cy="347472"/>
+            <a:off x="2011680" y="3383280"/>
+            <a:ext cx="3383280" cy="384048"/>
           </a:xfrm>
           <a:prstGeom prst="rect">
             <a:avLst/>
@@ -3816,8 +3816,8 @@
         </p:nvSpPr>
         <p:spPr>
           <a:xfrm>
-            <a:off x="5394960" y="3346704"/>
-            <a:ext cx="1554480" cy="347472"/>
+            <a:off x="5394960" y="3383280"/>
+            <a:ext cx="1554480" cy="384048"/>
           </a:xfrm>
           <a:prstGeom prst="rect">
             <a:avLst/>
@@ -3855,8 +3855,8 @@
         </p:nvSpPr>
         <p:spPr>
           <a:xfrm>
-            <a:off x="6949440" y="3346704"/>
-            <a:ext cx="1737360" cy="347472"/>
+            <a:off x="6949440" y="3383280"/>
+            <a:ext cx="1737360" cy="384048"/>
           </a:xfrm>
           <a:prstGeom prst="rect">
             <a:avLst/>
@@ -3894,8 +3894,8 @@
         </p:nvSpPr>
         <p:spPr>
           <a:xfrm>
-            <a:off x="457200" y="3694176"/>
-            <a:ext cx="1554480" cy="347472"/>
+            <a:off x="457200" y="3767328"/>
+            <a:ext cx="1554480" cy="384048"/>
           </a:xfrm>
           <a:prstGeom prst="rect">
             <a:avLst/>
@@ -3933,8 +3933,8 @@
         </p:nvSpPr>
         <p:spPr>
           <a:xfrm>
-            <a:off x="2011680" y="3694176"/>
-            <a:ext cx="3383280" cy="347472"/>
+            <a:off x="2011680" y="3767328"/>
+            <a:ext cx="3383280" cy="384048"/>
           </a:xfrm>
           <a:prstGeom prst="rect">
             <a:avLst/>
@@ -3972,8 +3972,8 @@
         </p:nvSpPr>
         <p:spPr>
           <a:xfrm>
-            <a:off x="5394960" y="3694176"/>
-            <a:ext cx="1554480" cy="347472"/>
+            <a:off x="5394960" y="3767328"/>
+            <a:ext cx="1554480" cy="384048"/>
           </a:xfrm>
           <a:prstGeom prst="rect">
             <a:avLst/>
@@ -4011,8 +4011,8 @@
         </p:nvSpPr>
         <p:spPr>
           <a:xfrm>
-            <a:off x="6949440" y="3694176"/>
-            <a:ext cx="1737360" cy="347472"/>
+            <a:off x="6949440" y="3767328"/>
+            <a:ext cx="1737360" cy="384048"/>
           </a:xfrm>
           <a:prstGeom prst="rect">
             <a:avLst/>
@@ -4050,8 +4050,8 @@
         </p:nvSpPr>
         <p:spPr>
           <a:xfrm>
-            <a:off x="457200" y="4041648"/>
-            <a:ext cx="8229600" cy="347472"/>
+            <a:off x="457200" y="4151376"/>
+            <a:ext cx="8229600" cy="384048"/>
           </a:xfrm>
           <a:prstGeom prst="rect">
             <a:avLst/>
@@ -4070,8 +4070,8 @@
         </p:nvSpPr>
         <p:spPr>
           <a:xfrm>
-            <a:off x="457200" y="4041648"/>
-            <a:ext cx="1554480" cy="347472"/>
+            <a:off x="457200" y="4151376"/>
+            <a:ext cx="1554480" cy="384048"/>
           </a:xfrm>
           <a:prstGeom prst="rect">
             <a:avLst/>
@@ -4109,8 +4109,8 @@
         </p:nvSpPr>
         <p:spPr>
           <a:xfrm>
-            <a:off x="2011680" y="4041648"/>
-            <a:ext cx="3383280" cy="347472"/>
+            <a:off x="2011680" y="4151376"/>
+            <a:ext cx="3383280" cy="384048"/>
           </a:xfrm>
           <a:prstGeom prst="rect">
             <a:avLst/>
@@ -4148,8 +4148,8 @@
         </p:nvSpPr>
         <p:spPr>
           <a:xfrm>
-            <a:off x="5394960" y="4041648"/>
-            <a:ext cx="1554480" cy="347472"/>
+            <a:off x="5394960" y="4151376"/>
+            <a:ext cx="1554480" cy="384048"/>
           </a:xfrm>
           <a:prstGeom prst="rect">
             <a:avLst/>
@@ -4187,8 +4187,8 @@
         </p:nvSpPr>
         <p:spPr>
           <a:xfrm>
-            <a:off x="6949440" y="4041648"/>
-            <a:ext cx="1737360" cy="347472"/>
+            <a:off x="6949440" y="4151376"/>
+            <a:ext cx="1737360" cy="384048"/>
           </a:xfrm>
           <a:prstGeom prst="rect">
             <a:avLst/>
@@ -4221,179 +4221,6 @@
       <p:sp>
         <p:nvSpPr>
           <p:cNvPr id="58" name="Shape 56"/>
-          <p:cNvSpPr/>
-          <p:nvPr/>
-        </p:nvSpPr>
-        <p:spPr>
-          <a:xfrm>
-            <a:off x="457200" y="4279392"/>
-            <a:ext cx="8229600" cy="329184"/>
-          </a:xfrm>
-          <a:prstGeom prst="roundRect">
-            <a:avLst>
-              <a:gd name="adj" fmla="val 13889"/>
-            </a:avLst>
-          </a:prstGeom>
-          <a:solidFill>
-            <a:srgbClr val="FAFBFC"/>
-          </a:solidFill>
-          <a:ln w="12700">
-            <a:solidFill>
-              <a:srgbClr val="1C7293"/>
-            </a:solidFill>
-            <a:prstDash val="solid"/>
-          </a:ln>
-        </p:spPr>
-      </p:sp>
-      <p:sp>
-        <p:nvSpPr>
-          <p:cNvPr id="59" name="Shape 57"/>
-          <p:cNvSpPr/>
-          <p:nvPr/>
-        </p:nvSpPr>
-        <p:spPr>
-          <a:xfrm>
-            <a:off x="457200" y="4279392"/>
-            <a:ext cx="45720" cy="329184"/>
-          </a:xfrm>
-          <a:prstGeom prst="rect">
-            <a:avLst/>
-          </a:prstGeom>
-          <a:solidFill>
-            <a:srgbClr val="1C7293"/>
-          </a:solidFill>
-          <a:ln/>
-        </p:spPr>
-      </p:sp>
-      <p:sp>
-        <p:nvSpPr>
-          <p:cNvPr id="60" name="Text 58"/>
-          <p:cNvSpPr/>
-          <p:nvPr/>
-        </p:nvSpPr>
-        <p:spPr>
-          <a:xfrm>
-            <a:off x="603504" y="4279392"/>
-            <a:ext cx="310896" cy="329184"/>
-          </a:xfrm>
-          <a:prstGeom prst="rect">
-            <a:avLst/>
-          </a:prstGeom>
-          <a:noFill/>
-          <a:ln/>
-        </p:spPr>
-        <p:txBody>
-          <a:bodyPr wrap="square" lIns="0" tIns="0" rIns="0" bIns="0" rtlCol="0" anchor="ctr"/>
-          <a:lstStyle/>
-          <a:p>
-            <a:pPr algn="ctr" indent="0" marL="0">
-              <a:buNone/>
-            </a:pPr>
-            <a:r>
-              <a:rPr lang="en-US" sz="1200" dirty="0">
-                <a:solidFill>
-                  <a:srgbClr val="000000"/>
-                </a:solidFill>
-                <a:latin typeface="Calibri" pitchFamily="34" charset="0"/>
-                <a:ea typeface="Calibri" pitchFamily="34" charset="-122"/>
-                <a:cs typeface="Calibri" pitchFamily="34" charset="-120"/>
-              </a:rPr>
-              <a:t>🔗</a:t>
-            </a:r>
-            <a:endParaRPr lang="en-US" sz="1200" dirty="0"/>
-          </a:p>
-        </p:txBody>
-      </p:sp>
-      <p:sp>
-        <p:nvSpPr>
-          <p:cNvPr id="61" name="Text 59"/>
-          <p:cNvSpPr/>
-          <p:nvPr/>
-        </p:nvSpPr>
-        <p:spPr>
-          <a:xfrm>
-            <a:off x="932688" y="4279392"/>
-            <a:ext cx="3200400" cy="329184"/>
-          </a:xfrm>
-          <a:prstGeom prst="rect">
-            <a:avLst/>
-          </a:prstGeom>
-          <a:noFill/>
-          <a:ln/>
-        </p:spPr>
-        <p:txBody>
-          <a:bodyPr wrap="square" lIns="0" tIns="0" rIns="0" bIns="0" rtlCol="0" anchor="ctr"/>
-          <a:lstStyle/>
-          <a:p>
-            <a:pPr indent="0" marL="0">
-              <a:buNone/>
-            </a:pPr>
-            <a:r>
-              <a:rPr lang="en-US" sz="1000" b="1" dirty="0">
-                <a:solidFill>
-                  <a:srgbClr val="1C7293"/>
-                </a:solidFill>
-                <a:latin typeface="Calibri" pitchFamily="34" charset="0"/>
-                <a:ea typeface="Calibri" pitchFamily="34" charset="-122"/>
-                <a:cs typeface="Calibri" pitchFamily="34" charset="-120"/>
-              </a:rPr>
-              <a:t>업무관리 시스템 — 실시간 현황 조회</a:t>
-            </a:r>
-            <a:endParaRPr lang="en-US" sz="1000" dirty="0"/>
-          </a:p>
-        </p:txBody>
-      </p:sp>
-      <p:sp>
-        <p:nvSpPr>
-          <p:cNvPr id="62" name="Text 60">
-            <a:hlinkClick r:id="rId1" tooltip=""/>
-          </p:cNvPr>
-          <p:cNvSpPr/>
-          <p:nvPr/>
-        </p:nvSpPr>
-        <p:spPr>
-          <a:xfrm>
-            <a:off x="4169664" y="4279392"/>
-            <a:ext cx="4389120" cy="329184"/>
-          </a:xfrm>
-          <a:prstGeom prst="rect">
-            <a:avLst/>
-          </a:prstGeom>
-          <a:noFill/>
-          <a:ln/>
-        </p:spPr>
-        <p:txBody>
-          <a:bodyPr wrap="square" lIns="0" tIns="0" rIns="0" bIns="0" rtlCol="0" anchor="ctr"/>
-          <a:lstStyle/>
-          <a:p>
-            <a:pPr indent="0" marL="0">
-              <a:buNone/>
-            </a:pPr>
-            <a:r>
-              <a:rPr lang="en-US" sz="950" u="sng" dirty="0">
-                <a:solidFill>
-                  <a:srgbClr val="5A6B7C"/>
-                </a:solidFill>
-                <a:latin typeface="Calibri" pitchFamily="34" charset="0"/>
-                <a:ea typeface="Calibri" pitchFamily="34" charset="-122"/>
-                <a:cs typeface="Calibri" pitchFamily="34" charset="-120"/>
-                <a:hlinkClick r:id="rId1" invalidUrl="" action="" tgtFrame="" tooltip="" history="1" highlightClick="0" endSnd="0">
-                  <a:extLst>
-                    <a:ext uri="{A12FA001-AC4F-418D-AE19-62706E023703}">
-                      <ahyp:hlinkClr xmlns:ahyp="http://schemas.microsoft.com/office/drawing/2018/hyperlinkcolor" val="tx"/>
-                    </a:ext>
-                  </a:extLst>
-                </a:hlinkClick>
-              </a:rPr>
-              <a:t>https://insys-hq.github.io/Insys-review/ims.html</a:t>
-            </a:r>
-            <a:endParaRPr lang="en-US" sz="950" dirty="0"/>
-          </a:p>
-        </p:txBody>
-      </p:sp>
-      <p:sp>
-        <p:nvSpPr>
-          <p:cNvPr id="63" name="Shape 61"/>
           <p:cNvSpPr/>
           <p:nvPr/>
         </p:nvSpPr>
@@ -4413,7 +4240,7 @@
       </p:sp>
       <p:sp>
         <p:nvSpPr>
-          <p:cNvPr id="64" name="Text 62"/>
+          <p:cNvPr id="59" name="Text 57"/>
           <p:cNvSpPr/>
           <p:nvPr/>
         </p:nvSpPr>
@@ -4452,7 +4279,7 @@
       </p:sp>
       <p:sp>
         <p:nvSpPr>
-          <p:cNvPr id="65" name="Text 63"/>
+          <p:cNvPr id="60" name="Text 58"/>
           <p:cNvSpPr/>
           <p:nvPr/>
         </p:nvSpPr>
@@ -4724,12 +4551,12 @@
         </p:nvSpPr>
         <p:spPr>
           <a:xfrm>
-            <a:off x="457200" y="1097280"/>
-            <a:ext cx="8229600" cy="548640"/>
+            <a:off x="457200" y="1133856"/>
+            <a:ext cx="8229600" cy="621792"/>
           </a:xfrm>
           <a:prstGeom prst="roundRect">
             <a:avLst>
-              <a:gd name="adj" fmla="val 6667"/>
+              <a:gd name="adj" fmla="val 5882"/>
             </a:avLst>
           </a:prstGeom>
           <a:solidFill>
@@ -4751,7 +4578,7 @@
         </p:nvSpPr>
         <p:spPr>
           <a:xfrm>
-            <a:off x="658368" y="1225296"/>
+            <a:off x="658368" y="1298448"/>
             <a:ext cx="658368" cy="292608"/>
           </a:xfrm>
           <a:prstGeom prst="roundRect">
@@ -4773,7 +4600,7 @@
         </p:nvSpPr>
         <p:spPr>
           <a:xfrm>
-            <a:off x="658368" y="1225296"/>
+            <a:off x="658368" y="1298448"/>
             <a:ext cx="658368" cy="292608"/>
           </a:xfrm>
           <a:prstGeom prst="rect">
@@ -4812,7 +4639,7 @@
         </p:nvSpPr>
         <p:spPr>
           <a:xfrm>
-            <a:off x="1481328" y="1170432"/>
+            <a:off x="1481328" y="1225296"/>
             <a:ext cx="3108960" cy="237744"/>
           </a:xfrm>
           <a:prstGeom prst="rect">
@@ -4851,7 +4678,7 @@
         </p:nvSpPr>
         <p:spPr>
           <a:xfrm>
-            <a:off x="1481328" y="1399032"/>
+            <a:off x="1481328" y="1463040"/>
             <a:ext cx="6949440" cy="219456"/>
           </a:xfrm>
           <a:prstGeom prst="rect">
@@ -4890,12 +4717,12 @@
         </p:nvSpPr>
         <p:spPr>
           <a:xfrm>
-            <a:off x="457200" y="1737360"/>
-            <a:ext cx="8229600" cy="548640"/>
+            <a:off x="457200" y="1847088"/>
+            <a:ext cx="8229600" cy="621792"/>
           </a:xfrm>
           <a:prstGeom prst="roundRect">
             <a:avLst>
-              <a:gd name="adj" fmla="val 6667"/>
+              <a:gd name="adj" fmla="val 5882"/>
             </a:avLst>
           </a:prstGeom>
           <a:solidFill>
@@ -4917,7 +4744,7 @@
         </p:nvSpPr>
         <p:spPr>
           <a:xfrm>
-            <a:off x="658368" y="1865376"/>
+            <a:off x="658368" y="2011680"/>
             <a:ext cx="658368" cy="292608"/>
           </a:xfrm>
           <a:prstGeom prst="roundRect">
@@ -4939,7 +4766,7 @@
         </p:nvSpPr>
         <p:spPr>
           <a:xfrm>
-            <a:off x="658368" y="1865376"/>
+            <a:off x="658368" y="2011680"/>
             <a:ext cx="658368" cy="292608"/>
           </a:xfrm>
           <a:prstGeom prst="rect">
@@ -4978,7 +4805,7 @@
         </p:nvSpPr>
         <p:spPr>
           <a:xfrm>
-            <a:off x="1481328" y="1810512"/>
+            <a:off x="1481328" y="1938528"/>
             <a:ext cx="3108960" cy="237744"/>
           </a:xfrm>
           <a:prstGeom prst="rect">
@@ -5017,7 +4844,7 @@
         </p:nvSpPr>
         <p:spPr>
           <a:xfrm>
-            <a:off x="1481328" y="2039112"/>
+            <a:off x="1481328" y="2176272"/>
             <a:ext cx="6949440" cy="219456"/>
           </a:xfrm>
           <a:prstGeom prst="rect">
@@ -5056,12 +4883,12 @@
         </p:nvSpPr>
         <p:spPr>
           <a:xfrm>
-            <a:off x="457200" y="2377440"/>
-            <a:ext cx="8229600" cy="548640"/>
+            <a:off x="457200" y="2560320"/>
+            <a:ext cx="8229600" cy="621792"/>
           </a:xfrm>
           <a:prstGeom prst="roundRect">
             <a:avLst>
-              <a:gd name="adj" fmla="val 6667"/>
+              <a:gd name="adj" fmla="val 5882"/>
             </a:avLst>
           </a:prstGeom>
           <a:solidFill>
@@ -5083,7 +4910,7 @@
         </p:nvSpPr>
         <p:spPr>
           <a:xfrm>
-            <a:off x="658368" y="2505456"/>
+            <a:off x="658368" y="2724912"/>
             <a:ext cx="658368" cy="292608"/>
           </a:xfrm>
           <a:prstGeom prst="roundRect">
@@ -5105,7 +4932,7 @@
         </p:nvSpPr>
         <p:spPr>
           <a:xfrm>
-            <a:off x="658368" y="2505456"/>
+            <a:off x="658368" y="2724912"/>
             <a:ext cx="658368" cy="292608"/>
           </a:xfrm>
           <a:prstGeom prst="rect">
@@ -5144,7 +4971,7 @@
         </p:nvSpPr>
         <p:spPr>
           <a:xfrm>
-            <a:off x="1481328" y="2450592"/>
+            <a:off x="1481328" y="2651760"/>
             <a:ext cx="3108960" cy="237744"/>
           </a:xfrm>
           <a:prstGeom prst="rect">
@@ -5183,7 +5010,7 @@
         </p:nvSpPr>
         <p:spPr>
           <a:xfrm>
-            <a:off x="1481328" y="2679192"/>
+            <a:off x="1481328" y="2889504"/>
             <a:ext cx="6949440" cy="219456"/>
           </a:xfrm>
           <a:prstGeom prst="rect">
@@ -5222,12 +5049,12 @@
         </p:nvSpPr>
         <p:spPr>
           <a:xfrm>
-            <a:off x="457200" y="3017520"/>
-            <a:ext cx="8229600" cy="548640"/>
+            <a:off x="457200" y="3273552"/>
+            <a:ext cx="8229600" cy="621792"/>
           </a:xfrm>
           <a:prstGeom prst="roundRect">
             <a:avLst>
-              <a:gd name="adj" fmla="val 6667"/>
+              <a:gd name="adj" fmla="val 5882"/>
             </a:avLst>
           </a:prstGeom>
           <a:solidFill>
@@ -5249,7 +5076,7 @@
         </p:nvSpPr>
         <p:spPr>
           <a:xfrm>
-            <a:off x="658368" y="3145536"/>
+            <a:off x="658368" y="3438144"/>
             <a:ext cx="658368" cy="292608"/>
           </a:xfrm>
           <a:prstGeom prst="roundRect">
@@ -5271,7 +5098,7 @@
         </p:nvSpPr>
         <p:spPr>
           <a:xfrm>
-            <a:off x="658368" y="3145536"/>
+            <a:off x="658368" y="3438144"/>
             <a:ext cx="658368" cy="292608"/>
           </a:xfrm>
           <a:prstGeom prst="rect">
@@ -5310,7 +5137,7 @@
         </p:nvSpPr>
         <p:spPr>
           <a:xfrm>
-            <a:off x="1481328" y="3090672"/>
+            <a:off x="1481328" y="3364992"/>
             <a:ext cx="3108960" cy="237744"/>
           </a:xfrm>
           <a:prstGeom prst="rect">
@@ -5349,7 +5176,7 @@
         </p:nvSpPr>
         <p:spPr>
           <a:xfrm>
-            <a:off x="1481328" y="3319272"/>
+            <a:off x="1481328" y="3602736"/>
             <a:ext cx="6949440" cy="219456"/>
           </a:xfrm>
           <a:prstGeom prst="rect">
@@ -5388,12 +5215,12 @@
         </p:nvSpPr>
         <p:spPr>
           <a:xfrm>
-            <a:off x="457200" y="3712464"/>
-            <a:ext cx="8229600" cy="475488"/>
+            <a:off x="457200" y="4041648"/>
+            <a:ext cx="8229600" cy="512064"/>
           </a:xfrm>
           <a:prstGeom prst="roundRect">
             <a:avLst>
-              <a:gd name="adj" fmla="val 7692"/>
+              <a:gd name="adj" fmla="val 7143"/>
             </a:avLst>
           </a:prstGeom>
           <a:solidFill>
@@ -5415,7 +5242,7 @@
         </p:nvSpPr>
         <p:spPr>
           <a:xfrm>
-            <a:off x="658368" y="3758184"/>
+            <a:off x="658368" y="4114800"/>
             <a:ext cx="1645920" cy="219456"/>
           </a:xfrm>
           <a:prstGeom prst="rect">
@@ -5454,7 +5281,7 @@
         </p:nvSpPr>
         <p:spPr>
           <a:xfrm>
-            <a:off x="658368" y="3959352"/>
+            <a:off x="658368" y="4315968"/>
             <a:ext cx="7863840" cy="219456"/>
           </a:xfrm>
           <a:prstGeom prst="rect">
@@ -5488,179 +5315,6 @@
       <p:sp>
         <p:nvSpPr>
           <p:cNvPr id="32" name="Shape 30"/>
-          <p:cNvSpPr/>
-          <p:nvPr/>
-        </p:nvSpPr>
-        <p:spPr>
-          <a:xfrm>
-            <a:off x="457200" y="4297680"/>
-            <a:ext cx="8229600" cy="329184"/>
-          </a:xfrm>
-          <a:prstGeom prst="roundRect">
-            <a:avLst>
-              <a:gd name="adj" fmla="val 13889"/>
-            </a:avLst>
-          </a:prstGeom>
-          <a:solidFill>
-            <a:srgbClr val="FAFBFC"/>
-          </a:solidFill>
-          <a:ln w="12700">
-            <a:solidFill>
-              <a:srgbClr val="1C7293"/>
-            </a:solidFill>
-            <a:prstDash val="solid"/>
-          </a:ln>
-        </p:spPr>
-      </p:sp>
-      <p:sp>
-        <p:nvSpPr>
-          <p:cNvPr id="33" name="Shape 31"/>
-          <p:cNvSpPr/>
-          <p:nvPr/>
-        </p:nvSpPr>
-        <p:spPr>
-          <a:xfrm>
-            <a:off x="457200" y="4297680"/>
-            <a:ext cx="45720" cy="329184"/>
-          </a:xfrm>
-          <a:prstGeom prst="rect">
-            <a:avLst/>
-          </a:prstGeom>
-          <a:solidFill>
-            <a:srgbClr val="1C7293"/>
-          </a:solidFill>
-          <a:ln/>
-        </p:spPr>
-      </p:sp>
-      <p:sp>
-        <p:nvSpPr>
-          <p:cNvPr id="34" name="Text 32"/>
-          <p:cNvSpPr/>
-          <p:nvPr/>
-        </p:nvSpPr>
-        <p:spPr>
-          <a:xfrm>
-            <a:off x="603504" y="4297680"/>
-            <a:ext cx="310896" cy="329184"/>
-          </a:xfrm>
-          <a:prstGeom prst="rect">
-            <a:avLst/>
-          </a:prstGeom>
-          <a:noFill/>
-          <a:ln/>
-        </p:spPr>
-        <p:txBody>
-          <a:bodyPr wrap="square" lIns="0" tIns="0" rIns="0" bIns="0" rtlCol="0" anchor="ctr"/>
-          <a:lstStyle/>
-          <a:p>
-            <a:pPr algn="ctr" indent="0" marL="0">
-              <a:buNone/>
-            </a:pPr>
-            <a:r>
-              <a:rPr lang="en-US" sz="1200" dirty="0">
-                <a:solidFill>
-                  <a:srgbClr val="000000"/>
-                </a:solidFill>
-                <a:latin typeface="Calibri" pitchFamily="34" charset="0"/>
-                <a:ea typeface="Calibri" pitchFamily="34" charset="-122"/>
-                <a:cs typeface="Calibri" pitchFamily="34" charset="-120"/>
-              </a:rPr>
-              <a:t>🔗</a:t>
-            </a:r>
-            <a:endParaRPr lang="en-US" sz="1200" dirty="0"/>
-          </a:p>
-        </p:txBody>
-      </p:sp>
-      <p:sp>
-        <p:nvSpPr>
-          <p:cNvPr id="35" name="Text 33"/>
-          <p:cNvSpPr/>
-          <p:nvPr/>
-        </p:nvSpPr>
-        <p:spPr>
-          <a:xfrm>
-            <a:off x="932688" y="4297680"/>
-            <a:ext cx="3200400" cy="329184"/>
-          </a:xfrm>
-          <a:prstGeom prst="rect">
-            <a:avLst/>
-          </a:prstGeom>
-          <a:noFill/>
-          <a:ln/>
-        </p:spPr>
-        <p:txBody>
-          <a:bodyPr wrap="square" lIns="0" tIns="0" rIns="0" bIns="0" rtlCol="0" anchor="ctr"/>
-          <a:lstStyle/>
-          <a:p>
-            <a:pPr indent="0" marL="0">
-              <a:buNone/>
-            </a:pPr>
-            <a:r>
-              <a:rPr lang="en-US" sz="1000" b="1" dirty="0">
-                <a:solidFill>
-                  <a:srgbClr val="1C7293"/>
-                </a:solidFill>
-                <a:latin typeface="Calibri" pitchFamily="34" charset="0"/>
-                <a:ea typeface="Calibri" pitchFamily="34" charset="-122"/>
-                <a:cs typeface="Calibri" pitchFamily="34" charset="-120"/>
-              </a:rPr>
-              <a:t>업무관리 시스템 접속</a:t>
-            </a:r>
-            <a:endParaRPr lang="en-US" sz="1000" dirty="0"/>
-          </a:p>
-        </p:txBody>
-      </p:sp>
-      <p:sp>
-        <p:nvSpPr>
-          <p:cNvPr id="36" name="Text 34">
-            <a:hlinkClick r:id="rId1" tooltip=""/>
-          </p:cNvPr>
-          <p:cNvSpPr/>
-          <p:nvPr/>
-        </p:nvSpPr>
-        <p:spPr>
-          <a:xfrm>
-            <a:off x="4169664" y="4297680"/>
-            <a:ext cx="4389120" cy="329184"/>
-          </a:xfrm>
-          <a:prstGeom prst="rect">
-            <a:avLst/>
-          </a:prstGeom>
-          <a:noFill/>
-          <a:ln/>
-        </p:spPr>
-        <p:txBody>
-          <a:bodyPr wrap="square" lIns="0" tIns="0" rIns="0" bIns="0" rtlCol="0" anchor="ctr"/>
-          <a:lstStyle/>
-          <a:p>
-            <a:pPr indent="0" marL="0">
-              <a:buNone/>
-            </a:pPr>
-            <a:r>
-              <a:rPr lang="en-US" sz="950" u="sng" dirty="0">
-                <a:solidFill>
-                  <a:srgbClr val="5A6B7C"/>
-                </a:solidFill>
-                <a:latin typeface="Calibri" pitchFamily="34" charset="0"/>
-                <a:ea typeface="Calibri" pitchFamily="34" charset="-122"/>
-                <a:cs typeface="Calibri" pitchFamily="34" charset="-120"/>
-                <a:hlinkClick r:id="rId1" invalidUrl="" action="" tgtFrame="" tooltip="" history="1" highlightClick="0" endSnd="0">
-                  <a:extLst>
-                    <a:ext uri="{A12FA001-AC4F-418D-AE19-62706E023703}">
-                      <ahyp:hlinkClr xmlns:ahyp="http://schemas.microsoft.com/office/drawing/2018/hyperlinkcolor" val="tx"/>
-                    </a:ext>
-                  </a:extLst>
-                </a:hlinkClick>
-              </a:rPr>
-              <a:t>https://insys-hq.github.io/Insys-review/ims.html</a:t>
-            </a:r>
-            <a:endParaRPr lang="en-US" sz="950" dirty="0"/>
-          </a:p>
-        </p:txBody>
-      </p:sp>
-      <p:sp>
-        <p:nvSpPr>
-          <p:cNvPr id="37" name="Shape 35"/>
           <p:cNvSpPr/>
           <p:nvPr/>
         </p:nvSpPr>
@@ -5680,7 +5334,7 @@
       </p:sp>
       <p:sp>
         <p:nvSpPr>
-          <p:cNvPr id="38" name="Text 36"/>
+          <p:cNvPr id="33" name="Text 31"/>
           <p:cNvSpPr/>
           <p:nvPr/>
         </p:nvSpPr>
@@ -5719,7 +5373,7 @@
       </p:sp>
       <p:sp>
         <p:nvSpPr>
-          <p:cNvPr id="39" name="Text 37"/>
+          <p:cNvPr id="34" name="Text 32"/>
           <p:cNvSpPr/>
           <p:nvPr/>
         </p:nvSpPr>
@@ -7645,8 +7299,8 @@
         </p:nvSpPr>
         <p:spPr>
           <a:xfrm>
-            <a:off x="457200" y="1481328"/>
-            <a:ext cx="8229600" cy="347472"/>
+            <a:off x="457200" y="1499616"/>
+            <a:ext cx="8229600" cy="393192"/>
           </a:xfrm>
           <a:prstGeom prst="rect">
             <a:avLst/>
@@ -7665,8 +7319,8 @@
         </p:nvSpPr>
         <p:spPr>
           <a:xfrm>
-            <a:off x="457200" y="1481328"/>
-            <a:ext cx="475488" cy="347472"/>
+            <a:off x="457200" y="1499616"/>
+            <a:ext cx="475488" cy="393192"/>
           </a:xfrm>
           <a:prstGeom prst="rect">
             <a:avLst/>
@@ -7704,8 +7358,8 @@
         </p:nvSpPr>
         <p:spPr>
           <a:xfrm>
-            <a:off x="987552" y="1481328"/>
-            <a:ext cx="2523744" cy="347472"/>
+            <a:off x="987552" y="1499616"/>
+            <a:ext cx="2523744" cy="393192"/>
           </a:xfrm>
           <a:prstGeom prst="rect">
             <a:avLst/>
@@ -7743,8 +7397,8 @@
         </p:nvSpPr>
         <p:spPr>
           <a:xfrm>
-            <a:off x="3566160" y="1481328"/>
-            <a:ext cx="2011680" cy="347472"/>
+            <a:off x="3566160" y="1499616"/>
+            <a:ext cx="2011680" cy="393192"/>
           </a:xfrm>
           <a:prstGeom prst="rect">
             <a:avLst/>
@@ -7782,8 +7436,8 @@
         </p:nvSpPr>
         <p:spPr>
           <a:xfrm>
-            <a:off x="5632704" y="1481328"/>
-            <a:ext cx="1207008" cy="347472"/>
+            <a:off x="5632704" y="1499616"/>
+            <a:ext cx="1207008" cy="393192"/>
           </a:xfrm>
           <a:prstGeom prst="rect">
             <a:avLst/>
@@ -7821,8 +7475,8 @@
         </p:nvSpPr>
         <p:spPr>
           <a:xfrm>
-            <a:off x="6876288" y="1481328"/>
-            <a:ext cx="749808" cy="347472"/>
+            <a:off x="6876288" y="1499616"/>
+            <a:ext cx="749808" cy="393192"/>
           </a:xfrm>
           <a:prstGeom prst="rect">
             <a:avLst/>
@@ -7860,7 +7514,7 @@
         </p:nvSpPr>
         <p:spPr>
           <a:xfrm>
-            <a:off x="7735824" y="1527048"/>
+            <a:off x="7735824" y="1568196"/>
             <a:ext cx="859536" cy="256032"/>
           </a:xfrm>
           <a:prstGeom prst="roundRect">
@@ -7887,7 +7541,7 @@
         </p:nvSpPr>
         <p:spPr>
           <a:xfrm>
-            <a:off x="7735824" y="1527048"/>
+            <a:off x="7735824" y="1568196"/>
             <a:ext cx="859536" cy="256032"/>
           </a:xfrm>
           <a:prstGeom prst="rect">
@@ -7926,8 +7580,8 @@
         </p:nvSpPr>
         <p:spPr>
           <a:xfrm>
-            <a:off x="457200" y="1828800"/>
-            <a:ext cx="475488" cy="347472"/>
+            <a:off x="457200" y="1892808"/>
+            <a:ext cx="475488" cy="393192"/>
           </a:xfrm>
           <a:prstGeom prst="rect">
             <a:avLst/>
@@ -7965,8 +7619,8 @@
         </p:nvSpPr>
         <p:spPr>
           <a:xfrm>
-            <a:off x="987552" y="1828800"/>
-            <a:ext cx="2523744" cy="347472"/>
+            <a:off x="987552" y="1892808"/>
+            <a:ext cx="2523744" cy="393192"/>
           </a:xfrm>
           <a:prstGeom prst="rect">
             <a:avLst/>
@@ -8004,8 +7658,8 @@
         </p:nvSpPr>
         <p:spPr>
           <a:xfrm>
-            <a:off x="3566160" y="1828800"/>
-            <a:ext cx="2011680" cy="347472"/>
+            <a:off x="3566160" y="1892808"/>
+            <a:ext cx="2011680" cy="393192"/>
           </a:xfrm>
           <a:prstGeom prst="rect">
             <a:avLst/>
@@ -8043,8 +7697,8 @@
         </p:nvSpPr>
         <p:spPr>
           <a:xfrm>
-            <a:off x="5632704" y="1828800"/>
-            <a:ext cx="1207008" cy="347472"/>
+            <a:off x="5632704" y="1892808"/>
+            <a:ext cx="1207008" cy="393192"/>
           </a:xfrm>
           <a:prstGeom prst="rect">
             <a:avLst/>
@@ -8082,8 +7736,8 @@
         </p:nvSpPr>
         <p:spPr>
           <a:xfrm>
-            <a:off x="6876288" y="1828800"/>
-            <a:ext cx="749808" cy="347472"/>
+            <a:off x="6876288" y="1892808"/>
+            <a:ext cx="749808" cy="393192"/>
           </a:xfrm>
           <a:prstGeom prst="rect">
             <a:avLst/>
@@ -8121,7 +7775,7 @@
         </p:nvSpPr>
         <p:spPr>
           <a:xfrm>
-            <a:off x="7735824" y="1874520"/>
+            <a:off x="7735824" y="1961388"/>
             <a:ext cx="859536" cy="256032"/>
           </a:xfrm>
           <a:prstGeom prst="roundRect">
@@ -8148,7 +7802,7 @@
         </p:nvSpPr>
         <p:spPr>
           <a:xfrm>
-            <a:off x="7735824" y="1874520"/>
+            <a:off x="7735824" y="1961388"/>
             <a:ext cx="859536" cy="256032"/>
           </a:xfrm>
           <a:prstGeom prst="rect">
@@ -8187,8 +7841,8 @@
         </p:nvSpPr>
         <p:spPr>
           <a:xfrm>
-            <a:off x="457200" y="2176272"/>
-            <a:ext cx="8229600" cy="347472"/>
+            <a:off x="457200" y="2286000"/>
+            <a:ext cx="8229600" cy="393192"/>
           </a:xfrm>
           <a:prstGeom prst="rect">
             <a:avLst/>
@@ -8207,8 +7861,8 @@
         </p:nvSpPr>
         <p:spPr>
           <a:xfrm>
-            <a:off x="457200" y="2176272"/>
-            <a:ext cx="475488" cy="347472"/>
+            <a:off x="457200" y="2286000"/>
+            <a:ext cx="475488" cy="393192"/>
           </a:xfrm>
           <a:prstGeom prst="rect">
             <a:avLst/>
@@ -8246,8 +7900,8 @@
         </p:nvSpPr>
         <p:spPr>
           <a:xfrm>
-            <a:off x="987552" y="2176272"/>
-            <a:ext cx="2523744" cy="347472"/>
+            <a:off x="987552" y="2286000"/>
+            <a:ext cx="2523744" cy="393192"/>
           </a:xfrm>
           <a:prstGeom prst="rect">
             <a:avLst/>
@@ -8285,8 +7939,8 @@
         </p:nvSpPr>
         <p:spPr>
           <a:xfrm>
-            <a:off x="3566160" y="2176272"/>
-            <a:ext cx="2011680" cy="347472"/>
+            <a:off x="3566160" y="2286000"/>
+            <a:ext cx="2011680" cy="393192"/>
           </a:xfrm>
           <a:prstGeom prst="rect">
             <a:avLst/>
@@ -8324,8 +7978,8 @@
         </p:nvSpPr>
         <p:spPr>
           <a:xfrm>
-            <a:off x="5632704" y="2176272"/>
-            <a:ext cx="1207008" cy="347472"/>
+            <a:off x="5632704" y="2286000"/>
+            <a:ext cx="1207008" cy="393192"/>
           </a:xfrm>
           <a:prstGeom prst="rect">
             <a:avLst/>
@@ -8363,8 +8017,8 @@
         </p:nvSpPr>
         <p:spPr>
           <a:xfrm>
-            <a:off x="6876288" y="2176272"/>
-            <a:ext cx="749808" cy="347472"/>
+            <a:off x="6876288" y="2286000"/>
+            <a:ext cx="749808" cy="393192"/>
           </a:xfrm>
           <a:prstGeom prst="rect">
             <a:avLst/>
@@ -8402,7 +8056,7 @@
         </p:nvSpPr>
         <p:spPr>
           <a:xfrm>
-            <a:off x="7735824" y="2221992"/>
+            <a:off x="7735824" y="2354580"/>
             <a:ext cx="859536" cy="256032"/>
           </a:xfrm>
           <a:prstGeom prst="roundRect">
@@ -8429,7 +8083,7 @@
         </p:nvSpPr>
         <p:spPr>
           <a:xfrm>
-            <a:off x="7735824" y="2221992"/>
+            <a:off x="7735824" y="2354580"/>
             <a:ext cx="859536" cy="256032"/>
           </a:xfrm>
           <a:prstGeom prst="rect">
@@ -8468,8 +8122,8 @@
         </p:nvSpPr>
         <p:spPr>
           <a:xfrm>
-            <a:off x="457200" y="2523744"/>
-            <a:ext cx="475488" cy="347472"/>
+            <a:off x="457200" y="2679192"/>
+            <a:ext cx="475488" cy="393192"/>
           </a:xfrm>
           <a:prstGeom prst="rect">
             <a:avLst/>
@@ -8507,8 +8161,8 @@
         </p:nvSpPr>
         <p:spPr>
           <a:xfrm>
-            <a:off x="987552" y="2523744"/>
-            <a:ext cx="2523744" cy="347472"/>
+            <a:off x="987552" y="2679192"/>
+            <a:ext cx="2523744" cy="393192"/>
           </a:xfrm>
           <a:prstGeom prst="rect">
             <a:avLst/>
@@ -8546,8 +8200,8 @@
         </p:nvSpPr>
         <p:spPr>
           <a:xfrm>
-            <a:off x="3566160" y="2523744"/>
-            <a:ext cx="2011680" cy="347472"/>
+            <a:off x="3566160" y="2679192"/>
+            <a:ext cx="2011680" cy="393192"/>
           </a:xfrm>
           <a:prstGeom prst="rect">
             <a:avLst/>
@@ -8585,8 +8239,8 @@
         </p:nvSpPr>
         <p:spPr>
           <a:xfrm>
-            <a:off x="5632704" y="2523744"/>
-            <a:ext cx="1207008" cy="347472"/>
+            <a:off x="5632704" y="2679192"/>
+            <a:ext cx="1207008" cy="393192"/>
           </a:xfrm>
           <a:prstGeom prst="rect">
             <a:avLst/>
@@ -8624,8 +8278,8 @@
         </p:nvSpPr>
         <p:spPr>
           <a:xfrm>
-            <a:off x="6876288" y="2523744"/>
-            <a:ext cx="749808" cy="347472"/>
+            <a:off x="6876288" y="2679192"/>
+            <a:ext cx="749808" cy="393192"/>
           </a:xfrm>
           <a:prstGeom prst="rect">
             <a:avLst/>
@@ -8663,7 +8317,7 @@
         </p:nvSpPr>
         <p:spPr>
           <a:xfrm>
-            <a:off x="7735824" y="2569464"/>
+            <a:off x="7735824" y="2747772"/>
             <a:ext cx="859536" cy="256032"/>
           </a:xfrm>
           <a:prstGeom prst="roundRect">
@@ -8690,7 +8344,7 @@
         </p:nvSpPr>
         <p:spPr>
           <a:xfrm>
-            <a:off x="7735824" y="2569464"/>
+            <a:off x="7735824" y="2747772"/>
             <a:ext cx="859536" cy="256032"/>
           </a:xfrm>
           <a:prstGeom prst="rect">
@@ -8729,8 +8383,8 @@
         </p:nvSpPr>
         <p:spPr>
           <a:xfrm>
-            <a:off x="457200" y="2871216"/>
-            <a:ext cx="8229600" cy="347472"/>
+            <a:off x="457200" y="3072384"/>
+            <a:ext cx="8229600" cy="393192"/>
           </a:xfrm>
           <a:prstGeom prst="rect">
             <a:avLst/>
@@ -8749,8 +8403,8 @@
         </p:nvSpPr>
         <p:spPr>
           <a:xfrm>
-            <a:off x="457200" y="2871216"/>
-            <a:ext cx="475488" cy="347472"/>
+            <a:off x="457200" y="3072384"/>
+            <a:ext cx="475488" cy="393192"/>
           </a:xfrm>
           <a:prstGeom prst="rect">
             <a:avLst/>
@@ -8788,8 +8442,8 @@
         </p:nvSpPr>
         <p:spPr>
           <a:xfrm>
-            <a:off x="987552" y="2871216"/>
-            <a:ext cx="2523744" cy="347472"/>
+            <a:off x="987552" y="3072384"/>
+            <a:ext cx="2523744" cy="393192"/>
           </a:xfrm>
           <a:prstGeom prst="rect">
             <a:avLst/>
@@ -8827,8 +8481,8 @@
         </p:nvSpPr>
         <p:spPr>
           <a:xfrm>
-            <a:off x="3566160" y="2871216"/>
-            <a:ext cx="2011680" cy="347472"/>
+            <a:off x="3566160" y="3072384"/>
+            <a:ext cx="2011680" cy="393192"/>
           </a:xfrm>
           <a:prstGeom prst="rect">
             <a:avLst/>
@@ -8866,8 +8520,8 @@
         </p:nvSpPr>
         <p:spPr>
           <a:xfrm>
-            <a:off x="5632704" y="2871216"/>
-            <a:ext cx="1207008" cy="347472"/>
+            <a:off x="5632704" y="3072384"/>
+            <a:ext cx="1207008" cy="393192"/>
           </a:xfrm>
           <a:prstGeom prst="rect">
             <a:avLst/>
@@ -8905,8 +8559,8 @@
         </p:nvSpPr>
         <p:spPr>
           <a:xfrm>
-            <a:off x="6876288" y="2871216"/>
-            <a:ext cx="749808" cy="347472"/>
+            <a:off x="6876288" y="3072384"/>
+            <a:ext cx="749808" cy="393192"/>
           </a:xfrm>
           <a:prstGeom prst="rect">
             <a:avLst/>
@@ -8944,7 +8598,7 @@
         </p:nvSpPr>
         <p:spPr>
           <a:xfrm>
-            <a:off x="7735824" y="2916936"/>
+            <a:off x="7735824" y="3140964"/>
             <a:ext cx="859536" cy="256032"/>
           </a:xfrm>
           <a:prstGeom prst="roundRect">
@@ -8971,7 +8625,7 @@
         </p:nvSpPr>
         <p:spPr>
           <a:xfrm>
-            <a:off x="7735824" y="2916936"/>
+            <a:off x="7735824" y="3140964"/>
             <a:ext cx="859536" cy="256032"/>
           </a:xfrm>
           <a:prstGeom prst="rect">
@@ -9010,8 +8664,8 @@
         </p:nvSpPr>
         <p:spPr>
           <a:xfrm>
-            <a:off x="457200" y="3218688"/>
-            <a:ext cx="475488" cy="347472"/>
+            <a:off x="457200" y="3465576"/>
+            <a:ext cx="475488" cy="393192"/>
           </a:xfrm>
           <a:prstGeom prst="rect">
             <a:avLst/>
@@ -9049,8 +8703,8 @@
         </p:nvSpPr>
         <p:spPr>
           <a:xfrm>
-            <a:off x="987552" y="3218688"/>
-            <a:ext cx="2523744" cy="347472"/>
+            <a:off x="987552" y="3465576"/>
+            <a:ext cx="2523744" cy="393192"/>
           </a:xfrm>
           <a:prstGeom prst="rect">
             <a:avLst/>
@@ -9088,8 +8742,8 @@
         </p:nvSpPr>
         <p:spPr>
           <a:xfrm>
-            <a:off x="3566160" y="3218688"/>
-            <a:ext cx="2011680" cy="347472"/>
+            <a:off x="3566160" y="3465576"/>
+            <a:ext cx="2011680" cy="393192"/>
           </a:xfrm>
           <a:prstGeom prst="rect">
             <a:avLst/>
@@ -9127,8 +8781,8 @@
         </p:nvSpPr>
         <p:spPr>
           <a:xfrm>
-            <a:off x="5632704" y="3218688"/>
-            <a:ext cx="1207008" cy="347472"/>
+            <a:off x="5632704" y="3465576"/>
+            <a:ext cx="1207008" cy="393192"/>
           </a:xfrm>
           <a:prstGeom prst="rect">
             <a:avLst/>
@@ -9166,8 +8820,8 @@
         </p:nvSpPr>
         <p:spPr>
           <a:xfrm>
-            <a:off x="6876288" y="3218688"/>
-            <a:ext cx="749808" cy="347472"/>
+            <a:off x="6876288" y="3465576"/>
+            <a:ext cx="749808" cy="393192"/>
           </a:xfrm>
           <a:prstGeom prst="rect">
             <a:avLst/>
@@ -9205,7 +8859,7 @@
         </p:nvSpPr>
         <p:spPr>
           <a:xfrm>
-            <a:off x="7735824" y="3264408"/>
+            <a:off x="7735824" y="3534156"/>
             <a:ext cx="859536" cy="256032"/>
           </a:xfrm>
           <a:prstGeom prst="roundRect">
@@ -9232,7 +8886,7 @@
         </p:nvSpPr>
         <p:spPr>
           <a:xfrm>
-            <a:off x="7735824" y="3264408"/>
+            <a:off x="7735824" y="3534156"/>
             <a:ext cx="859536" cy="256032"/>
           </a:xfrm>
           <a:prstGeom prst="rect">
@@ -9271,8 +8925,8 @@
         </p:nvSpPr>
         <p:spPr>
           <a:xfrm>
-            <a:off x="457200" y="3566160"/>
-            <a:ext cx="8229600" cy="347472"/>
+            <a:off x="457200" y="3858768"/>
+            <a:ext cx="8229600" cy="393192"/>
           </a:xfrm>
           <a:prstGeom prst="rect">
             <a:avLst/>
@@ -9291,8 +8945,8 @@
         </p:nvSpPr>
         <p:spPr>
           <a:xfrm>
-            <a:off x="457200" y="3566160"/>
-            <a:ext cx="475488" cy="347472"/>
+            <a:off x="457200" y="3858768"/>
+            <a:ext cx="475488" cy="393192"/>
           </a:xfrm>
           <a:prstGeom prst="rect">
             <a:avLst/>
@@ -9330,8 +8984,8 @@
         </p:nvSpPr>
         <p:spPr>
           <a:xfrm>
-            <a:off x="987552" y="3566160"/>
-            <a:ext cx="2523744" cy="347472"/>
+            <a:off x="987552" y="3858768"/>
+            <a:ext cx="2523744" cy="393192"/>
           </a:xfrm>
           <a:prstGeom prst="rect">
             <a:avLst/>
@@ -9369,8 +9023,8 @@
         </p:nvSpPr>
         <p:spPr>
           <a:xfrm>
-            <a:off x="3566160" y="3566160"/>
-            <a:ext cx="2011680" cy="347472"/>
+            <a:off x="3566160" y="3858768"/>
+            <a:ext cx="2011680" cy="393192"/>
           </a:xfrm>
           <a:prstGeom prst="rect">
             <a:avLst/>
@@ -9408,8 +9062,8 @@
         </p:nvSpPr>
         <p:spPr>
           <a:xfrm>
-            <a:off x="5632704" y="3566160"/>
-            <a:ext cx="1207008" cy="347472"/>
+            <a:off x="5632704" y="3858768"/>
+            <a:ext cx="1207008" cy="393192"/>
           </a:xfrm>
           <a:prstGeom prst="rect">
             <a:avLst/>
@@ -9447,8 +9101,8 @@
         </p:nvSpPr>
         <p:spPr>
           <a:xfrm>
-            <a:off x="6876288" y="3566160"/>
-            <a:ext cx="749808" cy="347472"/>
+            <a:off x="6876288" y="3858768"/>
+            <a:ext cx="749808" cy="393192"/>
           </a:xfrm>
           <a:prstGeom prst="rect">
             <a:avLst/>
@@ -9486,7 +9140,7 @@
         </p:nvSpPr>
         <p:spPr>
           <a:xfrm>
-            <a:off x="7735824" y="3611880"/>
+            <a:off x="7735824" y="3927348"/>
             <a:ext cx="859536" cy="256032"/>
           </a:xfrm>
           <a:prstGeom prst="roundRect">
@@ -9513,7 +9167,7 @@
         </p:nvSpPr>
         <p:spPr>
           <a:xfrm>
-            <a:off x="7735824" y="3611880"/>
+            <a:off x="7735824" y="3927348"/>
             <a:ext cx="859536" cy="256032"/>
           </a:xfrm>
           <a:prstGeom prst="rect">
@@ -9552,12 +9206,12 @@
         </p:nvSpPr>
         <p:spPr>
           <a:xfrm>
-            <a:off x="457200" y="3968496"/>
-            <a:ext cx="8229600" cy="329184"/>
+            <a:off x="457200" y="4315968"/>
+            <a:ext cx="8229600" cy="365760"/>
           </a:xfrm>
           <a:prstGeom prst="roundRect">
             <a:avLst>
-              <a:gd name="adj" fmla="val 11111"/>
+              <a:gd name="adj" fmla="val 10000"/>
             </a:avLst>
           </a:prstGeom>
           <a:solidFill>
@@ -9579,8 +9233,8 @@
         </p:nvSpPr>
         <p:spPr>
           <a:xfrm>
-            <a:off x="658368" y="3968496"/>
-            <a:ext cx="7863840" cy="329184"/>
+            <a:off x="658368" y="4315968"/>
+            <a:ext cx="7863840" cy="365760"/>
           </a:xfrm>
           <a:prstGeom prst="rect">
             <a:avLst/>
@@ -9604,7 +9258,7 @@
                 <a:ea typeface="Calibri" pitchFamily="34" charset="-122"/>
                 <a:cs typeface="Calibri" pitchFamily="34" charset="-120"/>
               </a:rPr>
-              <a:t>진행 현황 공유  —  주간: 금요일 이메일   |   월간: 방문 면담 시 대면   |   수시: 시스템 실시간 조회</a:t>
+              <a:t>진행 현황 공유  —  주간: 매주 금요일 이메일 보고   |   월간: 월말 방문 면담 시 대면 보고   |   수시: 시스템 실시간 조회</a:t>
             </a:r>
             <a:endParaRPr lang="en-US" sz="900" dirty="0"/>
           </a:p>
@@ -9613,179 +9267,6 @@
       <p:sp>
         <p:nvSpPr>
           <p:cNvPr id="68" name="Shape 66"/>
-          <p:cNvSpPr/>
-          <p:nvPr/>
-        </p:nvSpPr>
-        <p:spPr>
-          <a:xfrm>
-            <a:off x="457200" y="4297680"/>
-            <a:ext cx="8229600" cy="329184"/>
-          </a:xfrm>
-          <a:prstGeom prst="roundRect">
-            <a:avLst>
-              <a:gd name="adj" fmla="val 13889"/>
-            </a:avLst>
-          </a:prstGeom>
-          <a:solidFill>
-            <a:srgbClr val="FAFBFC"/>
-          </a:solidFill>
-          <a:ln w="12700">
-            <a:solidFill>
-              <a:srgbClr val="0B4F6C"/>
-            </a:solidFill>
-            <a:prstDash val="solid"/>
-          </a:ln>
-        </p:spPr>
-      </p:sp>
-      <p:sp>
-        <p:nvSpPr>
-          <p:cNvPr id="69" name="Shape 67"/>
-          <p:cNvSpPr/>
-          <p:nvPr/>
-        </p:nvSpPr>
-        <p:spPr>
-          <a:xfrm>
-            <a:off x="457200" y="4297680"/>
-            <a:ext cx="45720" cy="329184"/>
-          </a:xfrm>
-          <a:prstGeom prst="rect">
-            <a:avLst/>
-          </a:prstGeom>
-          <a:solidFill>
-            <a:srgbClr val="0B4F6C"/>
-          </a:solidFill>
-          <a:ln/>
-        </p:spPr>
-      </p:sp>
-      <p:sp>
-        <p:nvSpPr>
-          <p:cNvPr id="70" name="Text 68"/>
-          <p:cNvSpPr/>
-          <p:nvPr/>
-        </p:nvSpPr>
-        <p:spPr>
-          <a:xfrm>
-            <a:off x="603504" y="4297680"/>
-            <a:ext cx="310896" cy="329184"/>
-          </a:xfrm>
-          <a:prstGeom prst="rect">
-            <a:avLst/>
-          </a:prstGeom>
-          <a:noFill/>
-          <a:ln/>
-        </p:spPr>
-        <p:txBody>
-          <a:bodyPr wrap="square" lIns="0" tIns="0" rIns="0" bIns="0" rtlCol="0" anchor="ctr"/>
-          <a:lstStyle/>
-          <a:p>
-            <a:pPr algn="ctr" indent="0" marL="0">
-              <a:buNone/>
-            </a:pPr>
-            <a:r>
-              <a:rPr lang="en-US" sz="1200" dirty="0">
-                <a:solidFill>
-                  <a:srgbClr val="000000"/>
-                </a:solidFill>
-                <a:latin typeface="Calibri" pitchFamily="34" charset="0"/>
-                <a:ea typeface="Calibri" pitchFamily="34" charset="-122"/>
-                <a:cs typeface="Calibri" pitchFamily="34" charset="-120"/>
-              </a:rPr>
-              <a:t>🔗</a:t>
-            </a:r>
-            <a:endParaRPr lang="en-US" sz="1200" dirty="0"/>
-          </a:p>
-        </p:txBody>
-      </p:sp>
-      <p:sp>
-        <p:nvSpPr>
-          <p:cNvPr id="71" name="Text 69"/>
-          <p:cNvSpPr/>
-          <p:nvPr/>
-        </p:nvSpPr>
-        <p:spPr>
-          <a:xfrm>
-            <a:off x="932688" y="4297680"/>
-            <a:ext cx="3200400" cy="329184"/>
-          </a:xfrm>
-          <a:prstGeom prst="rect">
-            <a:avLst/>
-          </a:prstGeom>
-          <a:noFill/>
-          <a:ln/>
-        </p:spPr>
-        <p:txBody>
-          <a:bodyPr wrap="square" lIns="0" tIns="0" rIns="0" bIns="0" rtlCol="0" anchor="ctr"/>
-          <a:lstStyle/>
-          <a:p>
-            <a:pPr indent="0" marL="0">
-              <a:buNone/>
-            </a:pPr>
-            <a:r>
-              <a:rPr lang="en-US" sz="1000" b="1" dirty="0">
-                <a:solidFill>
-                  <a:srgbClr val="0B4F6C"/>
-                </a:solidFill>
-                <a:latin typeface="Calibri" pitchFamily="34" charset="0"/>
-                <a:ea typeface="Calibri" pitchFamily="34" charset="-122"/>
-                <a:cs typeface="Calibri" pitchFamily="34" charset="-120"/>
-              </a:rPr>
-              <a:t>업무관리 시스템</a:t>
-            </a:r>
-            <a:endParaRPr lang="en-US" sz="1000" dirty="0"/>
-          </a:p>
-        </p:txBody>
-      </p:sp>
-      <p:sp>
-        <p:nvSpPr>
-          <p:cNvPr id="72" name="Text 70">
-            <a:hlinkClick r:id="rId1" tooltip=""/>
-          </p:cNvPr>
-          <p:cNvSpPr/>
-          <p:nvPr/>
-        </p:nvSpPr>
-        <p:spPr>
-          <a:xfrm>
-            <a:off x="4169664" y="4297680"/>
-            <a:ext cx="4389120" cy="329184"/>
-          </a:xfrm>
-          <a:prstGeom prst="rect">
-            <a:avLst/>
-          </a:prstGeom>
-          <a:noFill/>
-          <a:ln/>
-        </p:spPr>
-        <p:txBody>
-          <a:bodyPr wrap="square" lIns="0" tIns="0" rIns="0" bIns="0" rtlCol="0" anchor="ctr"/>
-          <a:lstStyle/>
-          <a:p>
-            <a:pPr indent="0" marL="0">
-              <a:buNone/>
-            </a:pPr>
-            <a:r>
-              <a:rPr lang="en-US" sz="950" u="sng" dirty="0">
-                <a:solidFill>
-                  <a:srgbClr val="5A6B7C"/>
-                </a:solidFill>
-                <a:latin typeface="Calibri" pitchFamily="34" charset="0"/>
-                <a:ea typeface="Calibri" pitchFamily="34" charset="-122"/>
-                <a:cs typeface="Calibri" pitchFamily="34" charset="-120"/>
-                <a:hlinkClick r:id="rId1" invalidUrl="" action="" tgtFrame="" tooltip="" history="1" highlightClick="0" endSnd="0">
-                  <a:extLst>
-                    <a:ext uri="{A12FA001-AC4F-418D-AE19-62706E023703}">
-                      <ahyp:hlinkClr xmlns:ahyp="http://schemas.microsoft.com/office/drawing/2018/hyperlinkcolor" val="tx"/>
-                    </a:ext>
-                  </a:extLst>
-                </a:hlinkClick>
-              </a:rPr>
-              <a:t>https://insys-hq.github.io/Insys-review/ims.html</a:t>
-            </a:r>
-            <a:endParaRPr lang="en-US" sz="950" dirty="0"/>
-          </a:p>
-        </p:txBody>
-      </p:sp>
-      <p:sp>
-        <p:nvSpPr>
-          <p:cNvPr id="73" name="Shape 71"/>
           <p:cNvSpPr/>
           <p:nvPr/>
         </p:nvSpPr>
@@ -9805,7 +9286,7 @@
       </p:sp>
       <p:sp>
         <p:nvSpPr>
-          <p:cNvPr id="74" name="Text 72"/>
+          <p:cNvPr id="69" name="Text 67"/>
           <p:cNvSpPr/>
           <p:nvPr/>
         </p:nvSpPr>
@@ -9844,7 +9325,7 @@
       </p:sp>
       <p:sp>
         <p:nvSpPr>
-          <p:cNvPr id="75" name="Text 73"/>
+          <p:cNvPr id="70" name="Text 68"/>
           <p:cNvSpPr/>
           <p:nvPr/>
         </p:nvSpPr>
@@ -10299,7 +9780,7 @@
                 <a:ea typeface="Calibri" pitchFamily="34" charset="-122"/>
                 <a:cs typeface="Calibri" pitchFamily="34" charset="-120"/>
               </a:rPr>
-              <a:t>㈜인시스   ·   2026. 08. 05</a:t>
+              <a:t>㈜인시스   ·   2026. 08. 07</a:t>
             </a:r>
             <a:endParaRPr lang="en-US" sz="1100" dirty="0"/>
           </a:p>
@@ -23183,12 +22664,12 @@
         </p:nvSpPr>
         <p:spPr>
           <a:xfrm>
-            <a:off x="457200" y="3529584"/>
-            <a:ext cx="8229600" cy="585216"/>
+            <a:off x="457200" y="3602736"/>
+            <a:ext cx="8229600" cy="640080"/>
           </a:xfrm>
           <a:prstGeom prst="roundRect">
             <a:avLst>
-              <a:gd name="adj" fmla="val 6250"/>
+              <a:gd name="adj" fmla="val 5714"/>
             </a:avLst>
           </a:prstGeom>
           <a:solidFill>
@@ -23210,7 +22691,7 @@
         </p:nvSpPr>
         <p:spPr>
           <a:xfrm>
-            <a:off x="658368" y="3630168"/>
+            <a:off x="658368" y="3721608"/>
             <a:ext cx="45720" cy="219456"/>
           </a:xfrm>
           <a:prstGeom prst="rect">
@@ -23230,7 +22711,7 @@
         </p:nvSpPr>
         <p:spPr>
           <a:xfrm>
-            <a:off x="786384" y="3602736"/>
+            <a:off x="786384" y="3694176"/>
             <a:ext cx="2615184" cy="274320"/>
           </a:xfrm>
           <a:prstGeom prst="rect">
@@ -23269,7 +22750,7 @@
         </p:nvSpPr>
         <p:spPr>
           <a:xfrm>
-            <a:off x="658368" y="3840480"/>
+            <a:off x="658368" y="3950208"/>
             <a:ext cx="7863840" cy="237744"/>
           </a:xfrm>
           <a:prstGeom prst="rect">
@@ -23303,179 +22784,6 @@
       <p:sp>
         <p:nvSpPr>
           <p:cNvPr id="43" name="Shape 41"/>
-          <p:cNvSpPr/>
-          <p:nvPr/>
-        </p:nvSpPr>
-        <p:spPr>
-          <a:xfrm>
-            <a:off x="457200" y="4133088"/>
-            <a:ext cx="8229600" cy="329184"/>
-          </a:xfrm>
-          <a:prstGeom prst="roundRect">
-            <a:avLst>
-              <a:gd name="adj" fmla="val 13889"/>
-            </a:avLst>
-          </a:prstGeom>
-          <a:solidFill>
-            <a:srgbClr val="FAFBFC"/>
-          </a:solidFill>
-          <a:ln w="12700">
-            <a:solidFill>
-              <a:srgbClr val="1C7293"/>
-            </a:solidFill>
-            <a:prstDash val="solid"/>
-          </a:ln>
-        </p:spPr>
-      </p:sp>
-      <p:sp>
-        <p:nvSpPr>
-          <p:cNvPr id="44" name="Shape 42"/>
-          <p:cNvSpPr/>
-          <p:nvPr/>
-        </p:nvSpPr>
-        <p:spPr>
-          <a:xfrm>
-            <a:off x="457200" y="4133088"/>
-            <a:ext cx="45720" cy="329184"/>
-          </a:xfrm>
-          <a:prstGeom prst="rect">
-            <a:avLst/>
-          </a:prstGeom>
-          <a:solidFill>
-            <a:srgbClr val="1C7293"/>
-          </a:solidFill>
-          <a:ln/>
-        </p:spPr>
-      </p:sp>
-      <p:sp>
-        <p:nvSpPr>
-          <p:cNvPr id="45" name="Text 43"/>
-          <p:cNvSpPr/>
-          <p:nvPr/>
-        </p:nvSpPr>
-        <p:spPr>
-          <a:xfrm>
-            <a:off x="603504" y="4133088"/>
-            <a:ext cx="310896" cy="329184"/>
-          </a:xfrm>
-          <a:prstGeom prst="rect">
-            <a:avLst/>
-          </a:prstGeom>
-          <a:noFill/>
-          <a:ln/>
-        </p:spPr>
-        <p:txBody>
-          <a:bodyPr wrap="square" lIns="0" tIns="0" rIns="0" bIns="0" rtlCol="0" anchor="ctr"/>
-          <a:lstStyle/>
-          <a:p>
-            <a:pPr algn="ctr" indent="0" marL="0">
-              <a:buNone/>
-            </a:pPr>
-            <a:r>
-              <a:rPr lang="en-US" sz="1200" dirty="0">
-                <a:solidFill>
-                  <a:srgbClr val="000000"/>
-                </a:solidFill>
-                <a:latin typeface="Calibri" pitchFamily="34" charset="0"/>
-                <a:ea typeface="Calibri" pitchFamily="34" charset="-122"/>
-                <a:cs typeface="Calibri" pitchFamily="34" charset="-120"/>
-              </a:rPr>
-              <a:t>🔗</a:t>
-            </a:r>
-            <a:endParaRPr lang="en-US" sz="1200" dirty="0"/>
-          </a:p>
-        </p:txBody>
-      </p:sp>
-      <p:sp>
-        <p:nvSpPr>
-          <p:cNvPr id="46" name="Text 44"/>
-          <p:cNvSpPr/>
-          <p:nvPr/>
-        </p:nvSpPr>
-        <p:spPr>
-          <a:xfrm>
-            <a:off x="932688" y="4133088"/>
-            <a:ext cx="3200400" cy="329184"/>
-          </a:xfrm>
-          <a:prstGeom prst="rect">
-            <a:avLst/>
-          </a:prstGeom>
-          <a:noFill/>
-          <a:ln/>
-        </p:spPr>
-        <p:txBody>
-          <a:bodyPr wrap="square" lIns="0" tIns="0" rIns="0" bIns="0" rtlCol="0" anchor="ctr"/>
-          <a:lstStyle/>
-          <a:p>
-            <a:pPr indent="0" marL="0">
-              <a:buNone/>
-            </a:pPr>
-            <a:r>
-              <a:rPr lang="en-US" sz="1000" b="1" dirty="0">
-                <a:solidFill>
-                  <a:srgbClr val="1C7293"/>
-                </a:solidFill>
-                <a:latin typeface="Calibri" pitchFamily="34" charset="0"/>
-                <a:ea typeface="Calibri" pitchFamily="34" charset="-122"/>
-                <a:cs typeface="Calibri" pitchFamily="34" charset="-120"/>
-              </a:rPr>
-              <a:t>업무관리 시스템 — 일일 업무보고</a:t>
-            </a:r>
-            <a:endParaRPr lang="en-US" sz="1000" dirty="0"/>
-          </a:p>
-        </p:txBody>
-      </p:sp>
-      <p:sp>
-        <p:nvSpPr>
-          <p:cNvPr id="47" name="Text 45">
-            <a:hlinkClick r:id="rId1" tooltip=""/>
-          </p:cNvPr>
-          <p:cNvSpPr/>
-          <p:nvPr/>
-        </p:nvSpPr>
-        <p:spPr>
-          <a:xfrm>
-            <a:off x="4169664" y="4133088"/>
-            <a:ext cx="4389120" cy="329184"/>
-          </a:xfrm>
-          <a:prstGeom prst="rect">
-            <a:avLst/>
-          </a:prstGeom>
-          <a:noFill/>
-          <a:ln/>
-        </p:spPr>
-        <p:txBody>
-          <a:bodyPr wrap="square" lIns="0" tIns="0" rIns="0" bIns="0" rtlCol="0" anchor="ctr"/>
-          <a:lstStyle/>
-          <a:p>
-            <a:pPr indent="0" marL="0">
-              <a:buNone/>
-            </a:pPr>
-            <a:r>
-              <a:rPr lang="en-US" sz="950" u="sng" dirty="0">
-                <a:solidFill>
-                  <a:srgbClr val="5A6B7C"/>
-                </a:solidFill>
-                <a:latin typeface="Calibri" pitchFamily="34" charset="0"/>
-                <a:ea typeface="Calibri" pitchFamily="34" charset="-122"/>
-                <a:cs typeface="Calibri" pitchFamily="34" charset="-120"/>
-                <a:hlinkClick r:id="rId1" invalidUrl="" action="" tgtFrame="" tooltip="" history="1" highlightClick="0" endSnd="0">
-                  <a:extLst>
-                    <a:ext uri="{A12FA001-AC4F-418D-AE19-62706E023703}">
-                      <ahyp:hlinkClr xmlns:ahyp="http://schemas.microsoft.com/office/drawing/2018/hyperlinkcolor" val="tx"/>
-                    </a:ext>
-                  </a:extLst>
-                </a:hlinkClick>
-              </a:rPr>
-              <a:t>https://insys-hq.github.io/Insys-review/ims.html</a:t>
-            </a:r>
-            <a:endParaRPr lang="en-US" sz="950" dirty="0"/>
-          </a:p>
-        </p:txBody>
-      </p:sp>
-      <p:sp>
-        <p:nvSpPr>
-          <p:cNvPr id="48" name="Shape 46"/>
           <p:cNvSpPr/>
           <p:nvPr/>
         </p:nvSpPr>
@@ -23495,7 +22803,7 @@
       </p:sp>
       <p:sp>
         <p:nvSpPr>
-          <p:cNvPr id="49" name="Text 47"/>
+          <p:cNvPr id="44" name="Text 42"/>
           <p:cNvSpPr/>
           <p:nvPr/>
         </p:nvSpPr>
@@ -23534,7 +22842,7 @@
       </p:sp>
       <p:sp>
         <p:nvSpPr>
-          <p:cNvPr id="50" name="Text 48"/>
+          <p:cNvPr id="45" name="Text 43"/>
           <p:cNvSpPr/>
           <p:nvPr/>
         </p:nvSpPr>

</xml_diff>

<commit_message>
action_plan.pptx v5.0 - contract 3.2.1 flowchart
</commit_message>
<xml_diff>
--- a/action_plan.pptx
+++ b/action_plan.pptx
@@ -2367,7 +2367,7 @@
                 <a:ea typeface="Calibri" pitchFamily="34" charset="-122"/>
                 <a:cs typeface="Calibri" pitchFamily="34" charset="-120"/>
               </a:rPr>
-              <a:t>2026. 08. 07   |   v4.6</a:t>
+              <a:t>2026. 08. 07   |   v5.0</a:t>
             </a:r>
             <a:endParaRPr lang="en-US" sz="1050" dirty="0"/>
           </a:p>
@@ -2969,7 +2969,7 @@
                 <a:ea typeface="Calibri" pitchFamily="34" charset="-122"/>
                 <a:cs typeface="Calibri" pitchFamily="34" charset="-120"/>
               </a:rPr>
-              <a:t>품목 선택 · 외관/치수/판정</a:t>
+              <a:t>계약 지침서 7단계 준수</a:t>
             </a:r>
             <a:endParaRPr lang="en-US" sz="830" dirty="0"/>
           </a:p>
@@ -4271,7 +4271,7 @@
                 <a:ea typeface="Calibri" pitchFamily="34" charset="-122"/>
                 <a:cs typeface="Calibri" pitchFamily="34" charset="-120"/>
               </a:rPr>
-              <a:t>㈜인시스  ·  셰플러 이천공장 수입검사 실행계획서 v4.6</a:t>
+              <a:t>㈜인시스  ·  셰플러 이천공장 수입검사 실행계획서 v5.0</a:t>
             </a:r>
             <a:endParaRPr lang="en-US" sz="800" dirty="0"/>
           </a:p>
@@ -5365,7 +5365,7 @@
                 <a:ea typeface="Calibri" pitchFamily="34" charset="-122"/>
                 <a:cs typeface="Calibri" pitchFamily="34" charset="-120"/>
               </a:rPr>
-              <a:t>㈜인시스  ·  셰플러 이천공장 수입검사 실행계획서 v4.6</a:t>
+              <a:t>㈜인시스  ·  셰플러 이천공장 수입검사 실행계획서 v5.0</a:t>
             </a:r>
             <a:endParaRPr lang="en-US" sz="800" dirty="0"/>
           </a:p>
@@ -6849,7 +6849,7 @@
                 <a:ea typeface="Calibri" pitchFamily="34" charset="-122"/>
                 <a:cs typeface="Calibri" pitchFamily="34" charset="-120"/>
               </a:rPr>
-              <a:t>㈜인시스  ·  셰플러 이천공장 수입검사 실행계획서 v4.6</a:t>
+              <a:t>㈜인시스  ·  셰플러 이천공장 수입검사 실행계획서 v5.0</a:t>
             </a:r>
             <a:endParaRPr lang="en-US" sz="800" dirty="0"/>
           </a:p>
@@ -9317,7 +9317,7 @@
                 <a:ea typeface="Calibri" pitchFamily="34" charset="-122"/>
                 <a:cs typeface="Calibri" pitchFamily="34" charset="-120"/>
               </a:rPr>
-              <a:t>㈜인시스  ·  셰플러 이천공장 수입검사 실행계획서 v4.6</a:t>
+              <a:t>㈜인시스  ·  셰플러 이천공장 수입검사 실행계획서 v5.0</a:t>
             </a:r>
             <a:endParaRPr lang="en-US" sz="800" dirty="0"/>
           </a:p>
@@ -10405,7 +10405,7 @@
                 <a:ea typeface="Calibri" pitchFamily="34" charset="-122"/>
                 <a:cs typeface="Calibri" pitchFamily="34" charset="-120"/>
               </a:rPr>
-              <a:t>수입검사 Flow Chart 7단계</a:t>
+              <a:t>계약 지침서 3.2.1 기준 7단계</a:t>
             </a:r>
             <a:endParaRPr lang="en-US" sz="930" dirty="0"/>
           </a:p>
@@ -10425,7 +10425,7 @@
                 <a:ea typeface="Calibri" pitchFamily="34" charset="-122"/>
                 <a:cs typeface="Calibri" pitchFamily="34" charset="-120"/>
               </a:rPr>
-              <a:t>기준서 확인 절차 문서화</a:t>
+              <a:t>Flow Chart · 절차 문서화</a:t>
             </a:r>
             <a:endParaRPr lang="en-US" sz="930" dirty="0"/>
           </a:p>
@@ -11661,7 +11661,7 @@
                 <a:ea typeface="Calibri" pitchFamily="34" charset="-122"/>
                 <a:cs typeface="Calibri" pitchFamily="34" charset="-120"/>
               </a:rPr>
-              <a:t>㈜인시스  ·  셰플러 이천공장 수입검사 실행계획서 v4.6</a:t>
+              <a:t>㈜인시스  ·  셰플러 이천공장 수입검사 실행계획서 v5.0</a:t>
             </a:r>
             <a:endParaRPr lang="en-US" sz="800" dirty="0"/>
           </a:p>
@@ -13383,7 +13383,7 @@
                 <a:ea typeface="Calibri" pitchFamily="34" charset="-122"/>
                 <a:cs typeface="Calibri" pitchFamily="34" charset="-120"/>
               </a:rPr>
-              <a:t>㈜인시스  ·  셰플러 이천공장 수입검사 실행계획서 v4.6</a:t>
+              <a:t>㈜인시스  ·  셰플러 이천공장 수입검사 실행계획서 v5.0</a:t>
             </a:r>
             <a:endParaRPr lang="en-US" sz="800" dirty="0"/>
           </a:p>
@@ -14550,7 +14550,7 @@
                 <a:ea typeface="Calibri" pitchFamily="34" charset="-122"/>
                 <a:cs typeface="Calibri" pitchFamily="34" charset="-120"/>
               </a:rPr>
-              <a:t>㈜인시스  ·  셰플러 이천공장 수입검사 실행계획서 v4.6</a:t>
+              <a:t>㈜인시스  ·  셰플러 이천공장 수입검사 실행계획서 v5.0</a:t>
             </a:r>
             <a:endParaRPr lang="en-US" sz="800" dirty="0"/>
           </a:p>
@@ -14816,7 +14816,7 @@
                 <a:ea typeface="Calibri" pitchFamily="34" charset="-122"/>
                 <a:cs typeface="Calibri" pitchFamily="34" charset="-120"/>
               </a:rPr>
-              <a:t>수입검사 표준 Flow Chart — 7단계</a:t>
+              <a:t>계약 지침서 3.2.1 기준 표준 Flow Chart — 7단계</a:t>
             </a:r>
             <a:endParaRPr lang="en-US" sz="1050" dirty="0"/>
           </a:p>
@@ -14921,8 +14921,8 @@
         </p:nvSpPr>
         <p:spPr>
           <a:xfrm>
-            <a:off x="484632" y="1700784"/>
-            <a:ext cx="932688" cy="274320"/>
+            <a:off x="475488" y="1700784"/>
+            <a:ext cx="950976" cy="274320"/>
           </a:xfrm>
           <a:prstGeom prst="rect">
             <a:avLst/>
@@ -14938,7 +14938,7 @@
               <a:buNone/>
             </a:pPr>
             <a:r>
-              <a:rPr lang="en-US" sz="1050" b="1" dirty="0">
+              <a:rPr lang="en-US" sz="1000" b="1" dirty="0">
                 <a:solidFill>
                   <a:srgbClr val="21295C"/>
                 </a:solidFill>
@@ -14946,9 +14946,9 @@
                 <a:ea typeface="Calibri" pitchFamily="34" charset="-122"/>
                 <a:cs typeface="Calibri" pitchFamily="34" charset="-120"/>
               </a:rPr>
-              <a:t>입고 접수</a:t>
-            </a:r>
-            <a:endParaRPr lang="en-US" sz="1050" dirty="0"/>
+              <a:t>샘플 채취</a:t>
+            </a:r>
+            <a:endParaRPr lang="en-US" sz="1000" dirty="0"/>
           </a:p>
         </p:txBody>
       </p:sp>
@@ -14988,7 +14988,7 @@
                 <a:ea typeface="Calibri" pitchFamily="34" charset="-122"/>
                 <a:cs typeface="Calibri" pitchFamily="34" charset="-120"/>
               </a:rPr>
-              <a:t>납품서·수량 확인</a:t>
+              <a:t>AQL 무작위</a:t>
             </a:r>
             <a:endParaRPr lang="en-US" sz="800" dirty="0"/>
           </a:p>
@@ -15113,8 +15113,8 @@
         </p:nvSpPr>
         <p:spPr>
           <a:xfrm>
-            <a:off x="1691640" y="1700784"/>
-            <a:ext cx="932688" cy="274320"/>
+            <a:off x="1682496" y="1700784"/>
+            <a:ext cx="950976" cy="274320"/>
           </a:xfrm>
           <a:prstGeom prst="rect">
             <a:avLst/>
@@ -15130,7 +15130,7 @@
               <a:buNone/>
             </a:pPr>
             <a:r>
-              <a:rPr lang="en-US" sz="1050" b="1" dirty="0">
+              <a:rPr lang="en-US" sz="1000" b="1" dirty="0">
                 <a:solidFill>
                   <a:srgbClr val="21295C"/>
                 </a:solidFill>
@@ -15138,9 +15138,9 @@
                 <a:ea typeface="Calibri" pitchFamily="34" charset="-122"/>
                 <a:cs typeface="Calibri" pitchFamily="34" charset="-120"/>
               </a:rPr>
-              <a:t>기준서 확인</a:t>
-            </a:r>
-            <a:endParaRPr lang="en-US" sz="1050" dirty="0"/>
+              <a:t>외관</a:t>
+            </a:r>
+            <a:endParaRPr lang="en-US" sz="1000" dirty="0"/>
           </a:p>
         </p:txBody>
       </p:sp>
@@ -15180,7 +15180,7 @@
                 <a:ea typeface="Calibri" pitchFamily="34" charset="-122"/>
                 <a:cs typeface="Calibri" pitchFamily="34" charset="-120"/>
               </a:rPr>
-              <a:t>주기 도래 시 실시</a:t>
+              <a:t>기준서 대비</a:t>
             </a:r>
             <a:endParaRPr lang="en-US" sz="800" dirty="0"/>
           </a:p>
@@ -15305,8 +15305,8 @@
         </p:nvSpPr>
         <p:spPr>
           <a:xfrm>
-            <a:off x="2898648" y="1700784"/>
-            <a:ext cx="932688" cy="274320"/>
+            <a:off x="2889504" y="1700784"/>
+            <a:ext cx="950976" cy="274320"/>
           </a:xfrm>
           <a:prstGeom prst="rect">
             <a:avLst/>
@@ -15322,7 +15322,7 @@
               <a:buNone/>
             </a:pPr>
             <a:r>
-              <a:rPr lang="en-US" sz="1050" b="1" dirty="0">
+              <a:rPr lang="en-US" sz="1000" b="1" dirty="0">
                 <a:solidFill>
                   <a:srgbClr val="21295C"/>
                 </a:solidFill>
@@ -15330,9 +15330,9 @@
                 <a:ea typeface="Calibri" pitchFamily="34" charset="-122"/>
                 <a:cs typeface="Calibri" pitchFamily="34" charset="-120"/>
               </a:rPr>
-              <a:t>품목 선택</a:t>
-            </a:r>
-            <a:endParaRPr lang="en-US" sz="1050" dirty="0"/>
+              <a:t>측정</a:t>
+            </a:r>
+            <a:endParaRPr lang="en-US" sz="1000" dirty="0"/>
           </a:p>
         </p:txBody>
       </p:sp>
@@ -15372,7 +15372,7 @@
                 <a:ea typeface="Calibri" pitchFamily="34" charset="-122"/>
                 <a:cs typeface="Calibri" pitchFamily="34" charset="-120"/>
               </a:rPr>
-              <a:t>등록 품목 드롭다운</a:t>
+              <a:t>치수 실측</a:t>
             </a:r>
             <a:endParaRPr lang="en-US" sz="800" dirty="0"/>
           </a:p>
@@ -15497,8 +15497,8 @@
         </p:nvSpPr>
         <p:spPr>
           <a:xfrm>
-            <a:off x="4105656" y="1700784"/>
-            <a:ext cx="932688" cy="274320"/>
+            <a:off x="4096512" y="1700784"/>
+            <a:ext cx="950976" cy="274320"/>
           </a:xfrm>
           <a:prstGeom prst="rect">
             <a:avLst/>
@@ -15514,7 +15514,7 @@
               <a:buNone/>
             </a:pPr>
             <a:r>
-              <a:rPr lang="en-US" sz="1050" b="1" dirty="0">
+              <a:rPr lang="en-US" sz="1000" b="1" dirty="0">
                 <a:solidFill>
                   <a:srgbClr val="21295C"/>
                 </a:solidFill>
@@ -15522,9 +15522,9 @@
                 <a:ea typeface="Calibri" pitchFamily="34" charset="-122"/>
                 <a:cs typeface="Calibri" pitchFamily="34" charset="-120"/>
               </a:rPr>
-              <a:t>샘플 추출</a:t>
-            </a:r>
-            <a:endParaRPr lang="en-US" sz="1050" dirty="0"/>
+              <a:t>SAP 결과입력</a:t>
+            </a:r>
+            <a:endParaRPr lang="en-US" sz="1000" dirty="0"/>
           </a:p>
         </p:txBody>
       </p:sp>
@@ -15564,7 +15564,7 @@
                 <a:ea typeface="Calibri" pitchFamily="34" charset="-122"/>
                 <a:cs typeface="Calibri" pitchFamily="34" charset="-120"/>
               </a:rPr>
-              <a:t>AQL 기준 무작위</a:t>
+              <a:t>결과 등록</a:t>
             </a:r>
             <a:endParaRPr lang="en-US" sz="800" dirty="0"/>
           </a:p>
@@ -15599,6 +15599,218 @@
         <p:spPr>
           <a:xfrm>
             <a:off x="5285232" y="1188720"/>
+            <a:ext cx="987552" cy="1335024"/>
+          </a:xfrm>
+          <a:prstGeom prst="roundRect">
+            <a:avLst>
+              <a:gd name="adj" fmla="val 3704"/>
+            </a:avLst>
+          </a:prstGeom>
+          <a:solidFill>
+            <a:srgbClr val="E8F5EE"/>
+          </a:solidFill>
+          <a:ln w="12700">
+            <a:solidFill>
+              <a:srgbClr val="1F6B4A"/>
+            </a:solidFill>
+            <a:prstDash val="solid"/>
+          </a:ln>
+        </p:spPr>
+      </p:sp>
+      <p:sp>
+        <p:nvSpPr>
+          <p:cNvPr id="34" name="Shape 32"/>
+          <p:cNvSpPr/>
+          <p:nvPr/>
+        </p:nvSpPr>
+        <p:spPr>
+          <a:xfrm>
+            <a:off x="5285232" y="1188720"/>
+            <a:ext cx="987552" cy="41148"/>
+          </a:xfrm>
+          <a:prstGeom prst="rect">
+            <a:avLst/>
+          </a:prstGeom>
+          <a:solidFill>
+            <a:srgbClr val="1F6B4A"/>
+          </a:solidFill>
+          <a:ln/>
+        </p:spPr>
+      </p:sp>
+      <p:sp>
+        <p:nvSpPr>
+          <p:cNvPr id="35" name="Shape 33"/>
+          <p:cNvSpPr/>
+          <p:nvPr/>
+        </p:nvSpPr>
+        <p:spPr>
+          <a:xfrm>
+            <a:off x="5632704" y="1335024"/>
+            <a:ext cx="292608" cy="292608"/>
+          </a:xfrm>
+          <a:prstGeom prst="ellipse">
+            <a:avLst/>
+          </a:prstGeom>
+          <a:solidFill>
+            <a:srgbClr val="1F6B4A"/>
+          </a:solidFill>
+          <a:ln w="12700">
+            <a:solidFill>
+              <a:srgbClr val="1F6B4A"/>
+            </a:solidFill>
+            <a:prstDash val="solid"/>
+          </a:ln>
+        </p:spPr>
+      </p:sp>
+      <p:sp>
+        <p:nvSpPr>
+          <p:cNvPr id="36" name="Text 34"/>
+          <p:cNvSpPr/>
+          <p:nvPr/>
+        </p:nvSpPr>
+        <p:spPr>
+          <a:xfrm>
+            <a:off x="5632704" y="1335024"/>
+            <a:ext cx="292608" cy="292608"/>
+          </a:xfrm>
+          <a:prstGeom prst="rect">
+            <a:avLst/>
+          </a:prstGeom>
+          <a:noFill/>
+          <a:ln/>
+        </p:spPr>
+        <p:txBody>
+          <a:bodyPr wrap="square" lIns="0" tIns="0" rIns="0" bIns="0" rtlCol="0" anchor="ctr"/>
+          <a:lstStyle/>
+          <a:p>
+            <a:pPr algn="ctr" indent="0" marL="0">
+              <a:buNone/>
+            </a:pPr>
+            <a:r>
+              <a:rPr lang="en-US" sz="1050" b="1" dirty="0">
+                <a:solidFill>
+                  <a:srgbClr val="FFFFFF"/>
+                </a:solidFill>
+                <a:latin typeface="Cambria" pitchFamily="34" charset="0"/>
+                <a:ea typeface="Cambria" pitchFamily="34" charset="-122"/>
+                <a:cs typeface="Cambria" pitchFamily="34" charset="-120"/>
+              </a:rPr>
+              <a:t>5</a:t>
+            </a:r>
+            <a:endParaRPr lang="en-US" sz="1050" dirty="0"/>
+          </a:p>
+        </p:txBody>
+      </p:sp>
+      <p:sp>
+        <p:nvSpPr>
+          <p:cNvPr id="37" name="Text 35"/>
+          <p:cNvSpPr/>
+          <p:nvPr/>
+        </p:nvSpPr>
+        <p:spPr>
+          <a:xfrm>
+            <a:off x="5303520" y="1700784"/>
+            <a:ext cx="950976" cy="274320"/>
+          </a:xfrm>
+          <a:prstGeom prst="rect">
+            <a:avLst/>
+          </a:prstGeom>
+          <a:noFill/>
+          <a:ln/>
+        </p:spPr>
+        <p:txBody>
+          <a:bodyPr wrap="square" lIns="0" tIns="0" rIns="0" bIns="0" rtlCol="0" anchor="ctr"/>
+          <a:lstStyle/>
+          <a:p>
+            <a:pPr algn="ctr" indent="0" marL="0">
+              <a:buNone/>
+            </a:pPr>
+            <a:r>
+              <a:rPr lang="en-US" sz="1000" b="1" dirty="0">
+                <a:solidFill>
+                  <a:srgbClr val="21295C"/>
+                </a:solidFill>
+                <a:latin typeface="Calibri" pitchFamily="34" charset="0"/>
+                <a:ea typeface="Calibri" pitchFamily="34" charset="-122"/>
+                <a:cs typeface="Calibri" pitchFamily="34" charset="-120"/>
+              </a:rPr>
+              <a:t>Q Block 해제</a:t>
+            </a:r>
+            <a:endParaRPr lang="en-US" sz="1000" dirty="0"/>
+          </a:p>
+        </p:txBody>
+      </p:sp>
+      <p:sp>
+        <p:nvSpPr>
+          <p:cNvPr id="38" name="Text 36"/>
+          <p:cNvSpPr/>
+          <p:nvPr/>
+        </p:nvSpPr>
+        <p:spPr>
+          <a:xfrm>
+            <a:off x="5312664" y="1993392"/>
+            <a:ext cx="932688" cy="384048"/>
+          </a:xfrm>
+          <a:prstGeom prst="rect">
+            <a:avLst/>
+          </a:prstGeom>
+          <a:noFill/>
+          <a:ln/>
+        </p:spPr>
+        <p:txBody>
+          <a:bodyPr wrap="square" lIns="0" tIns="0" rIns="0" bIns="0" rtlCol="0" anchor="ctr"/>
+          <a:lstStyle/>
+          <a:p>
+            <a:pPr algn="ctr" indent="0" marL="0">
+              <a:lnSpc>
+                <a:spcPts val="1100"/>
+              </a:lnSpc>
+              <a:buNone/>
+            </a:pPr>
+            <a:r>
+              <a:rPr lang="en-US" sz="800" dirty="0">
+                <a:solidFill>
+                  <a:srgbClr val="5A6B7C"/>
+                </a:solidFill>
+                <a:latin typeface="Calibri" pitchFamily="34" charset="0"/>
+                <a:ea typeface="Calibri" pitchFamily="34" charset="-122"/>
+                <a:cs typeface="Calibri" pitchFamily="34" charset="-120"/>
+              </a:rPr>
+              <a:t>사용 승인</a:t>
+            </a:r>
+            <a:endParaRPr lang="en-US" sz="800" dirty="0"/>
+          </a:p>
+        </p:txBody>
+      </p:sp>
+      <p:sp>
+        <p:nvSpPr>
+          <p:cNvPr id="39" name="Shape 37"/>
+          <p:cNvSpPr/>
+          <p:nvPr/>
+        </p:nvSpPr>
+        <p:spPr>
+          <a:xfrm>
+            <a:off x="6323076" y="1847088"/>
+            <a:ext cx="118872" cy="20117"/>
+          </a:xfrm>
+          <a:prstGeom prst="rect">
+            <a:avLst/>
+          </a:prstGeom>
+          <a:solidFill>
+            <a:srgbClr val="1C7293"/>
+          </a:solidFill>
+          <a:ln/>
+        </p:spPr>
+      </p:sp>
+      <p:sp>
+        <p:nvSpPr>
+          <p:cNvPr id="40" name="Shape 38"/>
+          <p:cNvSpPr/>
+          <p:nvPr/>
+        </p:nvSpPr>
+        <p:spPr>
+          <a:xfrm>
+            <a:off x="6492240" y="1188720"/>
             <a:ext cx="987552" cy="1335024"/>
           </a:xfrm>
           <a:prstGeom prst="roundRect">
@@ -15619,13 +15831,13 @@
       </p:sp>
       <p:sp>
         <p:nvSpPr>
-          <p:cNvPr id="34" name="Shape 32"/>
-          <p:cNvSpPr/>
-          <p:nvPr/>
-        </p:nvSpPr>
-        <p:spPr>
-          <a:xfrm>
-            <a:off x="5632704" y="1335024"/>
+          <p:cNvPr id="41" name="Shape 39"/>
+          <p:cNvSpPr/>
+          <p:nvPr/>
+        </p:nvSpPr>
+        <p:spPr>
+          <a:xfrm>
+            <a:off x="6839712" y="1335024"/>
             <a:ext cx="292608" cy="292608"/>
           </a:xfrm>
           <a:prstGeom prst="ellipse">
@@ -15644,13 +15856,13 @@
       </p:sp>
       <p:sp>
         <p:nvSpPr>
-          <p:cNvPr id="35" name="Text 33"/>
-          <p:cNvSpPr/>
-          <p:nvPr/>
-        </p:nvSpPr>
-        <p:spPr>
-          <a:xfrm>
-            <a:off x="5632704" y="1335024"/>
+          <p:cNvPr id="42" name="Text 40"/>
+          <p:cNvSpPr/>
+          <p:nvPr/>
+        </p:nvSpPr>
+        <p:spPr>
+          <a:xfrm>
+            <a:off x="6839712" y="1335024"/>
             <a:ext cx="292608" cy="292608"/>
           </a:xfrm>
           <a:prstGeom prst="rect">
@@ -15675,7 +15887,7 @@
                 <a:ea typeface="Cambria" pitchFamily="34" charset="-122"/>
                 <a:cs typeface="Cambria" pitchFamily="34" charset="-120"/>
               </a:rPr>
-              <a:t>5</a:t>
+              <a:t>6</a:t>
             </a:r>
             <a:endParaRPr lang="en-US" sz="1050" dirty="0"/>
           </a:p>
@@ -15683,14 +15895,14 @@
       </p:sp>
       <p:sp>
         <p:nvSpPr>
-          <p:cNvPr id="36" name="Text 34"/>
-          <p:cNvSpPr/>
-          <p:nvPr/>
-        </p:nvSpPr>
-        <p:spPr>
-          <a:xfrm>
-            <a:off x="5312664" y="1700784"/>
-            <a:ext cx="932688" cy="274320"/>
+          <p:cNvPr id="43" name="Text 41"/>
+          <p:cNvSpPr/>
+          <p:nvPr/>
+        </p:nvSpPr>
+        <p:spPr>
+          <a:xfrm>
+            <a:off x="6510528" y="1700784"/>
+            <a:ext cx="950976" cy="274320"/>
           </a:xfrm>
           <a:prstGeom prst="rect">
             <a:avLst/>
@@ -15706,7 +15918,7 @@
               <a:buNone/>
             </a:pPr>
             <a:r>
-              <a:rPr lang="en-US" sz="1050" b="1" dirty="0">
+              <a:rPr lang="en-US" sz="1000" b="1" dirty="0">
                 <a:solidFill>
                   <a:srgbClr val="21295C"/>
                 </a:solidFill>
@@ -15714,21 +15926,21 @@
                 <a:ea typeface="Calibri" pitchFamily="34" charset="-122"/>
                 <a:cs typeface="Calibri" pitchFamily="34" charset="-120"/>
               </a:rPr>
-              <a:t>외관 검사</a:t>
-            </a:r>
-            <a:endParaRPr lang="en-US" sz="1050" dirty="0"/>
-          </a:p>
-        </p:txBody>
-      </p:sp>
-      <p:sp>
-        <p:nvSpPr>
-          <p:cNvPr id="37" name="Text 35"/>
-          <p:cNvSpPr/>
-          <p:nvPr/>
-        </p:nvSpPr>
-        <p:spPr>
-          <a:xfrm>
-            <a:off x="5312664" y="1993392"/>
+              <a:t>라벨 부착</a:t>
+            </a:r>
+            <a:endParaRPr lang="en-US" sz="1000" dirty="0"/>
+          </a:p>
+        </p:txBody>
+      </p:sp>
+      <p:sp>
+        <p:nvSpPr>
+          <p:cNvPr id="44" name="Text 42"/>
+          <p:cNvSpPr/>
+          <p:nvPr/>
+        </p:nvSpPr>
+        <p:spPr>
+          <a:xfrm>
+            <a:off x="6519672" y="1993392"/>
             <a:ext cx="932688" cy="384048"/>
           </a:xfrm>
           <a:prstGeom prst="rect">
@@ -15756,7 +15968,7 @@
                 <a:ea typeface="Calibri" pitchFamily="34" charset="-122"/>
                 <a:cs typeface="Calibri" pitchFamily="34" charset="-120"/>
               </a:rPr>
-              <a:t>기준서 대비 확인</a:t>
+              <a:t>완료 표시</a:t>
             </a:r>
             <a:endParaRPr lang="en-US" sz="800" dirty="0"/>
           </a:p>
@@ -15764,199 +15976,7 @@
       </p:sp>
       <p:sp>
         <p:nvSpPr>
-          <p:cNvPr id="38" name="Shape 36"/>
-          <p:cNvSpPr/>
-          <p:nvPr/>
-        </p:nvSpPr>
-        <p:spPr>
-          <a:xfrm>
-            <a:off x="6323076" y="1847088"/>
-            <a:ext cx="118872" cy="20117"/>
-          </a:xfrm>
-          <a:prstGeom prst="rect">
-            <a:avLst/>
-          </a:prstGeom>
-          <a:solidFill>
-            <a:srgbClr val="1C7293"/>
-          </a:solidFill>
-          <a:ln/>
-        </p:spPr>
-      </p:sp>
-      <p:sp>
-        <p:nvSpPr>
-          <p:cNvPr id="39" name="Shape 37"/>
-          <p:cNvSpPr/>
-          <p:nvPr/>
-        </p:nvSpPr>
-        <p:spPr>
-          <a:xfrm>
-            <a:off x="6492240" y="1188720"/>
-            <a:ext cx="987552" cy="1335024"/>
-          </a:xfrm>
-          <a:prstGeom prst="roundRect">
-            <a:avLst>
-              <a:gd name="adj" fmla="val 3704"/>
-            </a:avLst>
-          </a:prstGeom>
-          <a:solidFill>
-            <a:srgbClr val="FAFBFC"/>
-          </a:solidFill>
-          <a:ln w="12700">
-            <a:solidFill>
-              <a:srgbClr val="C4D2DD"/>
-            </a:solidFill>
-            <a:prstDash val="solid"/>
-          </a:ln>
-        </p:spPr>
-      </p:sp>
-      <p:sp>
-        <p:nvSpPr>
-          <p:cNvPr id="40" name="Shape 38"/>
-          <p:cNvSpPr/>
-          <p:nvPr/>
-        </p:nvSpPr>
-        <p:spPr>
-          <a:xfrm>
-            <a:off x="6839712" y="1335024"/>
-            <a:ext cx="292608" cy="292608"/>
-          </a:xfrm>
-          <a:prstGeom prst="ellipse">
-            <a:avLst/>
-          </a:prstGeom>
-          <a:solidFill>
-            <a:srgbClr val="1C7293"/>
-          </a:solidFill>
-          <a:ln w="12700">
-            <a:solidFill>
-              <a:srgbClr val="1C7293"/>
-            </a:solidFill>
-            <a:prstDash val="solid"/>
-          </a:ln>
-        </p:spPr>
-      </p:sp>
-      <p:sp>
-        <p:nvSpPr>
-          <p:cNvPr id="41" name="Text 39"/>
-          <p:cNvSpPr/>
-          <p:nvPr/>
-        </p:nvSpPr>
-        <p:spPr>
-          <a:xfrm>
-            <a:off x="6839712" y="1335024"/>
-            <a:ext cx="292608" cy="292608"/>
-          </a:xfrm>
-          <a:prstGeom prst="rect">
-            <a:avLst/>
-          </a:prstGeom>
-          <a:noFill/>
-          <a:ln/>
-        </p:spPr>
-        <p:txBody>
-          <a:bodyPr wrap="square" lIns="0" tIns="0" rIns="0" bIns="0" rtlCol="0" anchor="ctr"/>
-          <a:lstStyle/>
-          <a:p>
-            <a:pPr algn="ctr" indent="0" marL="0">
-              <a:buNone/>
-            </a:pPr>
-            <a:r>
-              <a:rPr lang="en-US" sz="1050" b="1" dirty="0">
-                <a:solidFill>
-                  <a:srgbClr val="FFFFFF"/>
-                </a:solidFill>
-                <a:latin typeface="Cambria" pitchFamily="34" charset="0"/>
-                <a:ea typeface="Cambria" pitchFamily="34" charset="-122"/>
-                <a:cs typeface="Cambria" pitchFamily="34" charset="-120"/>
-              </a:rPr>
-              <a:t>6</a:t>
-            </a:r>
-            <a:endParaRPr lang="en-US" sz="1050" dirty="0"/>
-          </a:p>
-        </p:txBody>
-      </p:sp>
-      <p:sp>
-        <p:nvSpPr>
-          <p:cNvPr id="42" name="Text 40"/>
-          <p:cNvSpPr/>
-          <p:nvPr/>
-        </p:nvSpPr>
-        <p:spPr>
-          <a:xfrm>
-            <a:off x="6519672" y="1700784"/>
-            <a:ext cx="932688" cy="274320"/>
-          </a:xfrm>
-          <a:prstGeom prst="rect">
-            <a:avLst/>
-          </a:prstGeom>
-          <a:noFill/>
-          <a:ln/>
-        </p:spPr>
-        <p:txBody>
-          <a:bodyPr wrap="square" lIns="0" tIns="0" rIns="0" bIns="0" rtlCol="0" anchor="ctr"/>
-          <a:lstStyle/>
-          <a:p>
-            <a:pPr algn="ctr" indent="0" marL="0">
-              <a:buNone/>
-            </a:pPr>
-            <a:r>
-              <a:rPr lang="en-US" sz="1050" b="1" dirty="0">
-                <a:solidFill>
-                  <a:srgbClr val="21295C"/>
-                </a:solidFill>
-                <a:latin typeface="Calibri" pitchFamily="34" charset="0"/>
-                <a:ea typeface="Calibri" pitchFamily="34" charset="-122"/>
-                <a:cs typeface="Calibri" pitchFamily="34" charset="-120"/>
-              </a:rPr>
-              <a:t>치수 검사</a:t>
-            </a:r>
-            <a:endParaRPr lang="en-US" sz="1050" dirty="0"/>
-          </a:p>
-        </p:txBody>
-      </p:sp>
-      <p:sp>
-        <p:nvSpPr>
-          <p:cNvPr id="43" name="Text 41"/>
-          <p:cNvSpPr/>
-          <p:nvPr/>
-        </p:nvSpPr>
-        <p:spPr>
-          <a:xfrm>
-            <a:off x="6519672" y="1993392"/>
-            <a:ext cx="932688" cy="384048"/>
-          </a:xfrm>
-          <a:prstGeom prst="rect">
-            <a:avLst/>
-          </a:prstGeom>
-          <a:noFill/>
-          <a:ln/>
-        </p:spPr>
-        <p:txBody>
-          <a:bodyPr wrap="square" lIns="0" tIns="0" rIns="0" bIns="0" rtlCol="0" anchor="ctr"/>
-          <a:lstStyle/>
-          <a:p>
-            <a:pPr algn="ctr" indent="0" marL="0">
-              <a:lnSpc>
-                <a:spcPts val="1100"/>
-              </a:lnSpc>
-              <a:buNone/>
-            </a:pPr>
-            <a:r>
-              <a:rPr lang="en-US" sz="800" dirty="0">
-                <a:solidFill>
-                  <a:srgbClr val="5A6B7C"/>
-                </a:solidFill>
-                <a:latin typeface="Calibri" pitchFamily="34" charset="0"/>
-                <a:ea typeface="Calibri" pitchFamily="34" charset="-122"/>
-                <a:cs typeface="Calibri" pitchFamily="34" charset="-120"/>
-              </a:rPr>
-              <a:t>측정기 실측</a:t>
-            </a:r>
-            <a:endParaRPr lang="en-US" sz="800" dirty="0"/>
-          </a:p>
-        </p:txBody>
-      </p:sp>
-      <p:sp>
-        <p:nvSpPr>
-          <p:cNvPr id="44" name="Shape 42"/>
+          <p:cNvPr id="45" name="Shape 43"/>
           <p:cNvSpPr/>
           <p:nvPr/>
         </p:nvSpPr>
@@ -15976,7 +15996,7 @@
       </p:sp>
       <p:sp>
         <p:nvSpPr>
-          <p:cNvPr id="45" name="Shape 43"/>
+          <p:cNvPr id="46" name="Shape 44"/>
           <p:cNvSpPr/>
           <p:nvPr/>
         </p:nvSpPr>
@@ -16003,7 +16023,7 @@
       </p:sp>
       <p:sp>
         <p:nvSpPr>
-          <p:cNvPr id="46" name="Shape 44"/>
+          <p:cNvPr id="47" name="Shape 45"/>
           <p:cNvSpPr/>
           <p:nvPr/>
         </p:nvSpPr>
@@ -16023,7 +16043,7 @@
       </p:sp>
       <p:sp>
         <p:nvSpPr>
-          <p:cNvPr id="47" name="Shape 45"/>
+          <p:cNvPr id="48" name="Shape 46"/>
           <p:cNvSpPr/>
           <p:nvPr/>
         </p:nvSpPr>
@@ -16048,7 +16068,7 @@
       </p:sp>
       <p:sp>
         <p:nvSpPr>
-          <p:cNvPr id="48" name="Text 46"/>
+          <p:cNvPr id="49" name="Text 47"/>
           <p:cNvSpPr/>
           <p:nvPr/>
         </p:nvSpPr>
@@ -16087,14 +16107,14 @@
       </p:sp>
       <p:sp>
         <p:nvSpPr>
-          <p:cNvPr id="49" name="Text 47"/>
-          <p:cNvSpPr/>
-          <p:nvPr/>
-        </p:nvSpPr>
-        <p:spPr>
-          <a:xfrm>
-            <a:off x="7726680" y="1700784"/>
-            <a:ext cx="932688" cy="274320"/>
+          <p:cNvPr id="50" name="Text 48"/>
+          <p:cNvSpPr/>
+          <p:nvPr/>
+        </p:nvSpPr>
+        <p:spPr>
+          <a:xfrm>
+            <a:off x="7717536" y="1700784"/>
+            <a:ext cx="950976" cy="274320"/>
           </a:xfrm>
           <a:prstGeom prst="rect">
             <a:avLst/>
@@ -16110,7 +16130,7 @@
               <a:buNone/>
             </a:pPr>
             <a:r>
-              <a:rPr lang="en-US" sz="1050" b="1" dirty="0">
+              <a:rPr lang="en-US" sz="1000" b="1" dirty="0">
                 <a:solidFill>
                   <a:srgbClr val="21295C"/>
                 </a:solidFill>
@@ -16118,15 +16138,15 @@
                 <a:ea typeface="Calibri" pitchFamily="34" charset="-122"/>
                 <a:cs typeface="Calibri" pitchFamily="34" charset="-120"/>
               </a:rPr>
-              <a:t>최종 판정</a:t>
-            </a:r>
-            <a:endParaRPr lang="en-US" sz="1050" dirty="0"/>
-          </a:p>
-        </p:txBody>
-      </p:sp>
-      <p:sp>
-        <p:nvSpPr>
-          <p:cNvPr id="50" name="Text 48"/>
+              <a:t>샘플 반납</a:t>
+            </a:r>
+            <a:endParaRPr lang="en-US" sz="1000" dirty="0"/>
+          </a:p>
+        </p:txBody>
+      </p:sp>
+      <p:sp>
+        <p:nvSpPr>
+          <p:cNvPr id="51" name="Text 49"/>
           <p:cNvSpPr/>
           <p:nvPr/>
         </p:nvSpPr>
@@ -16160,7 +16180,7 @@
                 <a:ea typeface="Calibri" pitchFamily="34" charset="-122"/>
                 <a:cs typeface="Calibri" pitchFamily="34" charset="-120"/>
               </a:rPr>
-              <a:t>합격/불합격/보류</a:t>
+              <a:t>원위치 복귀</a:t>
             </a:r>
             <a:endParaRPr lang="en-US" sz="800" dirty="0"/>
           </a:p>
@@ -16168,13 +16188,269 @@
       </p:sp>
       <p:sp>
         <p:nvSpPr>
-          <p:cNvPr id="51" name="Shape 49"/>
+          <p:cNvPr id="52" name="Shape 50"/>
           <p:cNvSpPr/>
           <p:nvPr/>
         </p:nvSpPr>
         <p:spPr>
           <a:xfrm>
             <a:off x="457200" y="2798064"/>
+            <a:ext cx="2624328" cy="914400"/>
+          </a:xfrm>
+          <a:prstGeom prst="roundRect">
+            <a:avLst>
+              <a:gd name="adj" fmla="val 4000"/>
+            </a:avLst>
+          </a:prstGeom>
+          <a:solidFill>
+            <a:srgbClr val="FFFFFF"/>
+          </a:solidFill>
+          <a:ln w="12700">
+            <a:solidFill>
+              <a:srgbClr val="0B4F6C"/>
+            </a:solidFill>
+            <a:prstDash val="solid"/>
+          </a:ln>
+        </p:spPr>
+      </p:sp>
+      <p:sp>
+        <p:nvSpPr>
+          <p:cNvPr id="53" name="Shape 51"/>
+          <p:cNvSpPr/>
+          <p:nvPr/>
+        </p:nvSpPr>
+        <p:spPr>
+          <a:xfrm>
+            <a:off x="457200" y="2798064"/>
+            <a:ext cx="45720" cy="914400"/>
+          </a:xfrm>
+          <a:prstGeom prst="rect">
+            <a:avLst/>
+          </a:prstGeom>
+          <a:solidFill>
+            <a:srgbClr val="0B4F6C"/>
+          </a:solidFill>
+          <a:ln/>
+        </p:spPr>
+      </p:sp>
+      <p:sp>
+        <p:nvSpPr>
+          <p:cNvPr id="54" name="Text 52"/>
+          <p:cNvSpPr/>
+          <p:nvPr/>
+        </p:nvSpPr>
+        <p:spPr>
+          <a:xfrm>
+            <a:off x="640080" y="2907792"/>
+            <a:ext cx="2331720" cy="256032"/>
+          </a:xfrm>
+          <a:prstGeom prst="rect">
+            <a:avLst/>
+          </a:prstGeom>
+          <a:noFill/>
+          <a:ln/>
+        </p:spPr>
+        <p:txBody>
+          <a:bodyPr wrap="square" lIns="0" tIns="0" rIns="0" bIns="0" rtlCol="0" anchor="ctr"/>
+          <a:lstStyle/>
+          <a:p>
+            <a:pPr indent="0" marL="0">
+              <a:buNone/>
+            </a:pPr>
+            <a:r>
+              <a:rPr lang="en-US" sz="1100" b="1" dirty="0">
+                <a:solidFill>
+                  <a:srgbClr val="0B4F6C"/>
+                </a:solidFill>
+                <a:latin typeface="Calibri" pitchFamily="34" charset="0"/>
+                <a:ea typeface="Calibri" pitchFamily="34" charset="-122"/>
+                <a:cs typeface="Calibri" pitchFamily="34" charset="-120"/>
+              </a:rPr>
+              <a:t>사전 — 기준서 확인</a:t>
+            </a:r>
+            <a:endParaRPr lang="en-US" sz="1100" dirty="0"/>
+          </a:p>
+        </p:txBody>
+      </p:sp>
+      <p:sp>
+        <p:nvSpPr>
+          <p:cNvPr id="55" name="Text 53"/>
+          <p:cNvSpPr/>
+          <p:nvPr/>
+        </p:nvSpPr>
+        <p:spPr>
+          <a:xfrm>
+            <a:off x="640080" y="3200400"/>
+            <a:ext cx="2331720" cy="402336"/>
+          </a:xfrm>
+          <a:prstGeom prst="rect">
+            <a:avLst/>
+          </a:prstGeom>
+          <a:noFill/>
+          <a:ln/>
+        </p:spPr>
+        <p:txBody>
+          <a:bodyPr wrap="square" lIns="0" tIns="0" rIns="0" bIns="0" rtlCol="0" anchor="ctr"/>
+          <a:lstStyle/>
+          <a:p>
+            <a:pPr indent="0" marL="0">
+              <a:lnSpc>
+                <a:spcPts val="1200"/>
+              </a:lnSpc>
+              <a:buNone/>
+            </a:pPr>
+            <a:r>
+              <a:rPr lang="en-US" sz="900" dirty="0">
+                <a:solidFill>
+                  <a:srgbClr val="5A6B7C"/>
+                </a:solidFill>
+                <a:latin typeface="Calibri" pitchFamily="34" charset="0"/>
+                <a:ea typeface="Calibri" pitchFamily="34" charset="-122"/>
+                <a:cs typeface="Calibri" pitchFamily="34" charset="-120"/>
+              </a:rPr>
+              <a:t>설정 주기 도래 품목만 실시 · 이상 시 SQM 보고</a:t>
+            </a:r>
+            <a:endParaRPr lang="en-US" sz="900" dirty="0"/>
+          </a:p>
+        </p:txBody>
+      </p:sp>
+      <p:sp>
+        <p:nvSpPr>
+          <p:cNvPr id="56" name="Shape 54"/>
+          <p:cNvSpPr/>
+          <p:nvPr/>
+        </p:nvSpPr>
+        <p:spPr>
+          <a:xfrm>
+            <a:off x="3264408" y="2798064"/>
+            <a:ext cx="2624328" cy="914400"/>
+          </a:xfrm>
+          <a:prstGeom prst="roundRect">
+            <a:avLst>
+              <a:gd name="adj" fmla="val 4000"/>
+            </a:avLst>
+          </a:prstGeom>
+          <a:solidFill>
+            <a:srgbClr val="FFFFFF"/>
+          </a:solidFill>
+          <a:ln w="12700">
+            <a:solidFill>
+              <a:srgbClr val="1F6B4A"/>
+            </a:solidFill>
+            <a:prstDash val="solid"/>
+          </a:ln>
+        </p:spPr>
+      </p:sp>
+      <p:sp>
+        <p:nvSpPr>
+          <p:cNvPr id="57" name="Shape 55"/>
+          <p:cNvSpPr/>
+          <p:nvPr/>
+        </p:nvSpPr>
+        <p:spPr>
+          <a:xfrm>
+            <a:off x="3264408" y="2798064"/>
+            <a:ext cx="45720" cy="914400"/>
+          </a:xfrm>
+          <a:prstGeom prst="rect">
+            <a:avLst/>
+          </a:prstGeom>
+          <a:solidFill>
+            <a:srgbClr val="1F6B4A"/>
+          </a:solidFill>
+          <a:ln/>
+        </p:spPr>
+      </p:sp>
+      <p:sp>
+        <p:nvSpPr>
+          <p:cNvPr id="58" name="Text 56"/>
+          <p:cNvSpPr/>
+          <p:nvPr/>
+        </p:nvSpPr>
+        <p:spPr>
+          <a:xfrm>
+            <a:off x="3447288" y="2907792"/>
+            <a:ext cx="2331720" cy="256032"/>
+          </a:xfrm>
+          <a:prstGeom prst="rect">
+            <a:avLst/>
+          </a:prstGeom>
+          <a:noFill/>
+          <a:ln/>
+        </p:spPr>
+        <p:txBody>
+          <a:bodyPr wrap="square" lIns="0" tIns="0" rIns="0" bIns="0" rtlCol="0" anchor="ctr"/>
+          <a:lstStyle/>
+          <a:p>
+            <a:pPr indent="0" marL="0">
+              <a:buNone/>
+            </a:pPr>
+            <a:r>
+              <a:rPr lang="en-US" sz="1100" b="1" dirty="0">
+                <a:solidFill>
+                  <a:srgbClr val="1F6B4A"/>
+                </a:solidFill>
+                <a:latin typeface="Calibri" pitchFamily="34" charset="0"/>
+                <a:ea typeface="Calibri" pitchFamily="34" charset="-122"/>
+                <a:cs typeface="Calibri" pitchFamily="34" charset="-120"/>
+              </a:rPr>
+              <a:t>합격 — STEP 4~7</a:t>
+            </a:r>
+            <a:endParaRPr lang="en-US" sz="1100" dirty="0"/>
+          </a:p>
+        </p:txBody>
+      </p:sp>
+      <p:sp>
+        <p:nvSpPr>
+          <p:cNvPr id="59" name="Text 57"/>
+          <p:cNvSpPr/>
+          <p:nvPr/>
+        </p:nvSpPr>
+        <p:spPr>
+          <a:xfrm>
+            <a:off x="3447288" y="3200400"/>
+            <a:ext cx="2331720" cy="402336"/>
+          </a:xfrm>
+          <a:prstGeom prst="rect">
+            <a:avLst/>
+          </a:prstGeom>
+          <a:noFill/>
+          <a:ln/>
+        </p:spPr>
+        <p:txBody>
+          <a:bodyPr wrap="square" lIns="0" tIns="0" rIns="0" bIns="0" rtlCol="0" anchor="ctr"/>
+          <a:lstStyle/>
+          <a:p>
+            <a:pPr indent="0" marL="0">
+              <a:lnSpc>
+                <a:spcPts val="1200"/>
+              </a:lnSpc>
+              <a:buNone/>
+            </a:pPr>
+            <a:r>
+              <a:rPr lang="en-US" sz="900" dirty="0">
+                <a:solidFill>
+                  <a:srgbClr val="5A6B7C"/>
+                </a:solidFill>
+                <a:latin typeface="Calibri" pitchFamily="34" charset="0"/>
+                <a:ea typeface="Calibri" pitchFamily="34" charset="-122"/>
+                <a:cs typeface="Calibri" pitchFamily="34" charset="-120"/>
+              </a:rPr>
+              <a:t>SAP 입력 → Q Block 해제 → 라벨 부착 → 샘플 반납</a:t>
+            </a:r>
+            <a:endParaRPr lang="en-US" sz="900" dirty="0"/>
+          </a:p>
+        </p:txBody>
+      </p:sp>
+      <p:sp>
+        <p:nvSpPr>
+          <p:cNvPr id="60" name="Shape 58"/>
+          <p:cNvSpPr/>
+          <p:nvPr/>
+        </p:nvSpPr>
+        <p:spPr>
+          <a:xfrm>
+            <a:off x="6071616" y="2798064"/>
             <a:ext cx="2624328" cy="914400"/>
           </a:xfrm>
           <a:prstGeom prst="roundRect">
@@ -16195,13 +16471,13 @@
       </p:sp>
       <p:sp>
         <p:nvSpPr>
-          <p:cNvPr id="52" name="Shape 50"/>
-          <p:cNvSpPr/>
-          <p:nvPr/>
-        </p:nvSpPr>
-        <p:spPr>
-          <a:xfrm>
-            <a:off x="457200" y="2798064"/>
+          <p:cNvPr id="61" name="Shape 59"/>
+          <p:cNvSpPr/>
+          <p:nvPr/>
+        </p:nvSpPr>
+        <p:spPr>
+          <a:xfrm>
+            <a:off x="6071616" y="2798064"/>
             <a:ext cx="45720" cy="914400"/>
           </a:xfrm>
           <a:prstGeom prst="rect">
@@ -16215,13 +16491,13 @@
       </p:sp>
       <p:sp>
         <p:nvSpPr>
-          <p:cNvPr id="53" name="Text 51"/>
-          <p:cNvSpPr/>
-          <p:nvPr/>
-        </p:nvSpPr>
-        <p:spPr>
-          <a:xfrm>
-            <a:off x="640080" y="2907792"/>
+          <p:cNvPr id="62" name="Text 60"/>
+          <p:cNvSpPr/>
+          <p:nvPr/>
+        </p:nvSpPr>
+        <p:spPr>
+          <a:xfrm>
+            <a:off x="6254496" y="2907792"/>
             <a:ext cx="2331720" cy="256032"/>
           </a:xfrm>
           <a:prstGeom prst="rect">
@@ -16246,7 +16522,7 @@
                 <a:ea typeface="Calibri" pitchFamily="34" charset="-122"/>
                 <a:cs typeface="Calibri" pitchFamily="34" charset="-120"/>
               </a:rPr>
-              <a:t>성적서 없음 / 기준서 이상</a:t>
+              <a:t>불합격 / 보류</a:t>
             </a:r>
             <a:endParaRPr lang="en-US" sz="1100" dirty="0"/>
           </a:p>
@@ -16254,13 +16530,13 @@
       </p:sp>
       <p:sp>
         <p:nvSpPr>
-          <p:cNvPr id="54" name="Text 52"/>
-          <p:cNvSpPr/>
-          <p:nvPr/>
-        </p:nvSpPr>
-        <p:spPr>
-          <a:xfrm>
-            <a:off x="640080" y="3200400"/>
+          <p:cNvPr id="63" name="Text 61"/>
+          <p:cNvSpPr/>
+          <p:nvPr/>
+        </p:nvSpPr>
+        <p:spPr>
+          <a:xfrm>
+            <a:off x="6254496" y="3200400"/>
             <a:ext cx="2331720" cy="402336"/>
           </a:xfrm>
           <a:prstGeom prst="rect">
@@ -16288,7 +16564,7 @@
                 <a:ea typeface="Calibri" pitchFamily="34" charset="-122"/>
                 <a:cs typeface="Calibri" pitchFamily="34" charset="-120"/>
               </a:rPr>
-              <a:t>검사 중단 → 셰플러 SQM 서면 보고 → 지시 대기</a:t>
+              <a:t>SAP 입력 → Q Block 유지 → 격리 → SQM 통보</a:t>
             </a:r>
             <a:endParaRPr lang="en-US" sz="900" dirty="0"/>
           </a:p>
@@ -16296,263 +16572,7 @@
       </p:sp>
       <p:sp>
         <p:nvSpPr>
-          <p:cNvPr id="55" name="Shape 53"/>
-          <p:cNvSpPr/>
-          <p:nvPr/>
-        </p:nvSpPr>
-        <p:spPr>
-          <a:xfrm>
-            <a:off x="3264408" y="2798064"/>
-            <a:ext cx="2624328" cy="914400"/>
-          </a:xfrm>
-          <a:prstGeom prst="roundRect">
-            <a:avLst>
-              <a:gd name="adj" fmla="val 4000"/>
-            </a:avLst>
-          </a:prstGeom>
-          <a:solidFill>
-            <a:srgbClr val="FFFFFF"/>
-          </a:solidFill>
-          <a:ln w="12700">
-            <a:solidFill>
-              <a:srgbClr val="1F6B4A"/>
-            </a:solidFill>
-            <a:prstDash val="solid"/>
-          </a:ln>
-        </p:spPr>
-      </p:sp>
-      <p:sp>
-        <p:nvSpPr>
-          <p:cNvPr id="56" name="Shape 54"/>
-          <p:cNvSpPr/>
-          <p:nvPr/>
-        </p:nvSpPr>
-        <p:spPr>
-          <a:xfrm>
-            <a:off x="3264408" y="2798064"/>
-            <a:ext cx="45720" cy="914400"/>
-          </a:xfrm>
-          <a:prstGeom prst="rect">
-            <a:avLst/>
-          </a:prstGeom>
-          <a:solidFill>
-            <a:srgbClr val="1F6B4A"/>
-          </a:solidFill>
-          <a:ln/>
-        </p:spPr>
-      </p:sp>
-      <p:sp>
-        <p:nvSpPr>
-          <p:cNvPr id="57" name="Text 55"/>
-          <p:cNvSpPr/>
-          <p:nvPr/>
-        </p:nvSpPr>
-        <p:spPr>
-          <a:xfrm>
-            <a:off x="3447288" y="2907792"/>
-            <a:ext cx="2331720" cy="256032"/>
-          </a:xfrm>
-          <a:prstGeom prst="rect">
-            <a:avLst/>
-          </a:prstGeom>
-          <a:noFill/>
-          <a:ln/>
-        </p:spPr>
-        <p:txBody>
-          <a:bodyPr wrap="square" lIns="0" tIns="0" rIns="0" bIns="0" rtlCol="0" anchor="ctr"/>
-          <a:lstStyle/>
-          <a:p>
-            <a:pPr indent="0" marL="0">
-              <a:buNone/>
-            </a:pPr>
-            <a:r>
-              <a:rPr lang="en-US" sz="1100" b="1" dirty="0">
-                <a:solidFill>
-                  <a:srgbClr val="1F6B4A"/>
-                </a:solidFill>
-                <a:latin typeface="Calibri" pitchFamily="34" charset="0"/>
-                <a:ea typeface="Calibri" pitchFamily="34" charset="-122"/>
-                <a:cs typeface="Calibri" pitchFamily="34" charset="-120"/>
-              </a:rPr>
-              <a:t>합격</a:t>
-            </a:r>
-            <a:endParaRPr lang="en-US" sz="1100" dirty="0"/>
-          </a:p>
-        </p:txBody>
-      </p:sp>
-      <p:sp>
-        <p:nvSpPr>
-          <p:cNvPr id="58" name="Text 56"/>
-          <p:cNvSpPr/>
-          <p:nvPr/>
-        </p:nvSpPr>
-        <p:spPr>
-          <a:xfrm>
-            <a:off x="3447288" y="3200400"/>
-            <a:ext cx="2331720" cy="402336"/>
-          </a:xfrm>
-          <a:prstGeom prst="rect">
-            <a:avLst/>
-          </a:prstGeom>
-          <a:noFill/>
-          <a:ln/>
-        </p:spPr>
-        <p:txBody>
-          <a:bodyPr wrap="square" lIns="0" tIns="0" rIns="0" bIns="0" rtlCol="0" anchor="ctr"/>
-          <a:lstStyle/>
-          <a:p>
-            <a:pPr indent="0" marL="0">
-              <a:lnSpc>
-                <a:spcPts val="1200"/>
-              </a:lnSpc>
-              <a:buNone/>
-            </a:pPr>
-            <a:r>
-              <a:rPr lang="en-US" sz="900" dirty="0">
-                <a:solidFill>
-                  <a:srgbClr val="5A6B7C"/>
-                </a:solidFill>
-                <a:latin typeface="Calibri" pitchFamily="34" charset="0"/>
-                <a:ea typeface="Calibri" pitchFamily="34" charset="-122"/>
-                <a:cs typeface="Calibri" pitchFamily="34" charset="-120"/>
-              </a:rPr>
-              <a:t>입고 승인 → SAP 결과 입력 → 지정 위치 이송</a:t>
-            </a:r>
-            <a:endParaRPr lang="en-US" sz="900" dirty="0"/>
-          </a:p>
-        </p:txBody>
-      </p:sp>
-      <p:sp>
-        <p:nvSpPr>
-          <p:cNvPr id="59" name="Shape 57"/>
-          <p:cNvSpPr/>
-          <p:nvPr/>
-        </p:nvSpPr>
-        <p:spPr>
-          <a:xfrm>
-            <a:off x="6071616" y="2798064"/>
-            <a:ext cx="2624328" cy="914400"/>
-          </a:xfrm>
-          <a:prstGeom prst="roundRect">
-            <a:avLst>
-              <a:gd name="adj" fmla="val 4000"/>
-            </a:avLst>
-          </a:prstGeom>
-          <a:solidFill>
-            <a:srgbClr val="FFFFFF"/>
-          </a:solidFill>
-          <a:ln w="12700">
-            <a:solidFill>
-              <a:srgbClr val="1C7293"/>
-            </a:solidFill>
-            <a:prstDash val="solid"/>
-          </a:ln>
-        </p:spPr>
-      </p:sp>
-      <p:sp>
-        <p:nvSpPr>
-          <p:cNvPr id="60" name="Shape 58"/>
-          <p:cNvSpPr/>
-          <p:nvPr/>
-        </p:nvSpPr>
-        <p:spPr>
-          <a:xfrm>
-            <a:off x="6071616" y="2798064"/>
-            <a:ext cx="45720" cy="914400"/>
-          </a:xfrm>
-          <a:prstGeom prst="rect">
-            <a:avLst/>
-          </a:prstGeom>
-          <a:solidFill>
-            <a:srgbClr val="1C7293"/>
-          </a:solidFill>
-          <a:ln/>
-        </p:spPr>
-      </p:sp>
-      <p:sp>
-        <p:nvSpPr>
-          <p:cNvPr id="61" name="Text 59"/>
-          <p:cNvSpPr/>
-          <p:nvPr/>
-        </p:nvSpPr>
-        <p:spPr>
-          <a:xfrm>
-            <a:off x="6254496" y="2907792"/>
-            <a:ext cx="2331720" cy="256032"/>
-          </a:xfrm>
-          <a:prstGeom prst="rect">
-            <a:avLst/>
-          </a:prstGeom>
-          <a:noFill/>
-          <a:ln/>
-        </p:spPr>
-        <p:txBody>
-          <a:bodyPr wrap="square" lIns="0" tIns="0" rIns="0" bIns="0" rtlCol="0" anchor="ctr"/>
-          <a:lstStyle/>
-          <a:p>
-            <a:pPr indent="0" marL="0">
-              <a:buNone/>
-            </a:pPr>
-            <a:r>
-              <a:rPr lang="en-US" sz="1100" b="1" dirty="0">
-                <a:solidFill>
-                  <a:srgbClr val="1C7293"/>
-                </a:solidFill>
-                <a:latin typeface="Calibri" pitchFamily="34" charset="0"/>
-                <a:ea typeface="Calibri" pitchFamily="34" charset="-122"/>
-                <a:cs typeface="Calibri" pitchFamily="34" charset="-120"/>
-              </a:rPr>
-              <a:t>불합격 / 보류</a:t>
-            </a:r>
-            <a:endParaRPr lang="en-US" sz="1100" dirty="0"/>
-          </a:p>
-        </p:txBody>
-      </p:sp>
-      <p:sp>
-        <p:nvSpPr>
-          <p:cNvPr id="62" name="Text 60"/>
-          <p:cNvSpPr/>
-          <p:nvPr/>
-        </p:nvSpPr>
-        <p:spPr>
-          <a:xfrm>
-            <a:off x="6254496" y="3200400"/>
-            <a:ext cx="2331720" cy="402336"/>
-          </a:xfrm>
-          <a:prstGeom prst="rect">
-            <a:avLst/>
-          </a:prstGeom>
-          <a:noFill/>
-          <a:ln/>
-        </p:spPr>
-        <p:txBody>
-          <a:bodyPr wrap="square" lIns="0" tIns="0" rIns="0" bIns="0" rtlCol="0" anchor="ctr"/>
-          <a:lstStyle/>
-          <a:p>
-            <a:pPr indent="0" marL="0">
-              <a:lnSpc>
-                <a:spcPts val="1200"/>
-              </a:lnSpc>
-              <a:buNone/>
-            </a:pPr>
-            <a:r>
-              <a:rPr lang="en-US" sz="900" dirty="0">
-                <a:solidFill>
-                  <a:srgbClr val="5A6B7C"/>
-                </a:solidFill>
-                <a:latin typeface="Calibri" pitchFamily="34" charset="0"/>
-                <a:ea typeface="Calibri" pitchFamily="34" charset="-122"/>
-                <a:cs typeface="Calibri" pitchFamily="34" charset="-120"/>
-              </a:rPr>
-              <a:t>부적합품 격리 → SQM 통보 → 승인 후 처리</a:t>
-            </a:r>
-            <a:endParaRPr lang="en-US" sz="900" dirty="0"/>
-          </a:p>
-        </p:txBody>
-      </p:sp>
-      <p:sp>
-        <p:nvSpPr>
-          <p:cNvPr id="63" name="Shape 61"/>
+          <p:cNvPr id="64" name="Shape 62"/>
           <p:cNvSpPr/>
           <p:nvPr/>
         </p:nvSpPr>
@@ -16572,7 +16592,7 @@
       </p:sp>
       <p:sp>
         <p:nvSpPr>
-          <p:cNvPr id="64" name="Text 62"/>
+          <p:cNvPr id="65" name="Text 63"/>
           <p:cNvSpPr/>
           <p:nvPr/>
         </p:nvSpPr>
@@ -16603,7 +16623,7 @@
                 <a:ea typeface="Calibri" pitchFamily="34" charset="-122"/>
                 <a:cs typeface="Calibri" pitchFamily="34" charset="-120"/>
               </a:rPr>
-              <a:t>㈜인시스  ·  셰플러 이천공장 수입검사 실행계획서 v4.6</a:t>
+              <a:t>㈜인시스  ·  셰플러 이천공장 수입검사 실행계획서 v5.0</a:t>
             </a:r>
             <a:endParaRPr lang="en-US" sz="800" dirty="0"/>
           </a:p>
@@ -16611,7 +16631,7 @@
       </p:sp>
       <p:sp>
         <p:nvSpPr>
-          <p:cNvPr id="65" name="Text 63"/>
+          <p:cNvPr id="66" name="Text 64"/>
           <p:cNvSpPr/>
           <p:nvPr/>
         </p:nvSpPr>
@@ -18170,7 +18190,7 @@
                 <a:ea typeface="Calibri" pitchFamily="34" charset="-122"/>
                 <a:cs typeface="Calibri" pitchFamily="34" charset="-120"/>
               </a:rPr>
-              <a:t>㈜인시스  ·  셰플러 이천공장 수입검사 실행계획서 v4.6</a:t>
+              <a:t>㈜인시스  ·  셰플러 이천공장 수입검사 실행계획서 v5.0</a:t>
             </a:r>
             <a:endParaRPr lang="en-US" sz="800" dirty="0"/>
           </a:p>
@@ -19698,7 +19718,7 @@
                 <a:ea typeface="Calibri" pitchFamily="34" charset="-122"/>
                 <a:cs typeface="Calibri" pitchFamily="34" charset="-120"/>
               </a:rPr>
-              <a:t>㈜인시스  ·  셰플러 이천공장 수입검사 실행계획서 v4.6</a:t>
+              <a:t>㈜인시스  ·  셰플러 이천공장 수입검사 실행계획서 v5.0</a:t>
             </a:r>
             <a:endParaRPr lang="en-US" sz="800" dirty="0"/>
           </a:p>
@@ -20598,7 +20618,7 @@
                 <a:ea typeface="Calibri" pitchFamily="34" charset="-122"/>
                 <a:cs typeface="Calibri" pitchFamily="34" charset="-120"/>
               </a:rPr>
-              <a:t>SAP 입력 + 소요시간·특이사항 기록</a:t>
+              <a:t>SAP 입력 → Q Block 해제 → 라벨 → 반납</a:t>
             </a:r>
             <a:endParaRPr lang="en-US" sz="930" dirty="0"/>
           </a:p>
@@ -21405,7 +21425,7 @@
                 <a:ea typeface="Calibri" pitchFamily="34" charset="-122"/>
                 <a:cs typeface="Calibri" pitchFamily="34" charset="-120"/>
               </a:rPr>
-              <a:t>㈜인시스  ·  셰플러 이천공장 수입검사 실행계획서 v4.6</a:t>
+              <a:t>㈜인시스  ·  셰플러 이천공장 수입검사 실행계획서 v5.0</a:t>
             </a:r>
             <a:endParaRPr lang="en-US" sz="800" dirty="0"/>
           </a:p>
@@ -21855,7 +21875,7 @@
                 <a:ea typeface="Calibri" pitchFamily="34" charset="-122"/>
                 <a:cs typeface="Calibri" pitchFamily="34" charset="-120"/>
               </a:rPr>
-              <a:t>품목 · 외관 · 치수 · 판정</a:t>
+              <a:t>외관 · 측정 · 판정 · 후속조치</a:t>
             </a:r>
             <a:endParaRPr lang="en-US" sz="850" dirty="0"/>
           </a:p>
@@ -22834,7 +22854,7 @@
                 <a:ea typeface="Calibri" pitchFamily="34" charset="-122"/>
                 <a:cs typeface="Calibri" pitchFamily="34" charset="-120"/>
               </a:rPr>
-              <a:t>㈜인시스  ·  셰플러 이천공장 수입검사 실행계획서 v4.6</a:t>
+              <a:t>㈜인시스  ·  셰플러 이천공장 수입검사 실행계획서 v5.0</a:t>
             </a:r>
             <a:endParaRPr lang="en-US" sz="800" dirty="0"/>
           </a:p>

</xml_diff>